<commit_message>
deck: Chinese progress briefing (12 slides, same layout)
All copy translated; the layout code is shared with the English builder so the
two decks cannot drift. PingFang HK throughout. Also fixes a duplicated status
column on the measurement slide, in both languages.
</commit_message>
<xml_diff>
--- a/deck/progress_deck.pptx
+++ b/deck/progress_deck.pptx
@@ -3620,7 +3620,7 @@
         <p:spPr>
           <a:xfrm>
             <a:off x="868680" y="1691640"/>
-            <a:ext cx="3520440" cy="3703320"/>
+            <a:ext cx="3520440" cy="2926080"/>
           </a:xfrm>
           <a:prstGeom prst="rect">
             <a:avLst/>
@@ -3840,7 +3840,7 @@
         <p:spPr>
           <a:xfrm>
             <a:off x="4553712" y="1691640"/>
-            <a:ext cx="3520440" cy="3703320"/>
+            <a:ext cx="3520440" cy="2926080"/>
           </a:xfrm>
           <a:prstGeom prst="rect">
             <a:avLst/>
@@ -4022,7 +4022,7 @@
         <p:spPr>
           <a:xfrm>
             <a:off x="8238744" y="1691640"/>
-            <a:ext cx="3520440" cy="3703320"/>
+            <a:ext cx="3520440" cy="2926080"/>
           </a:xfrm>
           <a:prstGeom prst="rect">
             <a:avLst/>
@@ -4222,7 +4222,7 @@
         </p:nvSpPr>
         <p:spPr>
           <a:xfrm>
-            <a:off x="868680" y="5623560"/>
+            <a:off x="868680" y="4937760"/>
             <a:ext cx="10881360" cy="548640"/>
           </a:xfrm>
           <a:prstGeom prst="rect">
@@ -13154,15 +13154,6 @@
                         </a:spcBef>
                       </a:pPr>
                       <a:r>
-                        <a:rPr sz="1000" b="0" i="0">
-                          <a:solidFill>
-                            <a:srgbClr val="1E3652"/>
-                          </a:solidFill>
-                          <a:latin typeface="Helvetica Neue"/>
-                        </a:rPr>
-                        <a:t>built</a:t>
-                      </a:r>
-                      <a:r>
                         <a:rPr sz="1000" b="1" i="0">
                           <a:solidFill>
                             <a:srgbClr val="2F7D5D"/>
@@ -13284,15 +13275,6 @@
                           <a:spcPts val="0"/>
                         </a:spcBef>
                       </a:pPr>
-                      <a:r>
-                        <a:rPr sz="1000" b="0" i="0">
-                          <a:solidFill>
-                            <a:srgbClr val="1E3652"/>
-                          </a:solidFill>
-                          <a:latin typeface="Helvetica Neue"/>
-                        </a:rPr>
-                        <a:t>built</a:t>
-                      </a:r>
                       <a:r>
                         <a:rPr sz="1000" b="1" i="0">
                           <a:solidFill>
@@ -13416,15 +13398,6 @@
                         </a:spcBef>
                       </a:pPr>
                       <a:r>
-                        <a:rPr sz="1000" b="0" i="0">
-                          <a:solidFill>
-                            <a:srgbClr val="1E3652"/>
-                          </a:solidFill>
-                          <a:latin typeface="Helvetica Neue"/>
-                        </a:rPr>
-                        <a:t>built (global)</a:t>
-                      </a:r>
-                      <a:r>
                         <a:rPr sz="1000" b="1" i="0">
                           <a:solidFill>
                             <a:srgbClr val="B07A1E"/>
@@ -13546,15 +13519,6 @@
                           <a:spcPts val="0"/>
                         </a:spcBef>
                       </a:pPr>
-                      <a:r>
-                        <a:rPr sz="1000" b="0" i="0">
-                          <a:solidFill>
-                            <a:srgbClr val="1E3652"/>
-                          </a:solidFill>
-                          <a:latin typeface="Helvetica Neue"/>
-                        </a:rPr>
-                        <a:t>built (global)</a:t>
-                      </a:r>
                       <a:r>
                         <a:rPr sz="1000" b="1" i="0">
                           <a:solidFill>
@@ -13678,15 +13642,6 @@
                         </a:spcBef>
                       </a:pPr>
                       <a:r>
-                        <a:rPr sz="1000" b="0" i="0">
-                          <a:solidFill>
-                            <a:srgbClr val="1E3652"/>
-                          </a:solidFill>
-                          <a:latin typeface="Helvetica Neue"/>
-                        </a:rPr>
-                        <a:t>next</a:t>
-                      </a:r>
-                      <a:r>
                         <a:rPr sz="1000" b="1" i="0">
                           <a:solidFill>
                             <a:srgbClr val="A83542"/>
@@ -13808,15 +13763,6 @@
                           <a:spcPts val="0"/>
                         </a:spcBef>
                       </a:pPr>
-                      <a:r>
-                        <a:rPr sz="1000" b="0" i="0">
-                          <a:solidFill>
-                            <a:srgbClr val="1E3652"/>
-                          </a:solidFill>
-                          <a:latin typeface="Helvetica Neue"/>
-                        </a:rPr>
-                        <a:t>next</a:t>
-                      </a:r>
                       <a:r>
                         <a:rPr sz="1000" b="1" i="0">
                           <a:solidFill>

</xml_diff>

<commit_message>
deck: show the run, not just the result
New slide 10 in both languages: a terminal capture of the actual commands -
run.sh producing 8 sections, 24 captions and 11 figures, then a 9-slide deck;
detect.py reporting 32 violations with SRR 0.00; pytest at 76 passed. The
capture script reads the logs and fails if a line it draws is not in them, so
the image cannot show output that never happened.
</commit_message>
<xml_diff>
--- a/deck/progress_deck.pptx
+++ b/deck/progress_deck.pptx
@@ -17,6 +17,7 @@
     <p:sldId id="265" r:id="rId16"/>
     <p:sldId id="266" r:id="rId17"/>
     <p:sldId id="267" r:id="rId18"/>
+    <p:sldId id="268" r:id="rId19"/>
   </p:sldIdLst>
   <p:sldSz cx="12191695" cy="6858000" type="screen4x3"/>
   <p:notesSz cx="6858000" cy="9144000"/>
@@ -3492,7 +3493,7 @@
                 </a:solidFill>
                 <a:latin typeface="Helvetica Neue"/>
               </a:rPr>
-              <a:t>STATUS</a:t>
+              <a:t>THE RUN</a:t>
             </a:r>
           </a:p>
         </p:txBody>
@@ -3534,7 +3535,7 @@
                 </a:solidFill>
                 <a:latin typeface="Helvetica Neue"/>
               </a:rPr>
-              <a:t>What is built, what is next</a:t>
+              <a:t>It runs end to end, and it fails honestly</a:t>
             </a:r>
           </a:p>
         </p:txBody>
@@ -3611,76 +3612,40 @@
           </a:p>
         </p:txBody>
       </p:sp>
-      <p:sp>
-        <p:nvSpPr>
-          <p:cNvPr id="8" name="Rectangle 7"/>
-          <p:cNvSpPr/>
-          <p:nvPr/>
-        </p:nvSpPr>
-        <p:spPr>
-          <a:xfrm>
-            <a:off x="868680" y="1691640"/>
-            <a:ext cx="3520440" cy="2926080"/>
-          </a:xfrm>
-          <a:prstGeom prst="rect">
-            <a:avLst/>
-          </a:prstGeom>
-          <a:solidFill>
-            <a:srgbClr val="F4F6F8"/>
-          </a:solidFill>
-          <a:ln>
-            <a:noFill/>
-          </a:ln>
-          <a:effectLst/>
-        </p:spPr>
-        <p:txBody>
-          <a:bodyPr rtlCol="0" anchor="ctr" wrap="square"/>
-          <a:lstStyle/>
-          <a:p>
-            <a:pPr algn="ctr"/>
-          </a:p>
-        </p:txBody>
-      </p:sp>
-      <p:sp>
-        <p:nvSpPr>
-          <p:cNvPr id="9" name="Rectangle 8"/>
-          <p:cNvSpPr/>
-          <p:nvPr/>
-        </p:nvSpPr>
-        <p:spPr>
-          <a:xfrm>
-            <a:off x="868680" y="1691640"/>
-            <a:ext cx="3520440" cy="50292"/>
-          </a:xfrm>
-          <a:prstGeom prst="rect">
-            <a:avLst/>
-          </a:prstGeom>
-          <a:solidFill>
-            <a:srgbClr val="2F7D5D"/>
-          </a:solidFill>
-          <a:ln>
-            <a:noFill/>
-          </a:ln>
-          <a:effectLst/>
-        </p:spPr>
-        <p:txBody>
-          <a:bodyPr rtlCol="0" anchor="ctr" wrap="square"/>
-          <a:lstStyle/>
-          <a:p>
-            <a:pPr algn="ctr"/>
-          </a:p>
-        </p:txBody>
-      </p:sp>
-      <p:sp>
-        <p:nvSpPr>
-          <p:cNvPr id="10" name="TextBox 9"/>
+      <p:pic>
+        <p:nvPicPr>
+          <p:cNvPr id="8" name="Picture 7" descr="console_run.png"/>
+          <p:cNvPicPr>
+            <a:picLocks noChangeAspect="1"/>
+          </p:cNvPicPr>
+          <p:nvPr/>
+        </p:nvPicPr>
+        <p:blipFill>
+          <a:blip r:embed="rId2"/>
+          <a:stretch>
+            <a:fillRect/>
+          </a:stretch>
+        </p:blipFill>
+        <p:spPr>
+          <a:xfrm>
+            <a:off x="868680" y="1645920"/>
+            <a:ext cx="7589520" cy="4827813"/>
+          </a:xfrm>
+          <a:prstGeom prst="rect">
+            <a:avLst/>
+          </a:prstGeom>
+        </p:spPr>
+      </p:pic>
+      <p:sp>
+        <p:nvSpPr>
+          <p:cNvPr id="9" name="TextBox 8"/>
           <p:cNvSpPr txBox="1"/>
           <p:nvPr/>
         </p:nvSpPr>
         <p:spPr>
           <a:xfrm>
-            <a:off x="1097280" y="1874519"/>
-            <a:ext cx="3108960" cy="320040"/>
+            <a:off x="868680" y="6455664"/>
+            <a:ext cx="7589520" cy="274320"/>
           </a:xfrm>
           <a:prstGeom prst="rect">
             <a:avLst/>
@@ -3702,205 +3667,27 @@
               </a:spcBef>
             </a:pPr>
             <a:r>
-              <a:rPr sz="1250" b="1" i="0">
-                <a:solidFill>
-                  <a:srgbClr val="10233A"/>
+              <a:rPr sz="800" b="0" i="1">
+                <a:solidFill>
+                  <a:srgbClr val="5A6B7C"/>
                 </a:solidFill>
                 <a:latin typeface="Helvetica Neue"/>
               </a:rPr>
-              <a:t>Built and tested</a:t>
-            </a:r>
-          </a:p>
-        </p:txBody>
-      </p:sp>
-      <p:sp>
-        <p:nvSpPr>
-          <p:cNvPr id="11" name="TextBox 10"/>
+              <a:t>Real terminal output; rows in the middle are elided.</a:t>
+            </a:r>
+          </a:p>
+        </p:txBody>
+      </p:sp>
+      <p:sp>
+        <p:nvSpPr>
+          <p:cNvPr id="10" name="TextBox 9"/>
           <p:cNvSpPr txBox="1"/>
           <p:nvPr/>
         </p:nvSpPr>
         <p:spPr>
           <a:xfrm>
-            <a:off x="1097280" y="2331720"/>
-            <a:ext cx="3154680" cy="2834640"/>
-          </a:xfrm>
-          <a:prstGeom prst="rect">
-            <a:avLst/>
-          </a:prstGeom>
-          <a:noFill/>
-        </p:spPr>
-        <p:txBody>
-          <a:bodyPr wrap="square" anchor="t" lIns="0" rIns="0" tIns="0" bIns="0">
-            <a:spAutoFit/>
-          </a:bodyPr>
-          <a:lstStyle/>
-          <a:p>
-            <a:pPr algn="l">
-              <a:lnSpc>
-                <a:spcPct val="125000"/>
-              </a:lnSpc>
-              <a:spcBef>
-                <a:spcPts val="0"/>
-              </a:spcBef>
-            </a:pPr>
-            <a:r>
-              <a:rPr sz="950" b="0" i="0">
-                <a:solidFill>
-                  <a:srgbClr val="1E3652"/>
-                </a:solidFill>
-                <a:latin typeface="Helvetica Neue"/>
-              </a:rPr>
-              <a:t>-  parse: sections, figures, captions</a:t>
-            </a:r>
-          </a:p>
-          <a:p>
-            <a:pPr algn="l">
-              <a:lnSpc>
-                <a:spcPct val="125000"/>
-              </a:lnSpc>
-              <a:spcBef>
-                <a:spcPts val="700"/>
-              </a:spcBef>
-            </a:pPr>
-            <a:r>
-              <a:rPr sz="950" b="0" i="0">
-                <a:solidFill>
-                  <a:srgbClr val="1E3652"/>
-                </a:solidFill>
-                <a:latin typeface="Helvetica Neue"/>
-              </a:rPr>
-              <a:t>-  figure clipping, 12/32 on the sample</a:t>
-            </a:r>
-          </a:p>
-          <a:p>
-            <a:pPr algn="l">
-              <a:lnSpc>
-                <a:spcPct val="125000"/>
-              </a:lnSpc>
-              <a:spcBef>
-                <a:spcPts val="700"/>
-              </a:spcBef>
-            </a:pPr>
-            <a:r>
-              <a:rPr sz="950" b="0" i="0">
-                <a:solidFill>
-                  <a:srgbClr val="1E3652"/>
-                </a:solidFill>
-                <a:latin typeface="Helvetica Neue"/>
-              </a:rPr>
-              <a:t>-  render: native .pptx with speaker notes</a:t>
-            </a:r>
-          </a:p>
-          <a:p>
-            <a:pPr algn="l">
-              <a:lnSpc>
-                <a:spcPct val="125000"/>
-              </a:lnSpc>
-              <a:spcBef>
-                <a:spcPts val="700"/>
-              </a:spcBef>
-            </a:pPr>
-            <a:r>
-              <a:rPr sz="950" b="0" i="0">
-                <a:solidFill>
-                  <a:srgbClr val="1E3652"/>
-                </a:solidFill>
-                <a:latin typeface="Helvetica Neue"/>
-              </a:rPr>
-              <a:t>-  G1, G2, G3, G6 + SRR</a:t>
-            </a:r>
-          </a:p>
-          <a:p>
-            <a:pPr algn="l">
-              <a:lnSpc>
-                <a:spcPct val="125000"/>
-              </a:lnSpc>
-              <a:spcBef>
-                <a:spcPts val="700"/>
-              </a:spcBef>
-            </a:pPr>
-            <a:r>
-              <a:rPr sz="950" b="0" i="0">
-                <a:solidFill>
-                  <a:srgbClr val="1E3652"/>
-                </a:solidFill>
-                <a:latin typeface="Helvetica Neue"/>
-              </a:rPr>
-              <a:t>-  selection rule table, 55 test functions</a:t>
-            </a:r>
-          </a:p>
-        </p:txBody>
-      </p:sp>
-      <p:sp>
-        <p:nvSpPr>
-          <p:cNvPr id="12" name="Rectangle 11"/>
-          <p:cNvSpPr/>
-          <p:nvPr/>
-        </p:nvSpPr>
-        <p:spPr>
-          <a:xfrm>
-            <a:off x="4553712" y="1691640"/>
-            <a:ext cx="3520440" cy="2926080"/>
-          </a:xfrm>
-          <a:prstGeom prst="rect">
-            <a:avLst/>
-          </a:prstGeom>
-          <a:solidFill>
-            <a:srgbClr val="F4F6F8"/>
-          </a:solidFill>
-          <a:ln>
-            <a:noFill/>
-          </a:ln>
-          <a:effectLst/>
-        </p:spPr>
-        <p:txBody>
-          <a:bodyPr rtlCol="0" anchor="ctr" wrap="square"/>
-          <a:lstStyle/>
-          <a:p>
-            <a:pPr algn="ctr"/>
-          </a:p>
-        </p:txBody>
-      </p:sp>
-      <p:sp>
-        <p:nvSpPr>
-          <p:cNvPr id="13" name="Rectangle 12"/>
-          <p:cNvSpPr/>
-          <p:nvPr/>
-        </p:nvSpPr>
-        <p:spPr>
-          <a:xfrm>
-            <a:off x="4553712" y="1691640"/>
-            <a:ext cx="3520440" cy="50292"/>
-          </a:xfrm>
-          <a:prstGeom prst="rect">
-            <a:avLst/>
-          </a:prstGeom>
-          <a:solidFill>
-            <a:srgbClr val="B07A1E"/>
-          </a:solidFill>
-          <a:ln>
-            <a:noFill/>
-          </a:ln>
-          <a:effectLst/>
-        </p:spPr>
-        <p:txBody>
-          <a:bodyPr rtlCol="0" anchor="ctr" wrap="square"/>
-          <a:lstStyle/>
-          <a:p>
-            <a:pPr algn="ctr"/>
-          </a:p>
-        </p:txBody>
-      </p:sp>
-      <p:sp>
-        <p:nvSpPr>
-          <p:cNvPr id="14" name="TextBox 13"/>
-          <p:cNvSpPr txBox="1"/>
-          <p:nvPr/>
-        </p:nvSpPr>
-        <p:spPr>
-          <a:xfrm>
-            <a:off x="4782312" y="1874519"/>
-            <a:ext cx="3108960" cy="320040"/>
+            <a:off x="8823960" y="1737360"/>
+            <a:ext cx="2926080" cy="685800"/>
           </a:xfrm>
           <a:prstGeom prst="rect">
             <a:avLst/>
@@ -3922,167 +3709,46 @@
               </a:spcBef>
             </a:pPr>
             <a:r>
-              <a:rPr sz="1250" b="1" i="0">
-                <a:solidFill>
-                  <a:srgbClr val="10233A"/>
+              <a:rPr sz="1000" b="1" i="0">
+                <a:solidFill>
+                  <a:srgbClr val="C08A2E"/>
                 </a:solidFill>
                 <a:latin typeface="Helvetica Neue"/>
               </a:rPr>
-              <a:t>Partially built</a:t>
-            </a:r>
-          </a:p>
-        </p:txBody>
-      </p:sp>
-      <p:sp>
-        <p:nvSpPr>
-          <p:cNvPr id="15" name="TextBox 14"/>
-          <p:cNvSpPr txBox="1"/>
-          <p:nvPr/>
-        </p:nvSpPr>
-        <p:spPr>
-          <a:xfrm>
-            <a:off x="4782312" y="2331720"/>
-            <a:ext cx="3154680" cy="2834640"/>
-          </a:xfrm>
-          <a:prstGeom prst="rect">
-            <a:avLst/>
-          </a:prstGeom>
-          <a:noFill/>
-        </p:spPr>
-        <p:txBody>
-          <a:bodyPr wrap="square" anchor="t" lIns="0" rIns="0" tIns="0" bIns="0">
-            <a:spAutoFit/>
-          </a:bodyPr>
-          <a:lstStyle/>
+              <a:t>parse</a:t>
+            </a:r>
+          </a:p>
           <a:p>
             <a:pPr algn="l">
               <a:lnSpc>
                 <a:spcPct val="125000"/>
               </a:lnSpc>
               <a:spcBef>
-                <a:spcPts val="0"/>
+                <a:spcPts val="100"/>
               </a:spcBef>
             </a:pPr>
             <a:r>
-              <a:rPr sz="950" b="0" i="0">
+              <a:rPr sz="900" b="0" i="0">
                 <a:solidFill>
                   <a:srgbClr val="1E3652"/>
                 </a:solidFill>
                 <a:latin typeface="Helvetica Neue"/>
               </a:rPr>
-              <a:t>-  G3 / G6 still use one global threshold</a:t>
-            </a:r>
-          </a:p>
-          <a:p>
-            <a:pPr algn="l">
-              <a:lnSpc>
-                <a:spcPct val="125000"/>
-              </a:lnSpc>
-              <a:spcBef>
-                <a:spcPts val="700"/>
-              </a:spcBef>
-            </a:pPr>
-            <a:r>
-              <a:rPr sz="950" b="0" i="0">
-                <a:solidFill>
-                  <a:srgbClr val="1E3652"/>
-                </a:solidFill>
-                <a:latin typeface="Helvetica Neue"/>
-              </a:rPr>
-              <a:t>-  figure captions need a word-boundary trim</a:t>
-            </a:r>
-          </a:p>
-          <a:p>
-            <a:pPr algn="l">
-              <a:lnSpc>
-                <a:spcPct val="125000"/>
-              </a:lnSpc>
-              <a:spcBef>
-                <a:spcPts val="700"/>
-              </a:spcBef>
-            </a:pPr>
-            <a:r>
-              <a:rPr sz="950" b="0" i="0">
-                <a:solidFill>
-                  <a:srgbClr val="1E3652"/>
-                </a:solidFill>
-                <a:latin typeface="Helvetica Neue"/>
-              </a:rPr>
-              <a:t>-  claims are still extracted by heuristic</a:t>
-            </a:r>
-          </a:p>
-        </p:txBody>
-      </p:sp>
-      <p:sp>
-        <p:nvSpPr>
-          <p:cNvPr id="16" name="Rectangle 15"/>
-          <p:cNvSpPr/>
-          <p:nvPr/>
-        </p:nvSpPr>
-        <p:spPr>
-          <a:xfrm>
-            <a:off x="8238744" y="1691640"/>
-            <a:ext cx="3520440" cy="2926080"/>
-          </a:xfrm>
-          <a:prstGeom prst="rect">
-            <a:avLst/>
-          </a:prstGeom>
-          <a:solidFill>
-            <a:srgbClr val="F4F6F8"/>
-          </a:solidFill>
-          <a:ln>
-            <a:noFill/>
-          </a:ln>
-          <a:effectLst/>
-        </p:spPr>
-        <p:txBody>
-          <a:bodyPr rtlCol="0" anchor="ctr" wrap="square"/>
-          <a:lstStyle/>
-          <a:p>
-            <a:pPr algn="ctr"/>
-          </a:p>
-        </p:txBody>
-      </p:sp>
-      <p:sp>
-        <p:nvSpPr>
-          <p:cNvPr id="17" name="Rectangle 16"/>
-          <p:cNvSpPr/>
-          <p:nvPr/>
-        </p:nvSpPr>
-        <p:spPr>
-          <a:xfrm>
-            <a:off x="8238744" y="1691640"/>
-            <a:ext cx="3520440" cy="50292"/>
-          </a:xfrm>
-          <a:prstGeom prst="rect">
-            <a:avLst/>
-          </a:prstGeom>
-          <a:solidFill>
-            <a:srgbClr val="5A6B7C"/>
-          </a:solidFill>
-          <a:ln>
-            <a:noFill/>
-          </a:ln>
-          <a:effectLst/>
-        </p:spPr>
-        <p:txBody>
-          <a:bodyPr rtlCol="0" anchor="ctr" wrap="square"/>
-          <a:lstStyle/>
-          <a:p>
-            <a:pPr algn="ctr"/>
-          </a:p>
-        </p:txBody>
-      </p:sp>
-      <p:sp>
-        <p:nvSpPr>
-          <p:cNvPr id="18" name="TextBox 17"/>
+              <a:t>8 sections, 24 captions, 11 figures clipped</a:t>
+            </a:r>
+          </a:p>
+        </p:txBody>
+      </p:sp>
+      <p:sp>
+        <p:nvSpPr>
+          <p:cNvPr id="11" name="TextBox 10"/>
           <p:cNvSpPr txBox="1"/>
           <p:nvPr/>
         </p:nvSpPr>
         <p:spPr>
           <a:xfrm>
-            <a:off x="8467344" y="1874519"/>
-            <a:ext cx="3108960" cy="320040"/>
+            <a:off x="8823960" y="2578608"/>
+            <a:ext cx="2926080" cy="685800"/>
           </a:xfrm>
           <a:prstGeom prst="rect">
             <a:avLst/>
@@ -4104,126 +3770,46 @@
               </a:spcBef>
             </a:pPr>
             <a:r>
-              <a:rPr sz="1250" b="1" i="0">
-                <a:solidFill>
-                  <a:srgbClr val="10233A"/>
+              <a:rPr sz="1000" b="1" i="0">
+                <a:solidFill>
+                  <a:srgbClr val="C08A2E"/>
                 </a:solidFill>
                 <a:latin typeface="Helvetica Neue"/>
               </a:rPr>
-              <a:t>Not started</a:t>
-            </a:r>
-          </a:p>
-        </p:txBody>
-      </p:sp>
-      <p:sp>
-        <p:nvSpPr>
-          <p:cNvPr id="19" name="TextBox 18"/>
-          <p:cNvSpPr txBox="1"/>
-          <p:nvPr/>
-        </p:nvSpPr>
-        <p:spPr>
-          <a:xfrm>
-            <a:off x="8467344" y="2331720"/>
-            <a:ext cx="3154680" cy="2834640"/>
-          </a:xfrm>
-          <a:prstGeom prst="rect">
-            <a:avLst/>
-          </a:prstGeom>
-          <a:noFill/>
-        </p:spPr>
-        <p:txBody>
-          <a:bodyPr wrap="square" anchor="t" lIns="0" rIns="0" tIns="0" bIns="0">
-            <a:spAutoFit/>
-          </a:bodyPr>
-          <a:lstStyle/>
+              <a:t>compose</a:t>
+            </a:r>
+          </a:p>
           <a:p>
             <a:pPr algn="l">
               <a:lnSpc>
                 <a:spcPct val="125000"/>
               </a:lnSpc>
               <a:spcBef>
-                <a:spcPts val="0"/>
+                <a:spcPts val="100"/>
               </a:spcBef>
             </a:pPr>
             <a:r>
-              <a:rPr sz="950" b="0" i="0">
+              <a:rPr sz="900" b="0" i="0">
                 <a:solidFill>
                   <a:srgbClr val="1E3652"/>
                 </a:solidFill>
                 <a:latin typeface="Helvetica Neue"/>
               </a:rPr>
-              <a:t>-  G4 contrast, G5 text fit</a:t>
-            </a:r>
-          </a:p>
-          <a:p>
-            <a:pPr algn="l">
-              <a:lnSpc>
-                <a:spcPct val="125000"/>
-              </a:lnSpc>
-              <a:spcBef>
-                <a:spcPts val="700"/>
-              </a:spcBef>
-            </a:pPr>
-            <a:r>
-              <a:rPr sz="950" b="0" i="0">
-                <a:solidFill>
-                  <a:srgbClr val="1E3652"/>
-                </a:solidFill>
-                <a:latin typeface="Helvetica Neue"/>
-              </a:rPr>
-              <a:t>-  repair actions and the loop</a:t>
-            </a:r>
-          </a:p>
-          <a:p>
-            <a:pPr algn="l">
-              <a:lnSpc>
-                <a:spcPct val="125000"/>
-              </a:lnSpc>
-              <a:spcBef>
-                <a:spcPts val="700"/>
-              </a:spcBef>
-            </a:pPr>
-            <a:r>
-              <a:rPr sz="950" b="0" i="0">
-                <a:solidFill>
-                  <a:srgbClr val="1E3652"/>
-                </a:solidFill>
-                <a:latin typeface="Helvetica Neue"/>
-              </a:rPr>
-              <a:t>-  110-slide test set and its labels</a:t>
-            </a:r>
-          </a:p>
-          <a:p>
-            <a:pPr algn="l">
-              <a:lnSpc>
-                <a:spcPct val="125000"/>
-              </a:lnSpc>
-              <a:spcBef>
-                <a:spcPts val="700"/>
-              </a:spcBef>
-            </a:pPr>
-            <a:r>
-              <a:rPr sz="950" b="0" i="0">
-                <a:solidFill>
-                  <a:srgbClr val="1E3652"/>
-                </a:solidFill>
-                <a:latin typeface="Helvetica Neue"/>
-              </a:rPr>
-              <a:t>-  human decks, baselines, the 2x2 experiment</a:t>
-            </a:r>
-          </a:p>
-        </p:txBody>
-      </p:sp>
-      <p:sp>
-        <p:nvSpPr>
-          <p:cNvPr id="20" name="TextBox 19"/>
+              <a:t>8 slides, 90 seconds each</a:t>
+            </a:r>
+          </a:p>
+        </p:txBody>
+      </p:sp>
+      <p:sp>
+        <p:nvSpPr>
+          <p:cNvPr id="12" name="TextBox 11"/>
           <p:cNvSpPr txBox="1"/>
           <p:nvPr/>
         </p:nvSpPr>
         <p:spPr>
           <a:xfrm>
-            <a:off x="868680" y="4937760"/>
-            <a:ext cx="10881360" cy="548640"/>
+            <a:off x="8823960" y="3419856"/>
+            <a:ext cx="2926080" cy="685800"/>
           </a:xfrm>
           <a:prstGeom prst="rect">
             <a:avLst/>
@@ -4245,13 +3831,154 @@
               </a:spcBef>
             </a:pPr>
             <a:r>
-              <a:rPr sz="1050" b="0" i="1">
-                <a:solidFill>
-                  <a:srgbClr val="5A6B7C"/>
+              <a:rPr sz="1000" b="1" i="0">
+                <a:solidFill>
+                  <a:srgbClr val="C08A2E"/>
                 </a:solidFill>
                 <a:latin typeface="Helvetica Neue"/>
               </a:rPr>
-              <a:t>76 test cases pass. The deck above was produced by this pipeline end to end.</a:t>
+              <a:t>render</a:t>
+            </a:r>
+          </a:p>
+          <a:p>
+            <a:pPr algn="l">
+              <a:lnSpc>
+                <a:spcPct val="125000"/>
+              </a:lnSpc>
+              <a:spcBef>
+                <a:spcPts val="100"/>
+              </a:spcBef>
+            </a:pPr>
+            <a:r>
+              <a:rPr sz="900" b="0" i="0">
+                <a:solidFill>
+                  <a:srgbClr val="1E3652"/>
+                </a:solidFill>
+                <a:latin typeface="Helvetica Neue"/>
+              </a:rPr>
+              <a:t>a 9-slide deck, native and editable</a:t>
+            </a:r>
+          </a:p>
+        </p:txBody>
+      </p:sp>
+      <p:sp>
+        <p:nvSpPr>
+          <p:cNvPr id="13" name="TextBox 12"/>
+          <p:cNvSpPr txBox="1"/>
+          <p:nvPr/>
+        </p:nvSpPr>
+        <p:spPr>
+          <a:xfrm>
+            <a:off x="8823960" y="4261104"/>
+            <a:ext cx="2926080" cy="685800"/>
+          </a:xfrm>
+          <a:prstGeom prst="rect">
+            <a:avLst/>
+          </a:prstGeom>
+          <a:noFill/>
+        </p:spPr>
+        <p:txBody>
+          <a:bodyPr wrap="square" anchor="t" lIns="0" rIns="0" tIns="0" bIns="0">
+            <a:spAutoFit/>
+          </a:bodyPr>
+          <a:lstStyle/>
+          <a:p>
+            <a:pPr algn="l">
+              <a:lnSpc>
+                <a:spcPct val="115000"/>
+              </a:lnSpc>
+              <a:spcBef>
+                <a:spcPts val="0"/>
+              </a:spcBef>
+            </a:pPr>
+            <a:r>
+              <a:rPr sz="1000" b="1" i="0">
+                <a:solidFill>
+                  <a:srgbClr val="C08A2E"/>
+                </a:solidFill>
+                <a:latin typeface="Helvetica Neue"/>
+              </a:rPr>
+              <a:t>detect</a:t>
+            </a:r>
+          </a:p>
+          <a:p>
+            <a:pPr algn="l">
+              <a:lnSpc>
+                <a:spcPct val="125000"/>
+              </a:lnSpc>
+              <a:spcBef>
+                <a:spcPts val="100"/>
+              </a:spcBef>
+            </a:pPr>
+            <a:r>
+              <a:rPr sz="900" b="0" i="0">
+                <a:solidFill>
+                  <a:srgbClr val="1E3652"/>
+                </a:solidFill>
+                <a:latin typeface="Helvetica Neue"/>
+              </a:rPr>
+              <a:t>32 violations, SRR 0.00</a:t>
+            </a:r>
+          </a:p>
+        </p:txBody>
+      </p:sp>
+      <p:sp>
+        <p:nvSpPr>
+          <p:cNvPr id="14" name="TextBox 13"/>
+          <p:cNvSpPr txBox="1"/>
+          <p:nvPr/>
+        </p:nvSpPr>
+        <p:spPr>
+          <a:xfrm>
+            <a:off x="8823960" y="5102352"/>
+            <a:ext cx="2926080" cy="685800"/>
+          </a:xfrm>
+          <a:prstGeom prst="rect">
+            <a:avLst/>
+          </a:prstGeom>
+          <a:noFill/>
+        </p:spPr>
+        <p:txBody>
+          <a:bodyPr wrap="square" anchor="t" lIns="0" rIns="0" tIns="0" bIns="0">
+            <a:spAutoFit/>
+          </a:bodyPr>
+          <a:lstStyle/>
+          <a:p>
+            <a:pPr algn="l">
+              <a:lnSpc>
+                <a:spcPct val="115000"/>
+              </a:lnSpc>
+              <a:spcBef>
+                <a:spcPts val="0"/>
+              </a:spcBef>
+            </a:pPr>
+            <a:r>
+              <a:rPr sz="1000" b="1" i="0">
+                <a:solidFill>
+                  <a:srgbClr val="C08A2E"/>
+                </a:solidFill>
+                <a:latin typeface="Helvetica Neue"/>
+              </a:rPr>
+              <a:t>pytest</a:t>
+            </a:r>
+          </a:p>
+          <a:p>
+            <a:pPr algn="l">
+              <a:lnSpc>
+                <a:spcPct val="125000"/>
+              </a:lnSpc>
+              <a:spcBef>
+                <a:spcPts val="100"/>
+              </a:spcBef>
+            </a:pPr>
+            <a:r>
+              <a:rPr sz="900" b="0" i="0">
+                <a:solidFill>
+                  <a:srgbClr val="1E3652"/>
+                </a:solidFill>
+                <a:latin typeface="Helvetica Neue"/>
+              </a:rPr>
+              <a:t>76 cases green</a:t>
             </a:r>
           </a:p>
         </p:txBody>
@@ -4371,7 +4098,7 @@
                 </a:solidFill>
                 <a:latin typeface="Helvetica Neue"/>
               </a:rPr>
-              <a:t>PLAN</a:t>
+              <a:t>STATUS</a:t>
             </a:r>
           </a:p>
         </p:txBody>
@@ -4413,7 +4140,7 @@
                 </a:solidFill>
                 <a:latin typeface="Helvetica Neue"/>
               </a:rPr>
-              <a:t>The experiment, and the calendar</a:t>
+              <a:t>What is built, what is next</a:t>
             </a:r>
           </a:p>
         </p:txBody>
@@ -4486,6 +4213,885 @@
                 <a:latin typeface="Helvetica Neue"/>
               </a:rPr>
               <a:t>11</a:t>
+            </a:r>
+          </a:p>
+        </p:txBody>
+      </p:sp>
+      <p:sp>
+        <p:nvSpPr>
+          <p:cNvPr id="8" name="Rectangle 7"/>
+          <p:cNvSpPr/>
+          <p:nvPr/>
+        </p:nvSpPr>
+        <p:spPr>
+          <a:xfrm>
+            <a:off x="868680" y="1691640"/>
+            <a:ext cx="3520440" cy="2926080"/>
+          </a:xfrm>
+          <a:prstGeom prst="rect">
+            <a:avLst/>
+          </a:prstGeom>
+          <a:solidFill>
+            <a:srgbClr val="F4F6F8"/>
+          </a:solidFill>
+          <a:ln>
+            <a:noFill/>
+          </a:ln>
+          <a:effectLst/>
+        </p:spPr>
+        <p:txBody>
+          <a:bodyPr rtlCol="0" anchor="ctr" wrap="square"/>
+          <a:lstStyle/>
+          <a:p>
+            <a:pPr algn="ctr"/>
+          </a:p>
+        </p:txBody>
+      </p:sp>
+      <p:sp>
+        <p:nvSpPr>
+          <p:cNvPr id="9" name="Rectangle 8"/>
+          <p:cNvSpPr/>
+          <p:nvPr/>
+        </p:nvSpPr>
+        <p:spPr>
+          <a:xfrm>
+            <a:off x="868680" y="1691640"/>
+            <a:ext cx="3520440" cy="50292"/>
+          </a:xfrm>
+          <a:prstGeom prst="rect">
+            <a:avLst/>
+          </a:prstGeom>
+          <a:solidFill>
+            <a:srgbClr val="2F7D5D"/>
+          </a:solidFill>
+          <a:ln>
+            <a:noFill/>
+          </a:ln>
+          <a:effectLst/>
+        </p:spPr>
+        <p:txBody>
+          <a:bodyPr rtlCol="0" anchor="ctr" wrap="square"/>
+          <a:lstStyle/>
+          <a:p>
+            <a:pPr algn="ctr"/>
+          </a:p>
+        </p:txBody>
+      </p:sp>
+      <p:sp>
+        <p:nvSpPr>
+          <p:cNvPr id="10" name="TextBox 9"/>
+          <p:cNvSpPr txBox="1"/>
+          <p:nvPr/>
+        </p:nvSpPr>
+        <p:spPr>
+          <a:xfrm>
+            <a:off x="1097280" y="1874519"/>
+            <a:ext cx="3108960" cy="320040"/>
+          </a:xfrm>
+          <a:prstGeom prst="rect">
+            <a:avLst/>
+          </a:prstGeom>
+          <a:noFill/>
+        </p:spPr>
+        <p:txBody>
+          <a:bodyPr wrap="square" anchor="t" lIns="0" rIns="0" tIns="0" bIns="0">
+            <a:spAutoFit/>
+          </a:bodyPr>
+          <a:lstStyle/>
+          <a:p>
+            <a:pPr algn="l">
+              <a:lnSpc>
+                <a:spcPct val="115000"/>
+              </a:lnSpc>
+              <a:spcBef>
+                <a:spcPts val="0"/>
+              </a:spcBef>
+            </a:pPr>
+            <a:r>
+              <a:rPr sz="1250" b="1" i="0">
+                <a:solidFill>
+                  <a:srgbClr val="10233A"/>
+                </a:solidFill>
+                <a:latin typeface="Helvetica Neue"/>
+              </a:rPr>
+              <a:t>Built and tested</a:t>
+            </a:r>
+          </a:p>
+        </p:txBody>
+      </p:sp>
+      <p:sp>
+        <p:nvSpPr>
+          <p:cNvPr id="11" name="TextBox 10"/>
+          <p:cNvSpPr txBox="1"/>
+          <p:nvPr/>
+        </p:nvSpPr>
+        <p:spPr>
+          <a:xfrm>
+            <a:off x="1097280" y="2331720"/>
+            <a:ext cx="3154680" cy="2834640"/>
+          </a:xfrm>
+          <a:prstGeom prst="rect">
+            <a:avLst/>
+          </a:prstGeom>
+          <a:noFill/>
+        </p:spPr>
+        <p:txBody>
+          <a:bodyPr wrap="square" anchor="t" lIns="0" rIns="0" tIns="0" bIns="0">
+            <a:spAutoFit/>
+          </a:bodyPr>
+          <a:lstStyle/>
+          <a:p>
+            <a:pPr algn="l">
+              <a:lnSpc>
+                <a:spcPct val="125000"/>
+              </a:lnSpc>
+              <a:spcBef>
+                <a:spcPts val="0"/>
+              </a:spcBef>
+            </a:pPr>
+            <a:r>
+              <a:rPr sz="950" b="0" i="0">
+                <a:solidFill>
+                  <a:srgbClr val="1E3652"/>
+                </a:solidFill>
+                <a:latin typeface="Helvetica Neue"/>
+              </a:rPr>
+              <a:t>-  parse: sections, figures, captions</a:t>
+            </a:r>
+          </a:p>
+          <a:p>
+            <a:pPr algn="l">
+              <a:lnSpc>
+                <a:spcPct val="125000"/>
+              </a:lnSpc>
+              <a:spcBef>
+                <a:spcPts val="700"/>
+              </a:spcBef>
+            </a:pPr>
+            <a:r>
+              <a:rPr sz="950" b="0" i="0">
+                <a:solidFill>
+                  <a:srgbClr val="1E3652"/>
+                </a:solidFill>
+                <a:latin typeface="Helvetica Neue"/>
+              </a:rPr>
+              <a:t>-  figure clipping, 12/32 on the sample</a:t>
+            </a:r>
+          </a:p>
+          <a:p>
+            <a:pPr algn="l">
+              <a:lnSpc>
+                <a:spcPct val="125000"/>
+              </a:lnSpc>
+              <a:spcBef>
+                <a:spcPts val="700"/>
+              </a:spcBef>
+            </a:pPr>
+            <a:r>
+              <a:rPr sz="950" b="0" i="0">
+                <a:solidFill>
+                  <a:srgbClr val="1E3652"/>
+                </a:solidFill>
+                <a:latin typeface="Helvetica Neue"/>
+              </a:rPr>
+              <a:t>-  render: native .pptx with speaker notes</a:t>
+            </a:r>
+          </a:p>
+          <a:p>
+            <a:pPr algn="l">
+              <a:lnSpc>
+                <a:spcPct val="125000"/>
+              </a:lnSpc>
+              <a:spcBef>
+                <a:spcPts val="700"/>
+              </a:spcBef>
+            </a:pPr>
+            <a:r>
+              <a:rPr sz="950" b="0" i="0">
+                <a:solidFill>
+                  <a:srgbClr val="1E3652"/>
+                </a:solidFill>
+                <a:latin typeface="Helvetica Neue"/>
+              </a:rPr>
+              <a:t>-  G1, G2, G3, G6 + SRR</a:t>
+            </a:r>
+          </a:p>
+          <a:p>
+            <a:pPr algn="l">
+              <a:lnSpc>
+                <a:spcPct val="125000"/>
+              </a:lnSpc>
+              <a:spcBef>
+                <a:spcPts val="700"/>
+              </a:spcBef>
+            </a:pPr>
+            <a:r>
+              <a:rPr sz="950" b="0" i="0">
+                <a:solidFill>
+                  <a:srgbClr val="1E3652"/>
+                </a:solidFill>
+                <a:latin typeface="Helvetica Neue"/>
+              </a:rPr>
+              <a:t>-  selection rule table, 55 test functions</a:t>
+            </a:r>
+          </a:p>
+        </p:txBody>
+      </p:sp>
+      <p:sp>
+        <p:nvSpPr>
+          <p:cNvPr id="12" name="Rectangle 11"/>
+          <p:cNvSpPr/>
+          <p:nvPr/>
+        </p:nvSpPr>
+        <p:spPr>
+          <a:xfrm>
+            <a:off x="4553712" y="1691640"/>
+            <a:ext cx="3520440" cy="2926080"/>
+          </a:xfrm>
+          <a:prstGeom prst="rect">
+            <a:avLst/>
+          </a:prstGeom>
+          <a:solidFill>
+            <a:srgbClr val="F4F6F8"/>
+          </a:solidFill>
+          <a:ln>
+            <a:noFill/>
+          </a:ln>
+          <a:effectLst/>
+        </p:spPr>
+        <p:txBody>
+          <a:bodyPr rtlCol="0" anchor="ctr" wrap="square"/>
+          <a:lstStyle/>
+          <a:p>
+            <a:pPr algn="ctr"/>
+          </a:p>
+        </p:txBody>
+      </p:sp>
+      <p:sp>
+        <p:nvSpPr>
+          <p:cNvPr id="13" name="Rectangle 12"/>
+          <p:cNvSpPr/>
+          <p:nvPr/>
+        </p:nvSpPr>
+        <p:spPr>
+          <a:xfrm>
+            <a:off x="4553712" y="1691640"/>
+            <a:ext cx="3520440" cy="50292"/>
+          </a:xfrm>
+          <a:prstGeom prst="rect">
+            <a:avLst/>
+          </a:prstGeom>
+          <a:solidFill>
+            <a:srgbClr val="B07A1E"/>
+          </a:solidFill>
+          <a:ln>
+            <a:noFill/>
+          </a:ln>
+          <a:effectLst/>
+        </p:spPr>
+        <p:txBody>
+          <a:bodyPr rtlCol="0" anchor="ctr" wrap="square"/>
+          <a:lstStyle/>
+          <a:p>
+            <a:pPr algn="ctr"/>
+          </a:p>
+        </p:txBody>
+      </p:sp>
+      <p:sp>
+        <p:nvSpPr>
+          <p:cNvPr id="14" name="TextBox 13"/>
+          <p:cNvSpPr txBox="1"/>
+          <p:nvPr/>
+        </p:nvSpPr>
+        <p:spPr>
+          <a:xfrm>
+            <a:off x="4782312" y="1874519"/>
+            <a:ext cx="3108960" cy="320040"/>
+          </a:xfrm>
+          <a:prstGeom prst="rect">
+            <a:avLst/>
+          </a:prstGeom>
+          <a:noFill/>
+        </p:spPr>
+        <p:txBody>
+          <a:bodyPr wrap="square" anchor="t" lIns="0" rIns="0" tIns="0" bIns="0">
+            <a:spAutoFit/>
+          </a:bodyPr>
+          <a:lstStyle/>
+          <a:p>
+            <a:pPr algn="l">
+              <a:lnSpc>
+                <a:spcPct val="115000"/>
+              </a:lnSpc>
+              <a:spcBef>
+                <a:spcPts val="0"/>
+              </a:spcBef>
+            </a:pPr>
+            <a:r>
+              <a:rPr sz="1250" b="1" i="0">
+                <a:solidFill>
+                  <a:srgbClr val="10233A"/>
+                </a:solidFill>
+                <a:latin typeface="Helvetica Neue"/>
+              </a:rPr>
+              <a:t>Partially built</a:t>
+            </a:r>
+          </a:p>
+        </p:txBody>
+      </p:sp>
+      <p:sp>
+        <p:nvSpPr>
+          <p:cNvPr id="15" name="TextBox 14"/>
+          <p:cNvSpPr txBox="1"/>
+          <p:nvPr/>
+        </p:nvSpPr>
+        <p:spPr>
+          <a:xfrm>
+            <a:off x="4782312" y="2331720"/>
+            <a:ext cx="3154680" cy="2834640"/>
+          </a:xfrm>
+          <a:prstGeom prst="rect">
+            <a:avLst/>
+          </a:prstGeom>
+          <a:noFill/>
+        </p:spPr>
+        <p:txBody>
+          <a:bodyPr wrap="square" anchor="t" lIns="0" rIns="0" tIns="0" bIns="0">
+            <a:spAutoFit/>
+          </a:bodyPr>
+          <a:lstStyle/>
+          <a:p>
+            <a:pPr algn="l">
+              <a:lnSpc>
+                <a:spcPct val="125000"/>
+              </a:lnSpc>
+              <a:spcBef>
+                <a:spcPts val="0"/>
+              </a:spcBef>
+            </a:pPr>
+            <a:r>
+              <a:rPr sz="950" b="0" i="0">
+                <a:solidFill>
+                  <a:srgbClr val="1E3652"/>
+                </a:solidFill>
+                <a:latin typeface="Helvetica Neue"/>
+              </a:rPr>
+              <a:t>-  G3 / G6 still use one global threshold</a:t>
+            </a:r>
+          </a:p>
+          <a:p>
+            <a:pPr algn="l">
+              <a:lnSpc>
+                <a:spcPct val="125000"/>
+              </a:lnSpc>
+              <a:spcBef>
+                <a:spcPts val="700"/>
+              </a:spcBef>
+            </a:pPr>
+            <a:r>
+              <a:rPr sz="950" b="0" i="0">
+                <a:solidFill>
+                  <a:srgbClr val="1E3652"/>
+                </a:solidFill>
+                <a:latin typeface="Helvetica Neue"/>
+              </a:rPr>
+              <a:t>-  figure captions need a word-boundary trim</a:t>
+            </a:r>
+          </a:p>
+          <a:p>
+            <a:pPr algn="l">
+              <a:lnSpc>
+                <a:spcPct val="125000"/>
+              </a:lnSpc>
+              <a:spcBef>
+                <a:spcPts val="700"/>
+              </a:spcBef>
+            </a:pPr>
+            <a:r>
+              <a:rPr sz="950" b="0" i="0">
+                <a:solidFill>
+                  <a:srgbClr val="1E3652"/>
+                </a:solidFill>
+                <a:latin typeface="Helvetica Neue"/>
+              </a:rPr>
+              <a:t>-  claims are still extracted by heuristic</a:t>
+            </a:r>
+          </a:p>
+        </p:txBody>
+      </p:sp>
+      <p:sp>
+        <p:nvSpPr>
+          <p:cNvPr id="16" name="Rectangle 15"/>
+          <p:cNvSpPr/>
+          <p:nvPr/>
+        </p:nvSpPr>
+        <p:spPr>
+          <a:xfrm>
+            <a:off x="8238744" y="1691640"/>
+            <a:ext cx="3520440" cy="2926080"/>
+          </a:xfrm>
+          <a:prstGeom prst="rect">
+            <a:avLst/>
+          </a:prstGeom>
+          <a:solidFill>
+            <a:srgbClr val="F4F6F8"/>
+          </a:solidFill>
+          <a:ln>
+            <a:noFill/>
+          </a:ln>
+          <a:effectLst/>
+        </p:spPr>
+        <p:txBody>
+          <a:bodyPr rtlCol="0" anchor="ctr" wrap="square"/>
+          <a:lstStyle/>
+          <a:p>
+            <a:pPr algn="ctr"/>
+          </a:p>
+        </p:txBody>
+      </p:sp>
+      <p:sp>
+        <p:nvSpPr>
+          <p:cNvPr id="17" name="Rectangle 16"/>
+          <p:cNvSpPr/>
+          <p:nvPr/>
+        </p:nvSpPr>
+        <p:spPr>
+          <a:xfrm>
+            <a:off x="8238744" y="1691640"/>
+            <a:ext cx="3520440" cy="50292"/>
+          </a:xfrm>
+          <a:prstGeom prst="rect">
+            <a:avLst/>
+          </a:prstGeom>
+          <a:solidFill>
+            <a:srgbClr val="5A6B7C"/>
+          </a:solidFill>
+          <a:ln>
+            <a:noFill/>
+          </a:ln>
+          <a:effectLst/>
+        </p:spPr>
+        <p:txBody>
+          <a:bodyPr rtlCol="0" anchor="ctr" wrap="square"/>
+          <a:lstStyle/>
+          <a:p>
+            <a:pPr algn="ctr"/>
+          </a:p>
+        </p:txBody>
+      </p:sp>
+      <p:sp>
+        <p:nvSpPr>
+          <p:cNvPr id="18" name="TextBox 17"/>
+          <p:cNvSpPr txBox="1"/>
+          <p:nvPr/>
+        </p:nvSpPr>
+        <p:spPr>
+          <a:xfrm>
+            <a:off x="8467344" y="1874519"/>
+            <a:ext cx="3108960" cy="320040"/>
+          </a:xfrm>
+          <a:prstGeom prst="rect">
+            <a:avLst/>
+          </a:prstGeom>
+          <a:noFill/>
+        </p:spPr>
+        <p:txBody>
+          <a:bodyPr wrap="square" anchor="t" lIns="0" rIns="0" tIns="0" bIns="0">
+            <a:spAutoFit/>
+          </a:bodyPr>
+          <a:lstStyle/>
+          <a:p>
+            <a:pPr algn="l">
+              <a:lnSpc>
+                <a:spcPct val="115000"/>
+              </a:lnSpc>
+              <a:spcBef>
+                <a:spcPts val="0"/>
+              </a:spcBef>
+            </a:pPr>
+            <a:r>
+              <a:rPr sz="1250" b="1" i="0">
+                <a:solidFill>
+                  <a:srgbClr val="10233A"/>
+                </a:solidFill>
+                <a:latin typeface="Helvetica Neue"/>
+              </a:rPr>
+              <a:t>Not started</a:t>
+            </a:r>
+          </a:p>
+        </p:txBody>
+      </p:sp>
+      <p:sp>
+        <p:nvSpPr>
+          <p:cNvPr id="19" name="TextBox 18"/>
+          <p:cNvSpPr txBox="1"/>
+          <p:nvPr/>
+        </p:nvSpPr>
+        <p:spPr>
+          <a:xfrm>
+            <a:off x="8467344" y="2331720"/>
+            <a:ext cx="3154680" cy="2834640"/>
+          </a:xfrm>
+          <a:prstGeom prst="rect">
+            <a:avLst/>
+          </a:prstGeom>
+          <a:noFill/>
+        </p:spPr>
+        <p:txBody>
+          <a:bodyPr wrap="square" anchor="t" lIns="0" rIns="0" tIns="0" bIns="0">
+            <a:spAutoFit/>
+          </a:bodyPr>
+          <a:lstStyle/>
+          <a:p>
+            <a:pPr algn="l">
+              <a:lnSpc>
+                <a:spcPct val="125000"/>
+              </a:lnSpc>
+              <a:spcBef>
+                <a:spcPts val="0"/>
+              </a:spcBef>
+            </a:pPr>
+            <a:r>
+              <a:rPr sz="950" b="0" i="0">
+                <a:solidFill>
+                  <a:srgbClr val="1E3652"/>
+                </a:solidFill>
+                <a:latin typeface="Helvetica Neue"/>
+              </a:rPr>
+              <a:t>-  G4 contrast, G5 text fit</a:t>
+            </a:r>
+          </a:p>
+          <a:p>
+            <a:pPr algn="l">
+              <a:lnSpc>
+                <a:spcPct val="125000"/>
+              </a:lnSpc>
+              <a:spcBef>
+                <a:spcPts val="700"/>
+              </a:spcBef>
+            </a:pPr>
+            <a:r>
+              <a:rPr sz="950" b="0" i="0">
+                <a:solidFill>
+                  <a:srgbClr val="1E3652"/>
+                </a:solidFill>
+                <a:latin typeface="Helvetica Neue"/>
+              </a:rPr>
+              <a:t>-  repair actions and the loop</a:t>
+            </a:r>
+          </a:p>
+          <a:p>
+            <a:pPr algn="l">
+              <a:lnSpc>
+                <a:spcPct val="125000"/>
+              </a:lnSpc>
+              <a:spcBef>
+                <a:spcPts val="700"/>
+              </a:spcBef>
+            </a:pPr>
+            <a:r>
+              <a:rPr sz="950" b="0" i="0">
+                <a:solidFill>
+                  <a:srgbClr val="1E3652"/>
+                </a:solidFill>
+                <a:latin typeface="Helvetica Neue"/>
+              </a:rPr>
+              <a:t>-  110-slide test set and its labels</a:t>
+            </a:r>
+          </a:p>
+          <a:p>
+            <a:pPr algn="l">
+              <a:lnSpc>
+                <a:spcPct val="125000"/>
+              </a:lnSpc>
+              <a:spcBef>
+                <a:spcPts val="700"/>
+              </a:spcBef>
+            </a:pPr>
+            <a:r>
+              <a:rPr sz="950" b="0" i="0">
+                <a:solidFill>
+                  <a:srgbClr val="1E3652"/>
+                </a:solidFill>
+                <a:latin typeface="Helvetica Neue"/>
+              </a:rPr>
+              <a:t>-  human decks, baselines, the 2x2 experiment</a:t>
+            </a:r>
+          </a:p>
+        </p:txBody>
+      </p:sp>
+      <p:sp>
+        <p:nvSpPr>
+          <p:cNvPr id="20" name="TextBox 19"/>
+          <p:cNvSpPr txBox="1"/>
+          <p:nvPr/>
+        </p:nvSpPr>
+        <p:spPr>
+          <a:xfrm>
+            <a:off x="868680" y="4937760"/>
+            <a:ext cx="10881360" cy="548640"/>
+          </a:xfrm>
+          <a:prstGeom prst="rect">
+            <a:avLst/>
+          </a:prstGeom>
+          <a:noFill/>
+        </p:spPr>
+        <p:txBody>
+          <a:bodyPr wrap="square" anchor="t" lIns="0" rIns="0" tIns="0" bIns="0">
+            <a:spAutoFit/>
+          </a:bodyPr>
+          <a:lstStyle/>
+          <a:p>
+            <a:pPr algn="l">
+              <a:lnSpc>
+                <a:spcPct val="115000"/>
+              </a:lnSpc>
+              <a:spcBef>
+                <a:spcPts val="0"/>
+              </a:spcBef>
+            </a:pPr>
+            <a:r>
+              <a:rPr sz="1050" b="0" i="1">
+                <a:solidFill>
+                  <a:srgbClr val="5A6B7C"/>
+                </a:solidFill>
+                <a:latin typeface="Helvetica Neue"/>
+              </a:rPr>
+              <a:t>76 test cases pass. The deck above was produced by this pipeline end to end.</a:t>
+            </a:r>
+          </a:p>
+        </p:txBody>
+      </p:sp>
+    </p:spTree>
+  </p:cSld>
+  <p:clrMapOvr>
+    <a:masterClrMapping/>
+  </p:clrMapOvr>
+</p:sld>
+</file>
+
+<file path=ppt/slides/slide12.xml><?xml version="1.0" encoding="utf-8"?>
+<p:sld xmlns:a="http://schemas.openxmlformats.org/drawingml/2006/main" xmlns:p="http://schemas.openxmlformats.org/presentationml/2006/main" xmlns:r="http://schemas.openxmlformats.org/officeDocument/2006/relationships">
+  <p:cSld>
+    <p:spTree>
+      <p:nvGrpSpPr>
+        <p:cNvPr id="1" name=""/>
+        <p:cNvGrpSpPr/>
+        <p:nvPr/>
+      </p:nvGrpSpPr>
+      <p:grpSpPr/>
+      <p:sp>
+        <p:nvSpPr>
+          <p:cNvPr id="2" name="Rectangle 1"/>
+          <p:cNvSpPr/>
+          <p:nvPr/>
+        </p:nvSpPr>
+        <p:spPr>
+          <a:xfrm>
+            <a:off x="0" y="0"/>
+            <a:ext cx="237744" cy="6858000"/>
+          </a:xfrm>
+          <a:prstGeom prst="rect">
+            <a:avLst/>
+          </a:prstGeom>
+          <a:solidFill>
+            <a:srgbClr val="10233A"/>
+          </a:solidFill>
+          <a:ln>
+            <a:noFill/>
+          </a:ln>
+          <a:effectLst/>
+        </p:spPr>
+        <p:txBody>
+          <a:bodyPr rtlCol="0" anchor="ctr" wrap="square"/>
+          <a:lstStyle/>
+          <a:p>
+            <a:pPr algn="ctr"/>
+          </a:p>
+        </p:txBody>
+      </p:sp>
+      <p:sp>
+        <p:nvSpPr>
+          <p:cNvPr id="3" name="Rectangle 2"/>
+          <p:cNvSpPr/>
+          <p:nvPr/>
+        </p:nvSpPr>
+        <p:spPr>
+          <a:xfrm>
+            <a:off x="237744" y="0"/>
+            <a:ext cx="45720" cy="6858000"/>
+          </a:xfrm>
+          <a:prstGeom prst="rect">
+            <a:avLst/>
+          </a:prstGeom>
+          <a:solidFill>
+            <a:srgbClr val="C08A2E"/>
+          </a:solidFill>
+          <a:ln>
+            <a:noFill/>
+          </a:ln>
+          <a:effectLst/>
+        </p:spPr>
+        <p:txBody>
+          <a:bodyPr rtlCol="0" anchor="ctr" wrap="square"/>
+          <a:lstStyle/>
+          <a:p>
+            <a:pPr algn="ctr"/>
+          </a:p>
+        </p:txBody>
+      </p:sp>
+      <p:sp>
+        <p:nvSpPr>
+          <p:cNvPr id="4" name="TextBox 3"/>
+          <p:cNvSpPr txBox="1"/>
+          <p:nvPr/>
+        </p:nvSpPr>
+        <p:spPr>
+          <a:xfrm>
+            <a:off x="868680" y="384048"/>
+            <a:ext cx="10607040" cy="274320"/>
+          </a:xfrm>
+          <a:prstGeom prst="rect">
+            <a:avLst/>
+          </a:prstGeom>
+          <a:noFill/>
+        </p:spPr>
+        <p:txBody>
+          <a:bodyPr wrap="square" anchor="t" lIns="0" rIns="0" tIns="0" bIns="0">
+            <a:spAutoFit/>
+          </a:bodyPr>
+          <a:lstStyle/>
+          <a:p>
+            <a:pPr algn="l">
+              <a:lnSpc>
+                <a:spcPct val="115000"/>
+              </a:lnSpc>
+              <a:spcBef>
+                <a:spcPts val="0"/>
+              </a:spcBef>
+            </a:pPr>
+            <a:r>
+              <a:rPr sz="950" b="1" i="0">
+                <a:solidFill>
+                  <a:srgbClr val="C08A2E"/>
+                </a:solidFill>
+                <a:latin typeface="Helvetica Neue"/>
+              </a:rPr>
+              <a:t>PLAN</a:t>
+            </a:r>
+          </a:p>
+        </p:txBody>
+      </p:sp>
+      <p:sp>
+        <p:nvSpPr>
+          <p:cNvPr id="5" name="TextBox 4"/>
+          <p:cNvSpPr txBox="1"/>
+          <p:nvPr/>
+        </p:nvSpPr>
+        <p:spPr>
+          <a:xfrm>
+            <a:off x="868680" y="640080"/>
+            <a:ext cx="10881360" cy="685800"/>
+          </a:xfrm>
+          <a:prstGeom prst="rect">
+            <a:avLst/>
+          </a:prstGeom>
+          <a:noFill/>
+        </p:spPr>
+        <p:txBody>
+          <a:bodyPr wrap="square" anchor="t" lIns="0" rIns="0" tIns="0" bIns="0">
+            <a:spAutoFit/>
+          </a:bodyPr>
+          <a:lstStyle/>
+          <a:p>
+            <a:pPr algn="l">
+              <a:lnSpc>
+                <a:spcPct val="105000"/>
+              </a:lnSpc>
+              <a:spcBef>
+                <a:spcPts val="0"/>
+              </a:spcBef>
+            </a:pPr>
+            <a:r>
+              <a:rPr sz="2500" b="1" i="0">
+                <a:solidFill>
+                  <a:srgbClr val="10233A"/>
+                </a:solidFill>
+                <a:latin typeface="Helvetica Neue"/>
+              </a:rPr>
+              <a:t>The experiment, and the calendar</a:t>
+            </a:r>
+          </a:p>
+        </p:txBody>
+      </p:sp>
+      <p:sp>
+        <p:nvSpPr>
+          <p:cNvPr id="6" name="Rectangle 5"/>
+          <p:cNvSpPr/>
+          <p:nvPr/>
+        </p:nvSpPr>
+        <p:spPr>
+          <a:xfrm>
+            <a:off x="868680" y="1389888"/>
+            <a:ext cx="10881360" cy="12801"/>
+          </a:xfrm>
+          <a:prstGeom prst="rect">
+            <a:avLst/>
+          </a:prstGeom>
+          <a:solidFill>
+            <a:srgbClr val="DDE2E8"/>
+          </a:solidFill>
+          <a:ln>
+            <a:noFill/>
+          </a:ln>
+          <a:effectLst/>
+        </p:spPr>
+        <p:txBody>
+          <a:bodyPr rtlCol="0" anchor="ctr" wrap="square"/>
+          <a:lstStyle/>
+          <a:p>
+            <a:pPr algn="ctr"/>
+          </a:p>
+        </p:txBody>
+      </p:sp>
+      <p:sp>
+        <p:nvSpPr>
+          <p:cNvPr id="7" name="TextBox 6"/>
+          <p:cNvSpPr txBox="1"/>
+          <p:nvPr/>
+        </p:nvSpPr>
+        <p:spPr>
+          <a:xfrm>
+            <a:off x="11155680" y="6355080"/>
+            <a:ext cx="640080" cy="274320"/>
+          </a:xfrm>
+          <a:prstGeom prst="rect">
+            <a:avLst/>
+          </a:prstGeom>
+          <a:noFill/>
+        </p:spPr>
+        <p:txBody>
+          <a:bodyPr wrap="square" anchor="t" lIns="0" rIns="0" tIns="0" bIns="0">
+            <a:spAutoFit/>
+          </a:bodyPr>
+          <a:lstStyle/>
+          <a:p>
+            <a:pPr algn="r">
+              <a:lnSpc>
+                <a:spcPct val="115000"/>
+              </a:lnSpc>
+              <a:spcBef>
+                <a:spcPts val="0"/>
+              </a:spcBef>
+            </a:pPr>
+            <a:r>
+              <a:rPr sz="900" b="0" i="0">
+                <a:solidFill>
+                  <a:srgbClr val="8A99A8"/>
+                </a:solidFill>
+                <a:latin typeface="Helvetica Neue"/>
+              </a:rPr>
+              <a:t>12</a:t>
             </a:r>
           </a:p>
         </p:txBody>
@@ -5525,7 +6131,7 @@
 </p:sld>
 </file>
 
-<file path=ppt/slides/slide12.xml><?xml version="1.0" encoding="utf-8"?>
+<file path=ppt/slides/slide13.xml><?xml version="1.0" encoding="utf-8"?>
 <p:sld xmlns:a="http://schemas.openxmlformats.org/drawingml/2006/main" xmlns:p="http://schemas.openxmlformats.org/presentationml/2006/main" xmlns:r="http://schemas.openxmlformats.org/officeDocument/2006/relationships">
   <p:cSld>
     <p:spTree>
@@ -5746,7 +6352,7 @@
                 </a:solidFill>
                 <a:latin typeface="Helvetica Neue"/>
               </a:rPr>
-              <a:t>12</a:t>
+              <a:t>13</a:t>
             </a:r>
           </a:p>
         </p:txBody>

</xml_diff>

<commit_message>
deck + docs: the design space behind the six gates
- docs/metric_candidates.md: 65 measurable properties in seven categories,
  each marked built / planned / needs render / human / not-a-gate, plus the
  five tests a candidate must pass and the three gaps the list exposes
- new slide 9 in both decks: 65 candidates -> 6 gates, with the source of each
  gate in the candidate list, and the boundary of a mechanical metric

Renumbers the slides that follow; 14 pages each.
</commit_message>
<xml_diff>
--- a/deck/progress_deck.pptx
+++ b/deck/progress_deck.pptx
@@ -18,6 +18,7 @@
     <p:sldId id="266" r:id="rId17"/>
     <p:sldId id="267" r:id="rId18"/>
     <p:sldId id="268" r:id="rId19"/>
+    <p:sldId id="269" r:id="rId20"/>
   </p:sldIdLst>
   <p:sldSz cx="12191695" cy="6858000" type="screen4x3"/>
   <p:notesSz cx="6858000" cy="9144000"/>
@@ -3493,7 +3494,7 @@
                 </a:solidFill>
                 <a:latin typeface="Helvetica Neue"/>
               </a:rPr>
-              <a:t>THE RUN</a:t>
+              <a:t>RESULTS SO FAR</a:t>
             </a:r>
           </a:p>
         </p:txBody>
@@ -3535,7 +3536,7 @@
                 </a:solidFill>
                 <a:latin typeface="Helvetica Neue"/>
               </a:rPr>
-              <a:t>It runs end to end, and it fails honestly</a:t>
+              <a:t>Every generated slide fails at least one gate</a:t>
             </a:r>
           </a:p>
         </p:txBody>
@@ -3614,7 +3615,7 @@
       </p:sp>
       <p:pic>
         <p:nvPicPr>
-          <p:cNvPr id="8" name="Picture 7" descr="console_run.png"/>
+          <p:cNvPr id="8" name="Picture 7" descr="slide02.png"/>
           <p:cNvPicPr>
             <a:picLocks noChangeAspect="1"/>
           </p:cNvPicPr>
@@ -3629,7 +3630,7 @@
         <p:spPr>
           <a:xfrm>
             <a:off x="868680" y="1645920"/>
-            <a:ext cx="7589520" cy="4827813"/>
+            <a:ext cx="6263640" cy="3523298"/>
           </a:xfrm>
           <a:prstGeom prst="rect">
             <a:avLst/>
@@ -3644,8 +3645,8 @@
         </p:nvSpPr>
         <p:spPr>
           <a:xfrm>
-            <a:off x="868680" y="6455664"/>
-            <a:ext cx="7589520" cy="274320"/>
+            <a:off x="868680" y="5257800"/>
+            <a:ext cx="6263640" cy="457200"/>
           </a:xfrm>
           <a:prstGeom prst="rect">
             <a:avLst/>
@@ -3667,27 +3668,698 @@
               </a:spcBef>
             </a:pPr>
             <a:r>
-              <a:rPr sz="800" b="0" i="1">
+              <a:rPr sz="850" b="0" i="1">
                 <a:solidFill>
                   <a:srgbClr val="5A6B7C"/>
                 </a:solidFill>
                 <a:latin typeface="Helvetica Neue"/>
               </a:rPr>
-              <a:t>Real terminal output; rows in the middle are elided.</a:t>
-            </a:r>
-          </a:p>
-        </p:txBody>
-      </p:sp>
-      <p:sp>
-        <p:nvSpPr>
-          <p:cNvPr id="10" name="TextBox 9"/>
+              <a:t>Slide 2 of the generated deck: figure placed, caption under it</a:t>
+            </a:r>
+          </a:p>
+        </p:txBody>
+      </p:sp>
+      <p:graphicFrame>
+        <p:nvGraphicFramePr>
+          <p:cNvPr id="10" name="Table 9"/>
+          <p:cNvGraphicFramePr>
+            <a:graphicFrameLocks noGrp="1"/>
+          </p:cNvGraphicFramePr>
+          <p:nvPr/>
+        </p:nvGraphicFramePr>
+        <p:xfrm>
+          <a:off x="7452360" y="1664208"/>
+          <a:ext cx="4160519" cy="2121408"/>
+        </p:xfrm>
+        <a:graphic>
+          <a:graphicData uri="http://schemas.openxmlformats.org/drawingml/2006/table">
+            <a:tbl>
+              <a:tblPr firstRow="1" bandRow="1">
+                <a:tableStyleId>{5C22544A-7EE6-4342-B048-85BDC9FD1C3A}</a:tableStyleId>
+              </a:tblPr>
+              <a:tblGrid>
+                <a:gridCol w="1874519"/>
+                <a:gridCol w="1143000"/>
+                <a:gridCol w="1143000"/>
+              </a:tblGrid>
+              <a:tr h="310896">
+                <a:tc>
+                  <a:txBody>
+                    <a:bodyPr wrap="square"/>
+                    <a:lstStyle/>
+                    <a:p>
+                      <a:pPr algn="l">
+                        <a:lnSpc>
+                          <a:spcPct val="115000"/>
+                        </a:lnSpc>
+                        <a:spcBef>
+                          <a:spcPts val="0"/>
+                        </a:spcBef>
+                      </a:pPr>
+                      <a:r>
+                        <a:rPr sz="950" b="1" i="0">
+                          <a:solidFill>
+                            <a:srgbClr val="10233A"/>
+                          </a:solidFill>
+                          <a:latin typeface="Helvetica Neue"/>
+                        </a:rPr>
+                        <a:t/>
+                      </a:r>
+                    </a:p>
+                  </a:txBody>
+                  <a:tcPr marL="73152" marT="36576" marB="36576">
+                    <a:solidFill>
+                      <a:srgbClr val="ECF1F5"/>
+                    </a:solidFill>
+                  </a:tcPr>
+                </a:tc>
+                <a:tc>
+                  <a:txBody>
+                    <a:bodyPr wrap="square"/>
+                    <a:lstStyle/>
+                    <a:p>
+                      <a:pPr algn="l">
+                        <a:lnSpc>
+                          <a:spcPct val="115000"/>
+                        </a:lnSpc>
+                        <a:spcBef>
+                          <a:spcPts val="0"/>
+                        </a:spcBef>
+                      </a:pPr>
+                      <a:r>
+                        <a:rPr sz="950" b="1" i="0">
+                          <a:solidFill>
+                            <a:srgbClr val="10233A"/>
+                          </a:solidFill>
+                          <a:latin typeface="Helvetica Neue"/>
+                        </a:rPr>
+                        <a:t>PPTAgent</a:t>
+                      </a:r>
+                    </a:p>
+                  </a:txBody>
+                  <a:tcPr marL="73152" marT="36576" marB="36576">
+                    <a:solidFill>
+                      <a:srgbClr val="ECF1F5"/>
+                    </a:solidFill>
+                  </a:tcPr>
+                </a:tc>
+                <a:tc>
+                  <a:txBody>
+                    <a:bodyPr wrap="square"/>
+                    <a:lstStyle/>
+                    <a:p>
+                      <a:pPr algn="l">
+                        <a:lnSpc>
+                          <a:spcPct val="115000"/>
+                        </a:lnSpc>
+                        <a:spcBef>
+                          <a:spcPts val="0"/>
+                        </a:spcBef>
+                      </a:pPr>
+                      <a:r>
+                        <a:rPr sz="950" b="1" i="0">
+                          <a:solidFill>
+                            <a:srgbClr val="10233A"/>
+                          </a:solidFill>
+                          <a:latin typeface="Helvetica Neue"/>
+                        </a:rPr>
+                        <a:t>DOC2PPT</a:t>
+                      </a:r>
+                    </a:p>
+                  </a:txBody>
+                  <a:tcPr marL="73152" marT="36576" marB="36576">
+                    <a:solidFill>
+                      <a:srgbClr val="ECF1F5"/>
+                    </a:solidFill>
+                  </a:tcPr>
+                </a:tc>
+              </a:tr>
+              <a:tr h="301752">
+                <a:tc>
+                  <a:txBody>
+                    <a:bodyPr wrap="square"/>
+                    <a:lstStyle/>
+                    <a:p>
+                      <a:pPr algn="l">
+                        <a:lnSpc>
+                          <a:spcPct val="110000"/>
+                        </a:lnSpc>
+                        <a:spcBef>
+                          <a:spcPts val="0"/>
+                        </a:spcBef>
+                      </a:pPr>
+                      <a:r>
+                        <a:rPr sz="1000" b="1" i="0">
+                          <a:solidFill>
+                            <a:srgbClr val="10233A"/>
+                          </a:solidFill>
+                          <a:latin typeface="Helvetica Neue"/>
+                        </a:rPr>
+                        <a:t>slides</a:t>
+                      </a:r>
+                    </a:p>
+                  </a:txBody>
+                  <a:tcPr marL="73152" marT="36576" marB="36576">
+                    <a:solidFill>
+                      <a:srgbClr val="FFFFFF"/>
+                    </a:solidFill>
+                  </a:tcPr>
+                </a:tc>
+                <a:tc>
+                  <a:txBody>
+                    <a:bodyPr wrap="square"/>
+                    <a:lstStyle/>
+                    <a:p>
+                      <a:pPr algn="l">
+                        <a:lnSpc>
+                          <a:spcPct val="110000"/>
+                        </a:lnSpc>
+                        <a:spcBef>
+                          <a:spcPts val="0"/>
+                        </a:spcBef>
+                      </a:pPr>
+                      <a:r>
+                        <a:rPr sz="1000" b="0" i="0">
+                          <a:solidFill>
+                            <a:srgbClr val="1E3652"/>
+                          </a:solidFill>
+                          <a:latin typeface="Helvetica Neue"/>
+                        </a:rPr>
+                        <a:t>9</a:t>
+                      </a:r>
+                    </a:p>
+                  </a:txBody>
+                  <a:tcPr marL="73152" marT="36576" marB="36576">
+                    <a:solidFill>
+                      <a:srgbClr val="FFFFFF"/>
+                    </a:solidFill>
+                  </a:tcPr>
+                </a:tc>
+                <a:tc>
+                  <a:txBody>
+                    <a:bodyPr wrap="square"/>
+                    <a:lstStyle/>
+                    <a:p>
+                      <a:pPr algn="l">
+                        <a:lnSpc>
+                          <a:spcPct val="110000"/>
+                        </a:lnSpc>
+                        <a:spcBef>
+                          <a:spcPts val="0"/>
+                        </a:spcBef>
+                      </a:pPr>
+                      <a:r>
+                        <a:rPr sz="1000" b="0" i="0">
+                          <a:solidFill>
+                            <a:srgbClr val="1E3652"/>
+                          </a:solidFill>
+                          <a:latin typeface="Helvetica Neue"/>
+                        </a:rPr>
+                        <a:t>9</a:t>
+                      </a:r>
+                    </a:p>
+                  </a:txBody>
+                  <a:tcPr marL="73152" marT="36576" marB="36576">
+                    <a:solidFill>
+                      <a:srgbClr val="FFFFFF"/>
+                    </a:solidFill>
+                  </a:tcPr>
+                </a:tc>
+              </a:tr>
+              <a:tr h="301752">
+                <a:tc>
+                  <a:txBody>
+                    <a:bodyPr wrap="square"/>
+                    <a:lstStyle/>
+                    <a:p>
+                      <a:pPr algn="l">
+                        <a:lnSpc>
+                          <a:spcPct val="110000"/>
+                        </a:lnSpc>
+                        <a:spcBef>
+                          <a:spcPts val="0"/>
+                        </a:spcBef>
+                      </a:pPr>
+                      <a:r>
+                        <a:rPr sz="1000" b="1" i="0">
+                          <a:solidFill>
+                            <a:srgbClr val="10233A"/>
+                          </a:solidFill>
+                          <a:latin typeface="Helvetica Neue"/>
+                        </a:rPr>
+                        <a:t>clean slides</a:t>
+                      </a:r>
+                    </a:p>
+                  </a:txBody>
+                  <a:tcPr marL="73152" marT="36576" marB="36576">
+                    <a:solidFill>
+                      <a:srgbClr val="FFFFFF"/>
+                    </a:solidFill>
+                  </a:tcPr>
+                </a:tc>
+                <a:tc>
+                  <a:txBody>
+                    <a:bodyPr wrap="square"/>
+                    <a:lstStyle/>
+                    <a:p>
+                      <a:pPr algn="l">
+                        <a:lnSpc>
+                          <a:spcPct val="110000"/>
+                        </a:lnSpc>
+                        <a:spcBef>
+                          <a:spcPts val="0"/>
+                        </a:spcBef>
+                      </a:pPr>
+                      <a:r>
+                        <a:rPr sz="1000" b="0" i="0">
+                          <a:solidFill>
+                            <a:srgbClr val="1E3652"/>
+                          </a:solidFill>
+                          <a:latin typeface="Helvetica Neue"/>
+                        </a:rPr>
+                        <a:t>0</a:t>
+                      </a:r>
+                    </a:p>
+                  </a:txBody>
+                  <a:tcPr marL="73152" marT="36576" marB="36576">
+                    <a:solidFill>
+                      <a:srgbClr val="FFFFFF"/>
+                    </a:solidFill>
+                  </a:tcPr>
+                </a:tc>
+                <a:tc>
+                  <a:txBody>
+                    <a:bodyPr wrap="square"/>
+                    <a:lstStyle/>
+                    <a:p>
+                      <a:pPr algn="l">
+                        <a:lnSpc>
+                          <a:spcPct val="110000"/>
+                        </a:lnSpc>
+                        <a:spcBef>
+                          <a:spcPts val="0"/>
+                        </a:spcBef>
+                      </a:pPr>
+                      <a:r>
+                        <a:rPr sz="1000" b="0" i="0">
+                          <a:solidFill>
+                            <a:srgbClr val="1E3652"/>
+                          </a:solidFill>
+                          <a:latin typeface="Helvetica Neue"/>
+                        </a:rPr>
+                        <a:t>0</a:t>
+                      </a:r>
+                    </a:p>
+                  </a:txBody>
+                  <a:tcPr marL="73152" marT="36576" marB="36576">
+                    <a:solidFill>
+                      <a:srgbClr val="FFFFFF"/>
+                    </a:solidFill>
+                  </a:tcPr>
+                </a:tc>
+              </a:tr>
+              <a:tr h="301752">
+                <a:tc>
+                  <a:txBody>
+                    <a:bodyPr wrap="square"/>
+                    <a:lstStyle/>
+                    <a:p>
+                      <a:pPr algn="l">
+                        <a:lnSpc>
+                          <a:spcPct val="110000"/>
+                        </a:lnSpc>
+                        <a:spcBef>
+                          <a:spcPts val="0"/>
+                        </a:spcBef>
+                      </a:pPr>
+                      <a:r>
+                        <a:rPr sz="1000" b="1" i="0">
+                          <a:solidFill>
+                            <a:srgbClr val="10233A"/>
+                          </a:solidFill>
+                          <a:latin typeface="Helvetica Neue"/>
+                        </a:rPr>
+                        <a:t>SRR (slide-level)</a:t>
+                      </a:r>
+                    </a:p>
+                  </a:txBody>
+                  <a:tcPr marL="73152" marT="36576" marB="36576">
+                    <a:solidFill>
+                      <a:srgbClr val="FFFFFF"/>
+                    </a:solidFill>
+                  </a:tcPr>
+                </a:tc>
+                <a:tc>
+                  <a:txBody>
+                    <a:bodyPr wrap="square"/>
+                    <a:lstStyle/>
+                    <a:p>
+                      <a:pPr algn="l">
+                        <a:lnSpc>
+                          <a:spcPct val="110000"/>
+                        </a:lnSpc>
+                        <a:spcBef>
+                          <a:spcPts val="0"/>
+                        </a:spcBef>
+                      </a:pPr>
+                      <a:r>
+                        <a:rPr sz="1000" b="0" i="0">
+                          <a:solidFill>
+                            <a:srgbClr val="1E3652"/>
+                          </a:solidFill>
+                          <a:latin typeface="Helvetica Neue"/>
+                        </a:rPr>
+                        <a:t>0.00</a:t>
+                      </a:r>
+                    </a:p>
+                  </a:txBody>
+                  <a:tcPr marL="73152" marT="36576" marB="36576">
+                    <a:solidFill>
+                      <a:srgbClr val="FFFFFF"/>
+                    </a:solidFill>
+                  </a:tcPr>
+                </a:tc>
+                <a:tc>
+                  <a:txBody>
+                    <a:bodyPr wrap="square"/>
+                    <a:lstStyle/>
+                    <a:p>
+                      <a:pPr algn="l">
+                        <a:lnSpc>
+                          <a:spcPct val="110000"/>
+                        </a:lnSpc>
+                        <a:spcBef>
+                          <a:spcPts val="0"/>
+                        </a:spcBef>
+                      </a:pPr>
+                      <a:r>
+                        <a:rPr sz="1000" b="0" i="0">
+                          <a:solidFill>
+                            <a:srgbClr val="1E3652"/>
+                          </a:solidFill>
+                          <a:latin typeface="Helvetica Neue"/>
+                        </a:rPr>
+                        <a:t>0.00</a:t>
+                      </a:r>
+                    </a:p>
+                  </a:txBody>
+                  <a:tcPr marL="73152" marT="36576" marB="36576">
+                    <a:solidFill>
+                      <a:srgbClr val="FFFFFF"/>
+                    </a:solidFill>
+                  </a:tcPr>
+                </a:tc>
+              </a:tr>
+              <a:tr h="301752">
+                <a:tc>
+                  <a:txBody>
+                    <a:bodyPr wrap="square"/>
+                    <a:lstStyle/>
+                    <a:p>
+                      <a:pPr algn="l">
+                        <a:lnSpc>
+                          <a:spcPct val="110000"/>
+                        </a:lnSpc>
+                        <a:spcBef>
+                          <a:spcPts val="0"/>
+                        </a:spcBef>
+                      </a:pPr>
+                      <a:r>
+                        <a:rPr sz="1000" b="1" i="0">
+                          <a:solidFill>
+                            <a:srgbClr val="10233A"/>
+                          </a:solidFill>
+                          <a:latin typeface="Helvetica Neue"/>
+                        </a:rPr>
+                        <a:t>violations</a:t>
+                      </a:r>
+                    </a:p>
+                  </a:txBody>
+                  <a:tcPr marL="73152" marT="36576" marB="36576">
+                    <a:solidFill>
+                      <a:srgbClr val="FFFFFF"/>
+                    </a:solidFill>
+                  </a:tcPr>
+                </a:tc>
+                <a:tc>
+                  <a:txBody>
+                    <a:bodyPr wrap="square"/>
+                    <a:lstStyle/>
+                    <a:p>
+                      <a:pPr algn="l">
+                        <a:lnSpc>
+                          <a:spcPct val="110000"/>
+                        </a:lnSpc>
+                        <a:spcBef>
+                          <a:spcPts val="0"/>
+                        </a:spcBef>
+                      </a:pPr>
+                      <a:r>
+                        <a:rPr sz="1000" b="0" i="0">
+                          <a:solidFill>
+                            <a:srgbClr val="1E3652"/>
+                          </a:solidFill>
+                          <a:latin typeface="Helvetica Neue"/>
+                        </a:rPr>
+                        <a:t>33</a:t>
+                      </a:r>
+                    </a:p>
+                  </a:txBody>
+                  <a:tcPr marL="73152" marT="36576" marB="36576">
+                    <a:solidFill>
+                      <a:srgbClr val="FFFFFF"/>
+                    </a:solidFill>
+                  </a:tcPr>
+                </a:tc>
+                <a:tc>
+                  <a:txBody>
+                    <a:bodyPr wrap="square"/>
+                    <a:lstStyle/>
+                    <a:p>
+                      <a:pPr algn="l">
+                        <a:lnSpc>
+                          <a:spcPct val="110000"/>
+                        </a:lnSpc>
+                        <a:spcBef>
+                          <a:spcPts val="0"/>
+                        </a:spcBef>
+                      </a:pPr>
+                      <a:r>
+                        <a:rPr sz="1000" b="0" i="0">
+                          <a:solidFill>
+                            <a:srgbClr val="1E3652"/>
+                          </a:solidFill>
+                          <a:latin typeface="Helvetica Neue"/>
+                        </a:rPr>
+                        <a:t>32</a:t>
+                      </a:r>
+                    </a:p>
+                  </a:txBody>
+                  <a:tcPr marL="73152" marT="36576" marB="36576">
+                    <a:solidFill>
+                      <a:srgbClr val="FFFFFF"/>
+                    </a:solidFill>
+                  </a:tcPr>
+                </a:tc>
+              </a:tr>
+              <a:tr h="301752">
+                <a:tc>
+                  <a:txBody>
+                    <a:bodyPr wrap="square"/>
+                    <a:lstStyle/>
+                    <a:p>
+                      <a:pPr algn="l">
+                        <a:lnSpc>
+                          <a:spcPct val="110000"/>
+                        </a:lnSpc>
+                        <a:spcBef>
+                          <a:spcPts val="0"/>
+                        </a:spcBef>
+                      </a:pPr>
+                      <a:r>
+                        <a:rPr sz="1000" b="1" i="0">
+                          <a:solidFill>
+                            <a:srgbClr val="10233A"/>
+                          </a:solidFill>
+                          <a:latin typeface="Helvetica Neue"/>
+                        </a:rPr>
+                        <a:t>slides failing G3</a:t>
+                      </a:r>
+                    </a:p>
+                  </a:txBody>
+                  <a:tcPr marL="73152" marT="36576" marB="36576">
+                    <a:solidFill>
+                      <a:srgbClr val="FFFFFF"/>
+                    </a:solidFill>
+                  </a:tcPr>
+                </a:tc>
+                <a:tc>
+                  <a:txBody>
+                    <a:bodyPr wrap="square"/>
+                    <a:lstStyle/>
+                    <a:p>
+                      <a:pPr algn="l">
+                        <a:lnSpc>
+                          <a:spcPct val="110000"/>
+                        </a:lnSpc>
+                        <a:spcBef>
+                          <a:spcPts val="0"/>
+                        </a:spcBef>
+                      </a:pPr>
+                      <a:r>
+                        <a:rPr sz="1000" b="0" i="0">
+                          <a:solidFill>
+                            <a:srgbClr val="1E3652"/>
+                          </a:solidFill>
+                          <a:latin typeface="Helvetica Neue"/>
+                        </a:rPr>
+                        <a:t>9 / 9</a:t>
+                      </a:r>
+                    </a:p>
+                  </a:txBody>
+                  <a:tcPr marL="73152" marT="36576" marB="36576">
+                    <a:solidFill>
+                      <a:srgbClr val="FFFFFF"/>
+                    </a:solidFill>
+                  </a:tcPr>
+                </a:tc>
+                <a:tc>
+                  <a:txBody>
+                    <a:bodyPr wrap="square"/>
+                    <a:lstStyle/>
+                    <a:p>
+                      <a:pPr algn="l">
+                        <a:lnSpc>
+                          <a:spcPct val="110000"/>
+                        </a:lnSpc>
+                        <a:spcBef>
+                          <a:spcPts val="0"/>
+                        </a:spcBef>
+                      </a:pPr>
+                      <a:r>
+                        <a:rPr sz="1000" b="0" i="0">
+                          <a:solidFill>
+                            <a:srgbClr val="1E3652"/>
+                          </a:solidFill>
+                          <a:latin typeface="Helvetica Neue"/>
+                        </a:rPr>
+                        <a:t>9 / 9</a:t>
+                      </a:r>
+                    </a:p>
+                  </a:txBody>
+                  <a:tcPr marL="73152" marT="36576" marB="36576">
+                    <a:solidFill>
+                      <a:srgbClr val="FFFFFF"/>
+                    </a:solidFill>
+                  </a:tcPr>
+                </a:tc>
+              </a:tr>
+              <a:tr h="301752">
+                <a:tc>
+                  <a:txBody>
+                    <a:bodyPr wrap="square"/>
+                    <a:lstStyle/>
+                    <a:p>
+                      <a:pPr algn="l">
+                        <a:lnSpc>
+                          <a:spcPct val="110000"/>
+                        </a:lnSpc>
+                        <a:spcBef>
+                          <a:spcPts val="0"/>
+                        </a:spcBef>
+                      </a:pPr>
+                      <a:r>
+                        <a:rPr sz="1000" b="1" i="0">
+                          <a:solidFill>
+                            <a:srgbClr val="10233A"/>
+                          </a:solidFill>
+                          <a:latin typeface="Helvetica Neue"/>
+                        </a:rPr>
+                        <a:t>slides failing G6</a:t>
+                      </a:r>
+                    </a:p>
+                  </a:txBody>
+                  <a:tcPr marL="73152" marT="36576" marB="36576">
+                    <a:solidFill>
+                      <a:srgbClr val="FFFFFF"/>
+                    </a:solidFill>
+                  </a:tcPr>
+                </a:tc>
+                <a:tc>
+                  <a:txBody>
+                    <a:bodyPr wrap="square"/>
+                    <a:lstStyle/>
+                    <a:p>
+                      <a:pPr algn="l">
+                        <a:lnSpc>
+                          <a:spcPct val="110000"/>
+                        </a:lnSpc>
+                        <a:spcBef>
+                          <a:spcPts val="0"/>
+                        </a:spcBef>
+                      </a:pPr>
+                      <a:r>
+                        <a:rPr sz="1000" b="0" i="0">
+                          <a:solidFill>
+                            <a:srgbClr val="1E3652"/>
+                          </a:solidFill>
+                          <a:latin typeface="Helvetica Neue"/>
+                        </a:rPr>
+                        <a:t>8 / 9</a:t>
+                      </a:r>
+                    </a:p>
+                  </a:txBody>
+                  <a:tcPr marL="73152" marT="36576" marB="36576">
+                    <a:solidFill>
+                      <a:srgbClr val="FFFFFF"/>
+                    </a:solidFill>
+                  </a:tcPr>
+                </a:tc>
+                <a:tc>
+                  <a:txBody>
+                    <a:bodyPr wrap="square"/>
+                    <a:lstStyle/>
+                    <a:p>
+                      <a:pPr algn="l">
+                        <a:lnSpc>
+                          <a:spcPct val="110000"/>
+                        </a:lnSpc>
+                        <a:spcBef>
+                          <a:spcPts val="0"/>
+                        </a:spcBef>
+                      </a:pPr>
+                      <a:r>
+                        <a:rPr sz="1000" b="0" i="0">
+                          <a:solidFill>
+                            <a:srgbClr val="1E3652"/>
+                          </a:solidFill>
+                          <a:latin typeface="Helvetica Neue"/>
+                        </a:rPr>
+                        <a:t>8 / 9</a:t>
+                      </a:r>
+                    </a:p>
+                  </a:txBody>
+                  <a:tcPr marL="73152" marT="36576" marB="36576">
+                    <a:solidFill>
+                      <a:srgbClr val="FFFFFF"/>
+                    </a:solidFill>
+                  </a:tcPr>
+                </a:tc>
+              </a:tr>
+            </a:tbl>
+          </a:graphicData>
+        </a:graphic>
+      </p:graphicFrame>
+      <p:sp>
+        <p:nvSpPr>
+          <p:cNvPr id="11" name="TextBox 10"/>
           <p:cNvSpPr txBox="1"/>
           <p:nvPr/>
         </p:nvSpPr>
         <p:spPr>
           <a:xfrm>
-            <a:off x="8823960" y="1737360"/>
-            <a:ext cx="2926080" cy="685800"/>
+            <a:off x="7452360" y="4224528"/>
+            <a:ext cx="4206240" cy="1463040"/>
           </a:xfrm>
           <a:prstGeom prst="rect">
             <a:avLst/>
@@ -3702,283 +4374,20 @@
           <a:p>
             <a:pPr algn="l">
               <a:lnSpc>
-                <a:spcPct val="115000"/>
+                <a:spcPct val="135000"/>
               </a:lnSpc>
               <a:spcBef>
                 <a:spcPts val="0"/>
               </a:spcBef>
             </a:pPr>
             <a:r>
-              <a:rPr sz="1000" b="1" i="0">
-                <a:solidFill>
-                  <a:srgbClr val="C08A2E"/>
+              <a:rPr sz="1000" b="0" i="0">
+                <a:solidFill>
+                  <a:srgbClr val="1E3652"/>
                 </a:solidFill>
                 <a:latin typeface="Helvetica Neue"/>
               </a:rPr>
-              <a:t>parse</a:t>
-            </a:r>
-          </a:p>
-          <a:p>
-            <a:pPr algn="l">
-              <a:lnSpc>
-                <a:spcPct val="125000"/>
-              </a:lnSpc>
-              <a:spcBef>
-                <a:spcPts val="100"/>
-              </a:spcBef>
-            </a:pPr>
-            <a:r>
-              <a:rPr sz="900" b="0" i="0">
-                <a:solidFill>
-                  <a:srgbClr val="1E3652"/>
-                </a:solidFill>
-                <a:latin typeface="Helvetica Neue"/>
-              </a:rPr>
-              <a:t>8 sections, 24 captions, 11 figures clipped</a:t>
-            </a:r>
-          </a:p>
-        </p:txBody>
-      </p:sp>
-      <p:sp>
-        <p:nvSpPr>
-          <p:cNvPr id="11" name="TextBox 10"/>
-          <p:cNvSpPr txBox="1"/>
-          <p:nvPr/>
-        </p:nvSpPr>
-        <p:spPr>
-          <a:xfrm>
-            <a:off x="8823960" y="2578608"/>
-            <a:ext cx="2926080" cy="685800"/>
-          </a:xfrm>
-          <a:prstGeom prst="rect">
-            <a:avLst/>
-          </a:prstGeom>
-          <a:noFill/>
-        </p:spPr>
-        <p:txBody>
-          <a:bodyPr wrap="square" anchor="t" lIns="0" rIns="0" tIns="0" bIns="0">
-            <a:spAutoFit/>
-          </a:bodyPr>
-          <a:lstStyle/>
-          <a:p>
-            <a:pPr algn="l">
-              <a:lnSpc>
-                <a:spcPct val="115000"/>
-              </a:lnSpc>
-              <a:spcBef>
-                <a:spcPts val="0"/>
-              </a:spcBef>
-            </a:pPr>
-            <a:r>
-              <a:rPr sz="1000" b="1" i="0">
-                <a:solidFill>
-                  <a:srgbClr val="C08A2E"/>
-                </a:solidFill>
-                <a:latin typeface="Helvetica Neue"/>
-              </a:rPr>
-              <a:t>compose</a:t>
-            </a:r>
-          </a:p>
-          <a:p>
-            <a:pPr algn="l">
-              <a:lnSpc>
-                <a:spcPct val="125000"/>
-              </a:lnSpc>
-              <a:spcBef>
-                <a:spcPts val="100"/>
-              </a:spcBef>
-            </a:pPr>
-            <a:r>
-              <a:rPr sz="900" b="0" i="0">
-                <a:solidFill>
-                  <a:srgbClr val="1E3652"/>
-                </a:solidFill>
-                <a:latin typeface="Helvetica Neue"/>
-              </a:rPr>
-              <a:t>8 slides, 90 seconds each</a:t>
-            </a:r>
-          </a:p>
-        </p:txBody>
-      </p:sp>
-      <p:sp>
-        <p:nvSpPr>
-          <p:cNvPr id="12" name="TextBox 11"/>
-          <p:cNvSpPr txBox="1"/>
-          <p:nvPr/>
-        </p:nvSpPr>
-        <p:spPr>
-          <a:xfrm>
-            <a:off x="8823960" y="3419856"/>
-            <a:ext cx="2926080" cy="685800"/>
-          </a:xfrm>
-          <a:prstGeom prst="rect">
-            <a:avLst/>
-          </a:prstGeom>
-          <a:noFill/>
-        </p:spPr>
-        <p:txBody>
-          <a:bodyPr wrap="square" anchor="t" lIns="0" rIns="0" tIns="0" bIns="0">
-            <a:spAutoFit/>
-          </a:bodyPr>
-          <a:lstStyle/>
-          <a:p>
-            <a:pPr algn="l">
-              <a:lnSpc>
-                <a:spcPct val="115000"/>
-              </a:lnSpc>
-              <a:spcBef>
-                <a:spcPts val="0"/>
-              </a:spcBef>
-            </a:pPr>
-            <a:r>
-              <a:rPr sz="1000" b="1" i="0">
-                <a:solidFill>
-                  <a:srgbClr val="C08A2E"/>
-                </a:solidFill>
-                <a:latin typeface="Helvetica Neue"/>
-              </a:rPr>
-              <a:t>render</a:t>
-            </a:r>
-          </a:p>
-          <a:p>
-            <a:pPr algn="l">
-              <a:lnSpc>
-                <a:spcPct val="125000"/>
-              </a:lnSpc>
-              <a:spcBef>
-                <a:spcPts val="100"/>
-              </a:spcBef>
-            </a:pPr>
-            <a:r>
-              <a:rPr sz="900" b="0" i="0">
-                <a:solidFill>
-                  <a:srgbClr val="1E3652"/>
-                </a:solidFill>
-                <a:latin typeface="Helvetica Neue"/>
-              </a:rPr>
-              <a:t>a 9-slide deck, native and editable</a:t>
-            </a:r>
-          </a:p>
-        </p:txBody>
-      </p:sp>
-      <p:sp>
-        <p:nvSpPr>
-          <p:cNvPr id="13" name="TextBox 12"/>
-          <p:cNvSpPr txBox="1"/>
-          <p:nvPr/>
-        </p:nvSpPr>
-        <p:spPr>
-          <a:xfrm>
-            <a:off x="8823960" y="4261104"/>
-            <a:ext cx="2926080" cy="685800"/>
-          </a:xfrm>
-          <a:prstGeom prst="rect">
-            <a:avLst/>
-          </a:prstGeom>
-          <a:noFill/>
-        </p:spPr>
-        <p:txBody>
-          <a:bodyPr wrap="square" anchor="t" lIns="0" rIns="0" tIns="0" bIns="0">
-            <a:spAutoFit/>
-          </a:bodyPr>
-          <a:lstStyle/>
-          <a:p>
-            <a:pPr algn="l">
-              <a:lnSpc>
-                <a:spcPct val="115000"/>
-              </a:lnSpc>
-              <a:spcBef>
-                <a:spcPts val="0"/>
-              </a:spcBef>
-            </a:pPr>
-            <a:r>
-              <a:rPr sz="1000" b="1" i="0">
-                <a:solidFill>
-                  <a:srgbClr val="C08A2E"/>
-                </a:solidFill>
-                <a:latin typeface="Helvetica Neue"/>
-              </a:rPr>
-              <a:t>detect</a:t>
-            </a:r>
-          </a:p>
-          <a:p>
-            <a:pPr algn="l">
-              <a:lnSpc>
-                <a:spcPct val="125000"/>
-              </a:lnSpc>
-              <a:spcBef>
-                <a:spcPts val="100"/>
-              </a:spcBef>
-            </a:pPr>
-            <a:r>
-              <a:rPr sz="900" b="0" i="0">
-                <a:solidFill>
-                  <a:srgbClr val="1E3652"/>
-                </a:solidFill>
-                <a:latin typeface="Helvetica Neue"/>
-              </a:rPr>
-              <a:t>32 violations, SRR 0.00</a:t>
-            </a:r>
-          </a:p>
-        </p:txBody>
-      </p:sp>
-      <p:sp>
-        <p:nvSpPr>
-          <p:cNvPr id="14" name="TextBox 13"/>
-          <p:cNvSpPr txBox="1"/>
-          <p:nvPr/>
-        </p:nvSpPr>
-        <p:spPr>
-          <a:xfrm>
-            <a:off x="8823960" y="5102352"/>
-            <a:ext cx="2926080" cy="685800"/>
-          </a:xfrm>
-          <a:prstGeom prst="rect">
-            <a:avLst/>
-          </a:prstGeom>
-          <a:noFill/>
-        </p:spPr>
-        <p:txBody>
-          <a:bodyPr wrap="square" anchor="t" lIns="0" rIns="0" tIns="0" bIns="0">
-            <a:spAutoFit/>
-          </a:bodyPr>
-          <a:lstStyle/>
-          <a:p>
-            <a:pPr algn="l">
-              <a:lnSpc>
-                <a:spcPct val="115000"/>
-              </a:lnSpc>
-              <a:spcBef>
-                <a:spcPts val="0"/>
-              </a:spcBef>
-            </a:pPr>
-            <a:r>
-              <a:rPr sz="1000" b="1" i="0">
-                <a:solidFill>
-                  <a:srgbClr val="C08A2E"/>
-                </a:solidFill>
-                <a:latin typeface="Helvetica Neue"/>
-              </a:rPr>
-              <a:t>pytest</a:t>
-            </a:r>
-          </a:p>
-          <a:p>
-            <a:pPr algn="l">
-              <a:lnSpc>
-                <a:spcPct val="125000"/>
-              </a:lnSpc>
-              <a:spcBef>
-                <a:spcPts val="100"/>
-              </a:spcBef>
-            </a:pPr>
-            <a:r>
-              <a:rPr sz="900" b="0" i="0">
-                <a:solidFill>
-                  <a:srgbClr val="1E3652"/>
-                </a:solidFill>
-                <a:latin typeface="Helvetica Neue"/>
-              </a:rPr>
-              <a:t>76 cases green</a:t>
+              <a:t>This is the expected result, not a defect: the baseline generator ignores every gate. What matters is that the number is reproducible and the violations are named.</a:t>
             </a:r>
           </a:p>
         </p:txBody>
@@ -4098,7 +4507,7 @@
                 </a:solidFill>
                 <a:latin typeface="Helvetica Neue"/>
               </a:rPr>
-              <a:t>STATUS</a:t>
+              <a:t>THE RUN</a:t>
             </a:r>
           </a:p>
         </p:txBody>
@@ -4140,7 +4549,7 @@
                 </a:solidFill>
                 <a:latin typeface="Helvetica Neue"/>
               </a:rPr>
-              <a:t>What is built, what is next</a:t>
+              <a:t>It runs end to end, and it fails honestly</a:t>
             </a:r>
           </a:p>
         </p:txBody>
@@ -4217,76 +4626,40 @@
           </a:p>
         </p:txBody>
       </p:sp>
-      <p:sp>
-        <p:nvSpPr>
-          <p:cNvPr id="8" name="Rectangle 7"/>
-          <p:cNvSpPr/>
-          <p:nvPr/>
-        </p:nvSpPr>
-        <p:spPr>
-          <a:xfrm>
-            <a:off x="868680" y="1691640"/>
-            <a:ext cx="3520440" cy="2926080"/>
-          </a:xfrm>
-          <a:prstGeom prst="rect">
-            <a:avLst/>
-          </a:prstGeom>
-          <a:solidFill>
-            <a:srgbClr val="F4F6F8"/>
-          </a:solidFill>
-          <a:ln>
-            <a:noFill/>
-          </a:ln>
-          <a:effectLst/>
-        </p:spPr>
-        <p:txBody>
-          <a:bodyPr rtlCol="0" anchor="ctr" wrap="square"/>
-          <a:lstStyle/>
-          <a:p>
-            <a:pPr algn="ctr"/>
-          </a:p>
-        </p:txBody>
-      </p:sp>
-      <p:sp>
-        <p:nvSpPr>
-          <p:cNvPr id="9" name="Rectangle 8"/>
-          <p:cNvSpPr/>
-          <p:nvPr/>
-        </p:nvSpPr>
-        <p:spPr>
-          <a:xfrm>
-            <a:off x="868680" y="1691640"/>
-            <a:ext cx="3520440" cy="50292"/>
-          </a:xfrm>
-          <a:prstGeom prst="rect">
-            <a:avLst/>
-          </a:prstGeom>
-          <a:solidFill>
-            <a:srgbClr val="2F7D5D"/>
-          </a:solidFill>
-          <a:ln>
-            <a:noFill/>
-          </a:ln>
-          <a:effectLst/>
-        </p:spPr>
-        <p:txBody>
-          <a:bodyPr rtlCol="0" anchor="ctr" wrap="square"/>
-          <a:lstStyle/>
-          <a:p>
-            <a:pPr algn="ctr"/>
-          </a:p>
-        </p:txBody>
-      </p:sp>
-      <p:sp>
-        <p:nvSpPr>
-          <p:cNvPr id="10" name="TextBox 9"/>
+      <p:pic>
+        <p:nvPicPr>
+          <p:cNvPr id="8" name="Picture 7" descr="console_run.png"/>
+          <p:cNvPicPr>
+            <a:picLocks noChangeAspect="1"/>
+          </p:cNvPicPr>
+          <p:nvPr/>
+        </p:nvPicPr>
+        <p:blipFill>
+          <a:blip r:embed="rId2"/>
+          <a:stretch>
+            <a:fillRect/>
+          </a:stretch>
+        </p:blipFill>
+        <p:spPr>
+          <a:xfrm>
+            <a:off x="868680" y="1645920"/>
+            <a:ext cx="7589520" cy="4827813"/>
+          </a:xfrm>
+          <a:prstGeom prst="rect">
+            <a:avLst/>
+          </a:prstGeom>
+        </p:spPr>
+      </p:pic>
+      <p:sp>
+        <p:nvSpPr>
+          <p:cNvPr id="9" name="TextBox 8"/>
           <p:cNvSpPr txBox="1"/>
           <p:nvPr/>
         </p:nvSpPr>
         <p:spPr>
           <a:xfrm>
-            <a:off x="1097280" y="1874519"/>
-            <a:ext cx="3108960" cy="320040"/>
+            <a:off x="868680" y="6455664"/>
+            <a:ext cx="7589520" cy="274320"/>
           </a:xfrm>
           <a:prstGeom prst="rect">
             <a:avLst/>
@@ -4308,205 +4681,27 @@
               </a:spcBef>
             </a:pPr>
             <a:r>
-              <a:rPr sz="1250" b="1" i="0">
-                <a:solidFill>
-                  <a:srgbClr val="10233A"/>
+              <a:rPr sz="800" b="0" i="1">
+                <a:solidFill>
+                  <a:srgbClr val="5A6B7C"/>
                 </a:solidFill>
                 <a:latin typeface="Helvetica Neue"/>
               </a:rPr>
-              <a:t>Built and tested</a:t>
-            </a:r>
-          </a:p>
-        </p:txBody>
-      </p:sp>
-      <p:sp>
-        <p:nvSpPr>
-          <p:cNvPr id="11" name="TextBox 10"/>
+              <a:t>Real terminal output; rows in the middle are elided.</a:t>
+            </a:r>
+          </a:p>
+        </p:txBody>
+      </p:sp>
+      <p:sp>
+        <p:nvSpPr>
+          <p:cNvPr id="10" name="TextBox 9"/>
           <p:cNvSpPr txBox="1"/>
           <p:nvPr/>
         </p:nvSpPr>
         <p:spPr>
           <a:xfrm>
-            <a:off x="1097280" y="2331720"/>
-            <a:ext cx="3154680" cy="2834640"/>
-          </a:xfrm>
-          <a:prstGeom prst="rect">
-            <a:avLst/>
-          </a:prstGeom>
-          <a:noFill/>
-        </p:spPr>
-        <p:txBody>
-          <a:bodyPr wrap="square" anchor="t" lIns="0" rIns="0" tIns="0" bIns="0">
-            <a:spAutoFit/>
-          </a:bodyPr>
-          <a:lstStyle/>
-          <a:p>
-            <a:pPr algn="l">
-              <a:lnSpc>
-                <a:spcPct val="125000"/>
-              </a:lnSpc>
-              <a:spcBef>
-                <a:spcPts val="0"/>
-              </a:spcBef>
-            </a:pPr>
-            <a:r>
-              <a:rPr sz="950" b="0" i="0">
-                <a:solidFill>
-                  <a:srgbClr val="1E3652"/>
-                </a:solidFill>
-                <a:latin typeface="Helvetica Neue"/>
-              </a:rPr>
-              <a:t>-  parse: sections, figures, captions</a:t>
-            </a:r>
-          </a:p>
-          <a:p>
-            <a:pPr algn="l">
-              <a:lnSpc>
-                <a:spcPct val="125000"/>
-              </a:lnSpc>
-              <a:spcBef>
-                <a:spcPts val="700"/>
-              </a:spcBef>
-            </a:pPr>
-            <a:r>
-              <a:rPr sz="950" b="0" i="0">
-                <a:solidFill>
-                  <a:srgbClr val="1E3652"/>
-                </a:solidFill>
-                <a:latin typeface="Helvetica Neue"/>
-              </a:rPr>
-              <a:t>-  figure clipping, 12/32 on the sample</a:t>
-            </a:r>
-          </a:p>
-          <a:p>
-            <a:pPr algn="l">
-              <a:lnSpc>
-                <a:spcPct val="125000"/>
-              </a:lnSpc>
-              <a:spcBef>
-                <a:spcPts val="700"/>
-              </a:spcBef>
-            </a:pPr>
-            <a:r>
-              <a:rPr sz="950" b="0" i="0">
-                <a:solidFill>
-                  <a:srgbClr val="1E3652"/>
-                </a:solidFill>
-                <a:latin typeface="Helvetica Neue"/>
-              </a:rPr>
-              <a:t>-  render: native .pptx with speaker notes</a:t>
-            </a:r>
-          </a:p>
-          <a:p>
-            <a:pPr algn="l">
-              <a:lnSpc>
-                <a:spcPct val="125000"/>
-              </a:lnSpc>
-              <a:spcBef>
-                <a:spcPts val="700"/>
-              </a:spcBef>
-            </a:pPr>
-            <a:r>
-              <a:rPr sz="950" b="0" i="0">
-                <a:solidFill>
-                  <a:srgbClr val="1E3652"/>
-                </a:solidFill>
-                <a:latin typeface="Helvetica Neue"/>
-              </a:rPr>
-              <a:t>-  G1, G2, G3, G6 + SRR</a:t>
-            </a:r>
-          </a:p>
-          <a:p>
-            <a:pPr algn="l">
-              <a:lnSpc>
-                <a:spcPct val="125000"/>
-              </a:lnSpc>
-              <a:spcBef>
-                <a:spcPts val="700"/>
-              </a:spcBef>
-            </a:pPr>
-            <a:r>
-              <a:rPr sz="950" b="0" i="0">
-                <a:solidFill>
-                  <a:srgbClr val="1E3652"/>
-                </a:solidFill>
-                <a:latin typeface="Helvetica Neue"/>
-              </a:rPr>
-              <a:t>-  selection rule table, 55 test functions</a:t>
-            </a:r>
-          </a:p>
-        </p:txBody>
-      </p:sp>
-      <p:sp>
-        <p:nvSpPr>
-          <p:cNvPr id="12" name="Rectangle 11"/>
-          <p:cNvSpPr/>
-          <p:nvPr/>
-        </p:nvSpPr>
-        <p:spPr>
-          <a:xfrm>
-            <a:off x="4553712" y="1691640"/>
-            <a:ext cx="3520440" cy="2926080"/>
-          </a:xfrm>
-          <a:prstGeom prst="rect">
-            <a:avLst/>
-          </a:prstGeom>
-          <a:solidFill>
-            <a:srgbClr val="F4F6F8"/>
-          </a:solidFill>
-          <a:ln>
-            <a:noFill/>
-          </a:ln>
-          <a:effectLst/>
-        </p:spPr>
-        <p:txBody>
-          <a:bodyPr rtlCol="0" anchor="ctr" wrap="square"/>
-          <a:lstStyle/>
-          <a:p>
-            <a:pPr algn="ctr"/>
-          </a:p>
-        </p:txBody>
-      </p:sp>
-      <p:sp>
-        <p:nvSpPr>
-          <p:cNvPr id="13" name="Rectangle 12"/>
-          <p:cNvSpPr/>
-          <p:nvPr/>
-        </p:nvSpPr>
-        <p:spPr>
-          <a:xfrm>
-            <a:off x="4553712" y="1691640"/>
-            <a:ext cx="3520440" cy="50292"/>
-          </a:xfrm>
-          <a:prstGeom prst="rect">
-            <a:avLst/>
-          </a:prstGeom>
-          <a:solidFill>
-            <a:srgbClr val="B07A1E"/>
-          </a:solidFill>
-          <a:ln>
-            <a:noFill/>
-          </a:ln>
-          <a:effectLst/>
-        </p:spPr>
-        <p:txBody>
-          <a:bodyPr rtlCol="0" anchor="ctr" wrap="square"/>
-          <a:lstStyle/>
-          <a:p>
-            <a:pPr algn="ctr"/>
-          </a:p>
-        </p:txBody>
-      </p:sp>
-      <p:sp>
-        <p:nvSpPr>
-          <p:cNvPr id="14" name="TextBox 13"/>
-          <p:cNvSpPr txBox="1"/>
-          <p:nvPr/>
-        </p:nvSpPr>
-        <p:spPr>
-          <a:xfrm>
-            <a:off x="4782312" y="1874519"/>
-            <a:ext cx="3108960" cy="320040"/>
+            <a:off x="8823960" y="1737360"/>
+            <a:ext cx="2926080" cy="685800"/>
           </a:xfrm>
           <a:prstGeom prst="rect">
             <a:avLst/>
@@ -4528,167 +4723,46 @@
               </a:spcBef>
             </a:pPr>
             <a:r>
-              <a:rPr sz="1250" b="1" i="0">
-                <a:solidFill>
-                  <a:srgbClr val="10233A"/>
+              <a:rPr sz="1000" b="1" i="0">
+                <a:solidFill>
+                  <a:srgbClr val="C08A2E"/>
                 </a:solidFill>
                 <a:latin typeface="Helvetica Neue"/>
               </a:rPr>
-              <a:t>Partially built</a:t>
-            </a:r>
-          </a:p>
-        </p:txBody>
-      </p:sp>
-      <p:sp>
-        <p:nvSpPr>
-          <p:cNvPr id="15" name="TextBox 14"/>
-          <p:cNvSpPr txBox="1"/>
-          <p:nvPr/>
-        </p:nvSpPr>
-        <p:spPr>
-          <a:xfrm>
-            <a:off x="4782312" y="2331720"/>
-            <a:ext cx="3154680" cy="2834640"/>
-          </a:xfrm>
-          <a:prstGeom prst="rect">
-            <a:avLst/>
-          </a:prstGeom>
-          <a:noFill/>
-        </p:spPr>
-        <p:txBody>
-          <a:bodyPr wrap="square" anchor="t" lIns="0" rIns="0" tIns="0" bIns="0">
-            <a:spAutoFit/>
-          </a:bodyPr>
-          <a:lstStyle/>
+              <a:t>parse</a:t>
+            </a:r>
+          </a:p>
           <a:p>
             <a:pPr algn="l">
               <a:lnSpc>
                 <a:spcPct val="125000"/>
               </a:lnSpc>
               <a:spcBef>
-                <a:spcPts val="0"/>
+                <a:spcPts val="100"/>
               </a:spcBef>
             </a:pPr>
             <a:r>
-              <a:rPr sz="950" b="0" i="0">
+              <a:rPr sz="900" b="0" i="0">
                 <a:solidFill>
                   <a:srgbClr val="1E3652"/>
                 </a:solidFill>
                 <a:latin typeface="Helvetica Neue"/>
               </a:rPr>
-              <a:t>-  G3 / G6 still use one global threshold</a:t>
-            </a:r>
-          </a:p>
-          <a:p>
-            <a:pPr algn="l">
-              <a:lnSpc>
-                <a:spcPct val="125000"/>
-              </a:lnSpc>
-              <a:spcBef>
-                <a:spcPts val="700"/>
-              </a:spcBef>
-            </a:pPr>
-            <a:r>
-              <a:rPr sz="950" b="0" i="0">
-                <a:solidFill>
-                  <a:srgbClr val="1E3652"/>
-                </a:solidFill>
-                <a:latin typeface="Helvetica Neue"/>
-              </a:rPr>
-              <a:t>-  figure captions need a word-boundary trim</a:t>
-            </a:r>
-          </a:p>
-          <a:p>
-            <a:pPr algn="l">
-              <a:lnSpc>
-                <a:spcPct val="125000"/>
-              </a:lnSpc>
-              <a:spcBef>
-                <a:spcPts val="700"/>
-              </a:spcBef>
-            </a:pPr>
-            <a:r>
-              <a:rPr sz="950" b="0" i="0">
-                <a:solidFill>
-                  <a:srgbClr val="1E3652"/>
-                </a:solidFill>
-                <a:latin typeface="Helvetica Neue"/>
-              </a:rPr>
-              <a:t>-  claims are still extracted by heuristic</a:t>
-            </a:r>
-          </a:p>
-        </p:txBody>
-      </p:sp>
-      <p:sp>
-        <p:nvSpPr>
-          <p:cNvPr id="16" name="Rectangle 15"/>
-          <p:cNvSpPr/>
-          <p:nvPr/>
-        </p:nvSpPr>
-        <p:spPr>
-          <a:xfrm>
-            <a:off x="8238744" y="1691640"/>
-            <a:ext cx="3520440" cy="2926080"/>
-          </a:xfrm>
-          <a:prstGeom prst="rect">
-            <a:avLst/>
-          </a:prstGeom>
-          <a:solidFill>
-            <a:srgbClr val="F4F6F8"/>
-          </a:solidFill>
-          <a:ln>
-            <a:noFill/>
-          </a:ln>
-          <a:effectLst/>
-        </p:spPr>
-        <p:txBody>
-          <a:bodyPr rtlCol="0" anchor="ctr" wrap="square"/>
-          <a:lstStyle/>
-          <a:p>
-            <a:pPr algn="ctr"/>
-          </a:p>
-        </p:txBody>
-      </p:sp>
-      <p:sp>
-        <p:nvSpPr>
-          <p:cNvPr id="17" name="Rectangle 16"/>
-          <p:cNvSpPr/>
-          <p:nvPr/>
-        </p:nvSpPr>
-        <p:spPr>
-          <a:xfrm>
-            <a:off x="8238744" y="1691640"/>
-            <a:ext cx="3520440" cy="50292"/>
-          </a:xfrm>
-          <a:prstGeom prst="rect">
-            <a:avLst/>
-          </a:prstGeom>
-          <a:solidFill>
-            <a:srgbClr val="5A6B7C"/>
-          </a:solidFill>
-          <a:ln>
-            <a:noFill/>
-          </a:ln>
-          <a:effectLst/>
-        </p:spPr>
-        <p:txBody>
-          <a:bodyPr rtlCol="0" anchor="ctr" wrap="square"/>
-          <a:lstStyle/>
-          <a:p>
-            <a:pPr algn="ctr"/>
-          </a:p>
-        </p:txBody>
-      </p:sp>
-      <p:sp>
-        <p:nvSpPr>
-          <p:cNvPr id="18" name="TextBox 17"/>
+              <a:t>8 sections, 24 captions, 11 figures clipped</a:t>
+            </a:r>
+          </a:p>
+        </p:txBody>
+      </p:sp>
+      <p:sp>
+        <p:nvSpPr>
+          <p:cNvPr id="11" name="TextBox 10"/>
           <p:cNvSpPr txBox="1"/>
           <p:nvPr/>
         </p:nvSpPr>
         <p:spPr>
           <a:xfrm>
-            <a:off x="8467344" y="1874519"/>
-            <a:ext cx="3108960" cy="320040"/>
+            <a:off x="8823960" y="2578608"/>
+            <a:ext cx="2926080" cy="685800"/>
           </a:xfrm>
           <a:prstGeom prst="rect">
             <a:avLst/>
@@ -4710,126 +4784,46 @@
               </a:spcBef>
             </a:pPr>
             <a:r>
-              <a:rPr sz="1250" b="1" i="0">
-                <a:solidFill>
-                  <a:srgbClr val="10233A"/>
+              <a:rPr sz="1000" b="1" i="0">
+                <a:solidFill>
+                  <a:srgbClr val="C08A2E"/>
                 </a:solidFill>
                 <a:latin typeface="Helvetica Neue"/>
               </a:rPr>
-              <a:t>Not started</a:t>
-            </a:r>
-          </a:p>
-        </p:txBody>
-      </p:sp>
-      <p:sp>
-        <p:nvSpPr>
-          <p:cNvPr id="19" name="TextBox 18"/>
-          <p:cNvSpPr txBox="1"/>
-          <p:nvPr/>
-        </p:nvSpPr>
-        <p:spPr>
-          <a:xfrm>
-            <a:off x="8467344" y="2331720"/>
-            <a:ext cx="3154680" cy="2834640"/>
-          </a:xfrm>
-          <a:prstGeom prst="rect">
-            <a:avLst/>
-          </a:prstGeom>
-          <a:noFill/>
-        </p:spPr>
-        <p:txBody>
-          <a:bodyPr wrap="square" anchor="t" lIns="0" rIns="0" tIns="0" bIns="0">
-            <a:spAutoFit/>
-          </a:bodyPr>
-          <a:lstStyle/>
+              <a:t>compose</a:t>
+            </a:r>
+          </a:p>
           <a:p>
             <a:pPr algn="l">
               <a:lnSpc>
                 <a:spcPct val="125000"/>
               </a:lnSpc>
               <a:spcBef>
-                <a:spcPts val="0"/>
+                <a:spcPts val="100"/>
               </a:spcBef>
             </a:pPr>
             <a:r>
-              <a:rPr sz="950" b="0" i="0">
+              <a:rPr sz="900" b="0" i="0">
                 <a:solidFill>
                   <a:srgbClr val="1E3652"/>
                 </a:solidFill>
                 <a:latin typeface="Helvetica Neue"/>
               </a:rPr>
-              <a:t>-  G4 contrast, G5 text fit</a:t>
-            </a:r>
-          </a:p>
-          <a:p>
-            <a:pPr algn="l">
-              <a:lnSpc>
-                <a:spcPct val="125000"/>
-              </a:lnSpc>
-              <a:spcBef>
-                <a:spcPts val="700"/>
-              </a:spcBef>
-            </a:pPr>
-            <a:r>
-              <a:rPr sz="950" b="0" i="0">
-                <a:solidFill>
-                  <a:srgbClr val="1E3652"/>
-                </a:solidFill>
-                <a:latin typeface="Helvetica Neue"/>
-              </a:rPr>
-              <a:t>-  repair actions and the loop</a:t>
-            </a:r>
-          </a:p>
-          <a:p>
-            <a:pPr algn="l">
-              <a:lnSpc>
-                <a:spcPct val="125000"/>
-              </a:lnSpc>
-              <a:spcBef>
-                <a:spcPts val="700"/>
-              </a:spcBef>
-            </a:pPr>
-            <a:r>
-              <a:rPr sz="950" b="0" i="0">
-                <a:solidFill>
-                  <a:srgbClr val="1E3652"/>
-                </a:solidFill>
-                <a:latin typeface="Helvetica Neue"/>
-              </a:rPr>
-              <a:t>-  110-slide test set and its labels</a:t>
-            </a:r>
-          </a:p>
-          <a:p>
-            <a:pPr algn="l">
-              <a:lnSpc>
-                <a:spcPct val="125000"/>
-              </a:lnSpc>
-              <a:spcBef>
-                <a:spcPts val="700"/>
-              </a:spcBef>
-            </a:pPr>
-            <a:r>
-              <a:rPr sz="950" b="0" i="0">
-                <a:solidFill>
-                  <a:srgbClr val="1E3652"/>
-                </a:solidFill>
-                <a:latin typeface="Helvetica Neue"/>
-              </a:rPr>
-              <a:t>-  human decks, baselines, the 2x2 experiment</a:t>
-            </a:r>
-          </a:p>
-        </p:txBody>
-      </p:sp>
-      <p:sp>
-        <p:nvSpPr>
-          <p:cNvPr id="20" name="TextBox 19"/>
+              <a:t>8 slides, 90 seconds each</a:t>
+            </a:r>
+          </a:p>
+        </p:txBody>
+      </p:sp>
+      <p:sp>
+        <p:nvSpPr>
+          <p:cNvPr id="12" name="TextBox 11"/>
           <p:cNvSpPr txBox="1"/>
           <p:nvPr/>
         </p:nvSpPr>
         <p:spPr>
           <a:xfrm>
-            <a:off x="868680" y="4937760"/>
-            <a:ext cx="10881360" cy="548640"/>
+            <a:off x="8823960" y="3419856"/>
+            <a:ext cx="2926080" cy="685800"/>
           </a:xfrm>
           <a:prstGeom prst="rect">
             <a:avLst/>
@@ -4851,13 +4845,154 @@
               </a:spcBef>
             </a:pPr>
             <a:r>
-              <a:rPr sz="1050" b="0" i="1">
-                <a:solidFill>
-                  <a:srgbClr val="5A6B7C"/>
+              <a:rPr sz="1000" b="1" i="0">
+                <a:solidFill>
+                  <a:srgbClr val="C08A2E"/>
                 </a:solidFill>
                 <a:latin typeface="Helvetica Neue"/>
               </a:rPr>
-              <a:t>76 test cases pass. The deck above was produced by this pipeline end to end.</a:t>
+              <a:t>render</a:t>
+            </a:r>
+          </a:p>
+          <a:p>
+            <a:pPr algn="l">
+              <a:lnSpc>
+                <a:spcPct val="125000"/>
+              </a:lnSpc>
+              <a:spcBef>
+                <a:spcPts val="100"/>
+              </a:spcBef>
+            </a:pPr>
+            <a:r>
+              <a:rPr sz="900" b="0" i="0">
+                <a:solidFill>
+                  <a:srgbClr val="1E3652"/>
+                </a:solidFill>
+                <a:latin typeface="Helvetica Neue"/>
+              </a:rPr>
+              <a:t>a 9-slide deck, native and editable</a:t>
+            </a:r>
+          </a:p>
+        </p:txBody>
+      </p:sp>
+      <p:sp>
+        <p:nvSpPr>
+          <p:cNvPr id="13" name="TextBox 12"/>
+          <p:cNvSpPr txBox="1"/>
+          <p:nvPr/>
+        </p:nvSpPr>
+        <p:spPr>
+          <a:xfrm>
+            <a:off x="8823960" y="4261104"/>
+            <a:ext cx="2926080" cy="685800"/>
+          </a:xfrm>
+          <a:prstGeom prst="rect">
+            <a:avLst/>
+          </a:prstGeom>
+          <a:noFill/>
+        </p:spPr>
+        <p:txBody>
+          <a:bodyPr wrap="square" anchor="t" lIns="0" rIns="0" tIns="0" bIns="0">
+            <a:spAutoFit/>
+          </a:bodyPr>
+          <a:lstStyle/>
+          <a:p>
+            <a:pPr algn="l">
+              <a:lnSpc>
+                <a:spcPct val="115000"/>
+              </a:lnSpc>
+              <a:spcBef>
+                <a:spcPts val="0"/>
+              </a:spcBef>
+            </a:pPr>
+            <a:r>
+              <a:rPr sz="1000" b="1" i="0">
+                <a:solidFill>
+                  <a:srgbClr val="C08A2E"/>
+                </a:solidFill>
+                <a:latin typeface="Helvetica Neue"/>
+              </a:rPr>
+              <a:t>detect</a:t>
+            </a:r>
+          </a:p>
+          <a:p>
+            <a:pPr algn="l">
+              <a:lnSpc>
+                <a:spcPct val="125000"/>
+              </a:lnSpc>
+              <a:spcBef>
+                <a:spcPts val="100"/>
+              </a:spcBef>
+            </a:pPr>
+            <a:r>
+              <a:rPr sz="900" b="0" i="0">
+                <a:solidFill>
+                  <a:srgbClr val="1E3652"/>
+                </a:solidFill>
+                <a:latin typeface="Helvetica Neue"/>
+              </a:rPr>
+              <a:t>32 violations, SRR 0.00</a:t>
+            </a:r>
+          </a:p>
+        </p:txBody>
+      </p:sp>
+      <p:sp>
+        <p:nvSpPr>
+          <p:cNvPr id="14" name="TextBox 13"/>
+          <p:cNvSpPr txBox="1"/>
+          <p:nvPr/>
+        </p:nvSpPr>
+        <p:spPr>
+          <a:xfrm>
+            <a:off x="8823960" y="5102352"/>
+            <a:ext cx="2926080" cy="685800"/>
+          </a:xfrm>
+          <a:prstGeom prst="rect">
+            <a:avLst/>
+          </a:prstGeom>
+          <a:noFill/>
+        </p:spPr>
+        <p:txBody>
+          <a:bodyPr wrap="square" anchor="t" lIns="0" rIns="0" tIns="0" bIns="0">
+            <a:spAutoFit/>
+          </a:bodyPr>
+          <a:lstStyle/>
+          <a:p>
+            <a:pPr algn="l">
+              <a:lnSpc>
+                <a:spcPct val="115000"/>
+              </a:lnSpc>
+              <a:spcBef>
+                <a:spcPts val="0"/>
+              </a:spcBef>
+            </a:pPr>
+            <a:r>
+              <a:rPr sz="1000" b="1" i="0">
+                <a:solidFill>
+                  <a:srgbClr val="C08A2E"/>
+                </a:solidFill>
+                <a:latin typeface="Helvetica Neue"/>
+              </a:rPr>
+              <a:t>pytest</a:t>
+            </a:r>
+          </a:p>
+          <a:p>
+            <a:pPr algn="l">
+              <a:lnSpc>
+                <a:spcPct val="125000"/>
+              </a:lnSpc>
+              <a:spcBef>
+                <a:spcPts val="100"/>
+              </a:spcBef>
+            </a:pPr>
+            <a:r>
+              <a:rPr sz="900" b="0" i="0">
+                <a:solidFill>
+                  <a:srgbClr val="1E3652"/>
+                </a:solidFill>
+                <a:latin typeface="Helvetica Neue"/>
+              </a:rPr>
+              <a:t>76 cases green</a:t>
             </a:r>
           </a:p>
         </p:txBody>
@@ -4977,7 +5112,7 @@
                 </a:solidFill>
                 <a:latin typeface="Helvetica Neue"/>
               </a:rPr>
-              <a:t>PLAN</a:t>
+              <a:t>STATUS</a:t>
             </a:r>
           </a:p>
         </p:txBody>
@@ -5019,7 +5154,7 @@
                 </a:solidFill>
                 <a:latin typeface="Helvetica Neue"/>
               </a:rPr>
-              <a:t>The experiment, and the calendar</a:t>
+              <a:t>What is built, what is next</a:t>
             </a:r>
           </a:p>
         </p:txBody>
@@ -5092,6 +5227,885 @@
                 <a:latin typeface="Helvetica Neue"/>
               </a:rPr>
               <a:t>12</a:t>
+            </a:r>
+          </a:p>
+        </p:txBody>
+      </p:sp>
+      <p:sp>
+        <p:nvSpPr>
+          <p:cNvPr id="8" name="Rectangle 7"/>
+          <p:cNvSpPr/>
+          <p:nvPr/>
+        </p:nvSpPr>
+        <p:spPr>
+          <a:xfrm>
+            <a:off x="868680" y="1691640"/>
+            <a:ext cx="3520440" cy="2926080"/>
+          </a:xfrm>
+          <a:prstGeom prst="rect">
+            <a:avLst/>
+          </a:prstGeom>
+          <a:solidFill>
+            <a:srgbClr val="F4F6F8"/>
+          </a:solidFill>
+          <a:ln>
+            <a:noFill/>
+          </a:ln>
+          <a:effectLst/>
+        </p:spPr>
+        <p:txBody>
+          <a:bodyPr rtlCol="0" anchor="ctr" wrap="square"/>
+          <a:lstStyle/>
+          <a:p>
+            <a:pPr algn="ctr"/>
+          </a:p>
+        </p:txBody>
+      </p:sp>
+      <p:sp>
+        <p:nvSpPr>
+          <p:cNvPr id="9" name="Rectangle 8"/>
+          <p:cNvSpPr/>
+          <p:nvPr/>
+        </p:nvSpPr>
+        <p:spPr>
+          <a:xfrm>
+            <a:off x="868680" y="1691640"/>
+            <a:ext cx="3520440" cy="50292"/>
+          </a:xfrm>
+          <a:prstGeom prst="rect">
+            <a:avLst/>
+          </a:prstGeom>
+          <a:solidFill>
+            <a:srgbClr val="2F7D5D"/>
+          </a:solidFill>
+          <a:ln>
+            <a:noFill/>
+          </a:ln>
+          <a:effectLst/>
+        </p:spPr>
+        <p:txBody>
+          <a:bodyPr rtlCol="0" anchor="ctr" wrap="square"/>
+          <a:lstStyle/>
+          <a:p>
+            <a:pPr algn="ctr"/>
+          </a:p>
+        </p:txBody>
+      </p:sp>
+      <p:sp>
+        <p:nvSpPr>
+          <p:cNvPr id="10" name="TextBox 9"/>
+          <p:cNvSpPr txBox="1"/>
+          <p:nvPr/>
+        </p:nvSpPr>
+        <p:spPr>
+          <a:xfrm>
+            <a:off x="1097280" y="1874519"/>
+            <a:ext cx="3108960" cy="320040"/>
+          </a:xfrm>
+          <a:prstGeom prst="rect">
+            <a:avLst/>
+          </a:prstGeom>
+          <a:noFill/>
+        </p:spPr>
+        <p:txBody>
+          <a:bodyPr wrap="square" anchor="t" lIns="0" rIns="0" tIns="0" bIns="0">
+            <a:spAutoFit/>
+          </a:bodyPr>
+          <a:lstStyle/>
+          <a:p>
+            <a:pPr algn="l">
+              <a:lnSpc>
+                <a:spcPct val="115000"/>
+              </a:lnSpc>
+              <a:spcBef>
+                <a:spcPts val="0"/>
+              </a:spcBef>
+            </a:pPr>
+            <a:r>
+              <a:rPr sz="1250" b="1" i="0">
+                <a:solidFill>
+                  <a:srgbClr val="10233A"/>
+                </a:solidFill>
+                <a:latin typeface="Helvetica Neue"/>
+              </a:rPr>
+              <a:t>Built and tested</a:t>
+            </a:r>
+          </a:p>
+        </p:txBody>
+      </p:sp>
+      <p:sp>
+        <p:nvSpPr>
+          <p:cNvPr id="11" name="TextBox 10"/>
+          <p:cNvSpPr txBox="1"/>
+          <p:nvPr/>
+        </p:nvSpPr>
+        <p:spPr>
+          <a:xfrm>
+            <a:off x="1097280" y="2331720"/>
+            <a:ext cx="3154680" cy="2834640"/>
+          </a:xfrm>
+          <a:prstGeom prst="rect">
+            <a:avLst/>
+          </a:prstGeom>
+          <a:noFill/>
+        </p:spPr>
+        <p:txBody>
+          <a:bodyPr wrap="square" anchor="t" lIns="0" rIns="0" tIns="0" bIns="0">
+            <a:spAutoFit/>
+          </a:bodyPr>
+          <a:lstStyle/>
+          <a:p>
+            <a:pPr algn="l">
+              <a:lnSpc>
+                <a:spcPct val="125000"/>
+              </a:lnSpc>
+              <a:spcBef>
+                <a:spcPts val="0"/>
+              </a:spcBef>
+            </a:pPr>
+            <a:r>
+              <a:rPr sz="950" b="0" i="0">
+                <a:solidFill>
+                  <a:srgbClr val="1E3652"/>
+                </a:solidFill>
+                <a:latin typeface="Helvetica Neue"/>
+              </a:rPr>
+              <a:t>-  parse: sections, figures, captions</a:t>
+            </a:r>
+          </a:p>
+          <a:p>
+            <a:pPr algn="l">
+              <a:lnSpc>
+                <a:spcPct val="125000"/>
+              </a:lnSpc>
+              <a:spcBef>
+                <a:spcPts val="700"/>
+              </a:spcBef>
+            </a:pPr>
+            <a:r>
+              <a:rPr sz="950" b="0" i="0">
+                <a:solidFill>
+                  <a:srgbClr val="1E3652"/>
+                </a:solidFill>
+                <a:latin typeface="Helvetica Neue"/>
+              </a:rPr>
+              <a:t>-  figure clipping, 12/32 on the sample</a:t>
+            </a:r>
+          </a:p>
+          <a:p>
+            <a:pPr algn="l">
+              <a:lnSpc>
+                <a:spcPct val="125000"/>
+              </a:lnSpc>
+              <a:spcBef>
+                <a:spcPts val="700"/>
+              </a:spcBef>
+            </a:pPr>
+            <a:r>
+              <a:rPr sz="950" b="0" i="0">
+                <a:solidFill>
+                  <a:srgbClr val="1E3652"/>
+                </a:solidFill>
+                <a:latin typeface="Helvetica Neue"/>
+              </a:rPr>
+              <a:t>-  render: native .pptx with speaker notes</a:t>
+            </a:r>
+          </a:p>
+          <a:p>
+            <a:pPr algn="l">
+              <a:lnSpc>
+                <a:spcPct val="125000"/>
+              </a:lnSpc>
+              <a:spcBef>
+                <a:spcPts val="700"/>
+              </a:spcBef>
+            </a:pPr>
+            <a:r>
+              <a:rPr sz="950" b="0" i="0">
+                <a:solidFill>
+                  <a:srgbClr val="1E3652"/>
+                </a:solidFill>
+                <a:latin typeface="Helvetica Neue"/>
+              </a:rPr>
+              <a:t>-  G1, G2, G3, G6 + SRR</a:t>
+            </a:r>
+          </a:p>
+          <a:p>
+            <a:pPr algn="l">
+              <a:lnSpc>
+                <a:spcPct val="125000"/>
+              </a:lnSpc>
+              <a:spcBef>
+                <a:spcPts val="700"/>
+              </a:spcBef>
+            </a:pPr>
+            <a:r>
+              <a:rPr sz="950" b="0" i="0">
+                <a:solidFill>
+                  <a:srgbClr val="1E3652"/>
+                </a:solidFill>
+                <a:latin typeface="Helvetica Neue"/>
+              </a:rPr>
+              <a:t>-  selection rule table, 55 test functions</a:t>
+            </a:r>
+          </a:p>
+        </p:txBody>
+      </p:sp>
+      <p:sp>
+        <p:nvSpPr>
+          <p:cNvPr id="12" name="Rectangle 11"/>
+          <p:cNvSpPr/>
+          <p:nvPr/>
+        </p:nvSpPr>
+        <p:spPr>
+          <a:xfrm>
+            <a:off x="4553712" y="1691640"/>
+            <a:ext cx="3520440" cy="2926080"/>
+          </a:xfrm>
+          <a:prstGeom prst="rect">
+            <a:avLst/>
+          </a:prstGeom>
+          <a:solidFill>
+            <a:srgbClr val="F4F6F8"/>
+          </a:solidFill>
+          <a:ln>
+            <a:noFill/>
+          </a:ln>
+          <a:effectLst/>
+        </p:spPr>
+        <p:txBody>
+          <a:bodyPr rtlCol="0" anchor="ctr" wrap="square"/>
+          <a:lstStyle/>
+          <a:p>
+            <a:pPr algn="ctr"/>
+          </a:p>
+        </p:txBody>
+      </p:sp>
+      <p:sp>
+        <p:nvSpPr>
+          <p:cNvPr id="13" name="Rectangle 12"/>
+          <p:cNvSpPr/>
+          <p:nvPr/>
+        </p:nvSpPr>
+        <p:spPr>
+          <a:xfrm>
+            <a:off x="4553712" y="1691640"/>
+            <a:ext cx="3520440" cy="50292"/>
+          </a:xfrm>
+          <a:prstGeom prst="rect">
+            <a:avLst/>
+          </a:prstGeom>
+          <a:solidFill>
+            <a:srgbClr val="B07A1E"/>
+          </a:solidFill>
+          <a:ln>
+            <a:noFill/>
+          </a:ln>
+          <a:effectLst/>
+        </p:spPr>
+        <p:txBody>
+          <a:bodyPr rtlCol="0" anchor="ctr" wrap="square"/>
+          <a:lstStyle/>
+          <a:p>
+            <a:pPr algn="ctr"/>
+          </a:p>
+        </p:txBody>
+      </p:sp>
+      <p:sp>
+        <p:nvSpPr>
+          <p:cNvPr id="14" name="TextBox 13"/>
+          <p:cNvSpPr txBox="1"/>
+          <p:nvPr/>
+        </p:nvSpPr>
+        <p:spPr>
+          <a:xfrm>
+            <a:off x="4782312" y="1874519"/>
+            <a:ext cx="3108960" cy="320040"/>
+          </a:xfrm>
+          <a:prstGeom prst="rect">
+            <a:avLst/>
+          </a:prstGeom>
+          <a:noFill/>
+        </p:spPr>
+        <p:txBody>
+          <a:bodyPr wrap="square" anchor="t" lIns="0" rIns="0" tIns="0" bIns="0">
+            <a:spAutoFit/>
+          </a:bodyPr>
+          <a:lstStyle/>
+          <a:p>
+            <a:pPr algn="l">
+              <a:lnSpc>
+                <a:spcPct val="115000"/>
+              </a:lnSpc>
+              <a:spcBef>
+                <a:spcPts val="0"/>
+              </a:spcBef>
+            </a:pPr>
+            <a:r>
+              <a:rPr sz="1250" b="1" i="0">
+                <a:solidFill>
+                  <a:srgbClr val="10233A"/>
+                </a:solidFill>
+                <a:latin typeface="Helvetica Neue"/>
+              </a:rPr>
+              <a:t>Partially built</a:t>
+            </a:r>
+          </a:p>
+        </p:txBody>
+      </p:sp>
+      <p:sp>
+        <p:nvSpPr>
+          <p:cNvPr id="15" name="TextBox 14"/>
+          <p:cNvSpPr txBox="1"/>
+          <p:nvPr/>
+        </p:nvSpPr>
+        <p:spPr>
+          <a:xfrm>
+            <a:off x="4782312" y="2331720"/>
+            <a:ext cx="3154680" cy="2834640"/>
+          </a:xfrm>
+          <a:prstGeom prst="rect">
+            <a:avLst/>
+          </a:prstGeom>
+          <a:noFill/>
+        </p:spPr>
+        <p:txBody>
+          <a:bodyPr wrap="square" anchor="t" lIns="0" rIns="0" tIns="0" bIns="0">
+            <a:spAutoFit/>
+          </a:bodyPr>
+          <a:lstStyle/>
+          <a:p>
+            <a:pPr algn="l">
+              <a:lnSpc>
+                <a:spcPct val="125000"/>
+              </a:lnSpc>
+              <a:spcBef>
+                <a:spcPts val="0"/>
+              </a:spcBef>
+            </a:pPr>
+            <a:r>
+              <a:rPr sz="950" b="0" i="0">
+                <a:solidFill>
+                  <a:srgbClr val="1E3652"/>
+                </a:solidFill>
+                <a:latin typeface="Helvetica Neue"/>
+              </a:rPr>
+              <a:t>-  G3 / G6 still use one global threshold</a:t>
+            </a:r>
+          </a:p>
+          <a:p>
+            <a:pPr algn="l">
+              <a:lnSpc>
+                <a:spcPct val="125000"/>
+              </a:lnSpc>
+              <a:spcBef>
+                <a:spcPts val="700"/>
+              </a:spcBef>
+            </a:pPr>
+            <a:r>
+              <a:rPr sz="950" b="0" i="0">
+                <a:solidFill>
+                  <a:srgbClr val="1E3652"/>
+                </a:solidFill>
+                <a:latin typeface="Helvetica Neue"/>
+              </a:rPr>
+              <a:t>-  figure captions need a word-boundary trim</a:t>
+            </a:r>
+          </a:p>
+          <a:p>
+            <a:pPr algn="l">
+              <a:lnSpc>
+                <a:spcPct val="125000"/>
+              </a:lnSpc>
+              <a:spcBef>
+                <a:spcPts val="700"/>
+              </a:spcBef>
+            </a:pPr>
+            <a:r>
+              <a:rPr sz="950" b="0" i="0">
+                <a:solidFill>
+                  <a:srgbClr val="1E3652"/>
+                </a:solidFill>
+                <a:latin typeface="Helvetica Neue"/>
+              </a:rPr>
+              <a:t>-  claims are still extracted by heuristic</a:t>
+            </a:r>
+          </a:p>
+        </p:txBody>
+      </p:sp>
+      <p:sp>
+        <p:nvSpPr>
+          <p:cNvPr id="16" name="Rectangle 15"/>
+          <p:cNvSpPr/>
+          <p:nvPr/>
+        </p:nvSpPr>
+        <p:spPr>
+          <a:xfrm>
+            <a:off x="8238744" y="1691640"/>
+            <a:ext cx="3520440" cy="2926080"/>
+          </a:xfrm>
+          <a:prstGeom prst="rect">
+            <a:avLst/>
+          </a:prstGeom>
+          <a:solidFill>
+            <a:srgbClr val="F4F6F8"/>
+          </a:solidFill>
+          <a:ln>
+            <a:noFill/>
+          </a:ln>
+          <a:effectLst/>
+        </p:spPr>
+        <p:txBody>
+          <a:bodyPr rtlCol="0" anchor="ctr" wrap="square"/>
+          <a:lstStyle/>
+          <a:p>
+            <a:pPr algn="ctr"/>
+          </a:p>
+        </p:txBody>
+      </p:sp>
+      <p:sp>
+        <p:nvSpPr>
+          <p:cNvPr id="17" name="Rectangle 16"/>
+          <p:cNvSpPr/>
+          <p:nvPr/>
+        </p:nvSpPr>
+        <p:spPr>
+          <a:xfrm>
+            <a:off x="8238744" y="1691640"/>
+            <a:ext cx="3520440" cy="50292"/>
+          </a:xfrm>
+          <a:prstGeom prst="rect">
+            <a:avLst/>
+          </a:prstGeom>
+          <a:solidFill>
+            <a:srgbClr val="5A6B7C"/>
+          </a:solidFill>
+          <a:ln>
+            <a:noFill/>
+          </a:ln>
+          <a:effectLst/>
+        </p:spPr>
+        <p:txBody>
+          <a:bodyPr rtlCol="0" anchor="ctr" wrap="square"/>
+          <a:lstStyle/>
+          <a:p>
+            <a:pPr algn="ctr"/>
+          </a:p>
+        </p:txBody>
+      </p:sp>
+      <p:sp>
+        <p:nvSpPr>
+          <p:cNvPr id="18" name="TextBox 17"/>
+          <p:cNvSpPr txBox="1"/>
+          <p:nvPr/>
+        </p:nvSpPr>
+        <p:spPr>
+          <a:xfrm>
+            <a:off x="8467344" y="1874519"/>
+            <a:ext cx="3108960" cy="320040"/>
+          </a:xfrm>
+          <a:prstGeom prst="rect">
+            <a:avLst/>
+          </a:prstGeom>
+          <a:noFill/>
+        </p:spPr>
+        <p:txBody>
+          <a:bodyPr wrap="square" anchor="t" lIns="0" rIns="0" tIns="0" bIns="0">
+            <a:spAutoFit/>
+          </a:bodyPr>
+          <a:lstStyle/>
+          <a:p>
+            <a:pPr algn="l">
+              <a:lnSpc>
+                <a:spcPct val="115000"/>
+              </a:lnSpc>
+              <a:spcBef>
+                <a:spcPts val="0"/>
+              </a:spcBef>
+            </a:pPr>
+            <a:r>
+              <a:rPr sz="1250" b="1" i="0">
+                <a:solidFill>
+                  <a:srgbClr val="10233A"/>
+                </a:solidFill>
+                <a:latin typeface="Helvetica Neue"/>
+              </a:rPr>
+              <a:t>Not started</a:t>
+            </a:r>
+          </a:p>
+        </p:txBody>
+      </p:sp>
+      <p:sp>
+        <p:nvSpPr>
+          <p:cNvPr id="19" name="TextBox 18"/>
+          <p:cNvSpPr txBox="1"/>
+          <p:nvPr/>
+        </p:nvSpPr>
+        <p:spPr>
+          <a:xfrm>
+            <a:off x="8467344" y="2331720"/>
+            <a:ext cx="3154680" cy="2834640"/>
+          </a:xfrm>
+          <a:prstGeom prst="rect">
+            <a:avLst/>
+          </a:prstGeom>
+          <a:noFill/>
+        </p:spPr>
+        <p:txBody>
+          <a:bodyPr wrap="square" anchor="t" lIns="0" rIns="0" tIns="0" bIns="0">
+            <a:spAutoFit/>
+          </a:bodyPr>
+          <a:lstStyle/>
+          <a:p>
+            <a:pPr algn="l">
+              <a:lnSpc>
+                <a:spcPct val="125000"/>
+              </a:lnSpc>
+              <a:spcBef>
+                <a:spcPts val="0"/>
+              </a:spcBef>
+            </a:pPr>
+            <a:r>
+              <a:rPr sz="950" b="0" i="0">
+                <a:solidFill>
+                  <a:srgbClr val="1E3652"/>
+                </a:solidFill>
+                <a:latin typeface="Helvetica Neue"/>
+              </a:rPr>
+              <a:t>-  G4 contrast, G5 text fit</a:t>
+            </a:r>
+          </a:p>
+          <a:p>
+            <a:pPr algn="l">
+              <a:lnSpc>
+                <a:spcPct val="125000"/>
+              </a:lnSpc>
+              <a:spcBef>
+                <a:spcPts val="700"/>
+              </a:spcBef>
+            </a:pPr>
+            <a:r>
+              <a:rPr sz="950" b="0" i="0">
+                <a:solidFill>
+                  <a:srgbClr val="1E3652"/>
+                </a:solidFill>
+                <a:latin typeface="Helvetica Neue"/>
+              </a:rPr>
+              <a:t>-  repair actions and the loop</a:t>
+            </a:r>
+          </a:p>
+          <a:p>
+            <a:pPr algn="l">
+              <a:lnSpc>
+                <a:spcPct val="125000"/>
+              </a:lnSpc>
+              <a:spcBef>
+                <a:spcPts val="700"/>
+              </a:spcBef>
+            </a:pPr>
+            <a:r>
+              <a:rPr sz="950" b="0" i="0">
+                <a:solidFill>
+                  <a:srgbClr val="1E3652"/>
+                </a:solidFill>
+                <a:latin typeface="Helvetica Neue"/>
+              </a:rPr>
+              <a:t>-  110-slide test set and its labels</a:t>
+            </a:r>
+          </a:p>
+          <a:p>
+            <a:pPr algn="l">
+              <a:lnSpc>
+                <a:spcPct val="125000"/>
+              </a:lnSpc>
+              <a:spcBef>
+                <a:spcPts val="700"/>
+              </a:spcBef>
+            </a:pPr>
+            <a:r>
+              <a:rPr sz="950" b="0" i="0">
+                <a:solidFill>
+                  <a:srgbClr val="1E3652"/>
+                </a:solidFill>
+                <a:latin typeface="Helvetica Neue"/>
+              </a:rPr>
+              <a:t>-  human decks, baselines, the 2x2 experiment</a:t>
+            </a:r>
+          </a:p>
+        </p:txBody>
+      </p:sp>
+      <p:sp>
+        <p:nvSpPr>
+          <p:cNvPr id="20" name="TextBox 19"/>
+          <p:cNvSpPr txBox="1"/>
+          <p:nvPr/>
+        </p:nvSpPr>
+        <p:spPr>
+          <a:xfrm>
+            <a:off x="868680" y="4937760"/>
+            <a:ext cx="10881360" cy="548640"/>
+          </a:xfrm>
+          <a:prstGeom prst="rect">
+            <a:avLst/>
+          </a:prstGeom>
+          <a:noFill/>
+        </p:spPr>
+        <p:txBody>
+          <a:bodyPr wrap="square" anchor="t" lIns="0" rIns="0" tIns="0" bIns="0">
+            <a:spAutoFit/>
+          </a:bodyPr>
+          <a:lstStyle/>
+          <a:p>
+            <a:pPr algn="l">
+              <a:lnSpc>
+                <a:spcPct val="115000"/>
+              </a:lnSpc>
+              <a:spcBef>
+                <a:spcPts val="0"/>
+              </a:spcBef>
+            </a:pPr>
+            <a:r>
+              <a:rPr sz="1050" b="0" i="1">
+                <a:solidFill>
+                  <a:srgbClr val="5A6B7C"/>
+                </a:solidFill>
+                <a:latin typeface="Helvetica Neue"/>
+              </a:rPr>
+              <a:t>76 test cases pass. The deck above was produced by this pipeline end to end.</a:t>
+            </a:r>
+          </a:p>
+        </p:txBody>
+      </p:sp>
+    </p:spTree>
+  </p:cSld>
+  <p:clrMapOvr>
+    <a:masterClrMapping/>
+  </p:clrMapOvr>
+</p:sld>
+</file>
+
+<file path=ppt/slides/slide13.xml><?xml version="1.0" encoding="utf-8"?>
+<p:sld xmlns:a="http://schemas.openxmlformats.org/drawingml/2006/main" xmlns:p="http://schemas.openxmlformats.org/presentationml/2006/main" xmlns:r="http://schemas.openxmlformats.org/officeDocument/2006/relationships">
+  <p:cSld>
+    <p:spTree>
+      <p:nvGrpSpPr>
+        <p:cNvPr id="1" name=""/>
+        <p:cNvGrpSpPr/>
+        <p:nvPr/>
+      </p:nvGrpSpPr>
+      <p:grpSpPr/>
+      <p:sp>
+        <p:nvSpPr>
+          <p:cNvPr id="2" name="Rectangle 1"/>
+          <p:cNvSpPr/>
+          <p:nvPr/>
+        </p:nvSpPr>
+        <p:spPr>
+          <a:xfrm>
+            <a:off x="0" y="0"/>
+            <a:ext cx="237744" cy="6858000"/>
+          </a:xfrm>
+          <a:prstGeom prst="rect">
+            <a:avLst/>
+          </a:prstGeom>
+          <a:solidFill>
+            <a:srgbClr val="10233A"/>
+          </a:solidFill>
+          <a:ln>
+            <a:noFill/>
+          </a:ln>
+          <a:effectLst/>
+        </p:spPr>
+        <p:txBody>
+          <a:bodyPr rtlCol="0" anchor="ctr" wrap="square"/>
+          <a:lstStyle/>
+          <a:p>
+            <a:pPr algn="ctr"/>
+          </a:p>
+        </p:txBody>
+      </p:sp>
+      <p:sp>
+        <p:nvSpPr>
+          <p:cNvPr id="3" name="Rectangle 2"/>
+          <p:cNvSpPr/>
+          <p:nvPr/>
+        </p:nvSpPr>
+        <p:spPr>
+          <a:xfrm>
+            <a:off x="237744" y="0"/>
+            <a:ext cx="45720" cy="6858000"/>
+          </a:xfrm>
+          <a:prstGeom prst="rect">
+            <a:avLst/>
+          </a:prstGeom>
+          <a:solidFill>
+            <a:srgbClr val="C08A2E"/>
+          </a:solidFill>
+          <a:ln>
+            <a:noFill/>
+          </a:ln>
+          <a:effectLst/>
+        </p:spPr>
+        <p:txBody>
+          <a:bodyPr rtlCol="0" anchor="ctr" wrap="square"/>
+          <a:lstStyle/>
+          <a:p>
+            <a:pPr algn="ctr"/>
+          </a:p>
+        </p:txBody>
+      </p:sp>
+      <p:sp>
+        <p:nvSpPr>
+          <p:cNvPr id="4" name="TextBox 3"/>
+          <p:cNvSpPr txBox="1"/>
+          <p:nvPr/>
+        </p:nvSpPr>
+        <p:spPr>
+          <a:xfrm>
+            <a:off x="868680" y="384048"/>
+            <a:ext cx="10607040" cy="274320"/>
+          </a:xfrm>
+          <a:prstGeom prst="rect">
+            <a:avLst/>
+          </a:prstGeom>
+          <a:noFill/>
+        </p:spPr>
+        <p:txBody>
+          <a:bodyPr wrap="square" anchor="t" lIns="0" rIns="0" tIns="0" bIns="0">
+            <a:spAutoFit/>
+          </a:bodyPr>
+          <a:lstStyle/>
+          <a:p>
+            <a:pPr algn="l">
+              <a:lnSpc>
+                <a:spcPct val="115000"/>
+              </a:lnSpc>
+              <a:spcBef>
+                <a:spcPts val="0"/>
+              </a:spcBef>
+            </a:pPr>
+            <a:r>
+              <a:rPr sz="950" b="1" i="0">
+                <a:solidFill>
+                  <a:srgbClr val="C08A2E"/>
+                </a:solidFill>
+                <a:latin typeface="Helvetica Neue"/>
+              </a:rPr>
+              <a:t>PLAN</a:t>
+            </a:r>
+          </a:p>
+        </p:txBody>
+      </p:sp>
+      <p:sp>
+        <p:nvSpPr>
+          <p:cNvPr id="5" name="TextBox 4"/>
+          <p:cNvSpPr txBox="1"/>
+          <p:nvPr/>
+        </p:nvSpPr>
+        <p:spPr>
+          <a:xfrm>
+            <a:off x="868680" y="640080"/>
+            <a:ext cx="10881360" cy="685800"/>
+          </a:xfrm>
+          <a:prstGeom prst="rect">
+            <a:avLst/>
+          </a:prstGeom>
+          <a:noFill/>
+        </p:spPr>
+        <p:txBody>
+          <a:bodyPr wrap="square" anchor="t" lIns="0" rIns="0" tIns="0" bIns="0">
+            <a:spAutoFit/>
+          </a:bodyPr>
+          <a:lstStyle/>
+          <a:p>
+            <a:pPr algn="l">
+              <a:lnSpc>
+                <a:spcPct val="105000"/>
+              </a:lnSpc>
+              <a:spcBef>
+                <a:spcPts val="0"/>
+              </a:spcBef>
+            </a:pPr>
+            <a:r>
+              <a:rPr sz="2500" b="1" i="0">
+                <a:solidFill>
+                  <a:srgbClr val="10233A"/>
+                </a:solidFill>
+                <a:latin typeface="Helvetica Neue"/>
+              </a:rPr>
+              <a:t>The experiment, and the calendar</a:t>
+            </a:r>
+          </a:p>
+        </p:txBody>
+      </p:sp>
+      <p:sp>
+        <p:nvSpPr>
+          <p:cNvPr id="6" name="Rectangle 5"/>
+          <p:cNvSpPr/>
+          <p:nvPr/>
+        </p:nvSpPr>
+        <p:spPr>
+          <a:xfrm>
+            <a:off x="868680" y="1389888"/>
+            <a:ext cx="10881360" cy="12801"/>
+          </a:xfrm>
+          <a:prstGeom prst="rect">
+            <a:avLst/>
+          </a:prstGeom>
+          <a:solidFill>
+            <a:srgbClr val="DDE2E8"/>
+          </a:solidFill>
+          <a:ln>
+            <a:noFill/>
+          </a:ln>
+          <a:effectLst/>
+        </p:spPr>
+        <p:txBody>
+          <a:bodyPr rtlCol="0" anchor="ctr" wrap="square"/>
+          <a:lstStyle/>
+          <a:p>
+            <a:pPr algn="ctr"/>
+          </a:p>
+        </p:txBody>
+      </p:sp>
+      <p:sp>
+        <p:nvSpPr>
+          <p:cNvPr id="7" name="TextBox 6"/>
+          <p:cNvSpPr txBox="1"/>
+          <p:nvPr/>
+        </p:nvSpPr>
+        <p:spPr>
+          <a:xfrm>
+            <a:off x="11155680" y="6355080"/>
+            <a:ext cx="640080" cy="274320"/>
+          </a:xfrm>
+          <a:prstGeom prst="rect">
+            <a:avLst/>
+          </a:prstGeom>
+          <a:noFill/>
+        </p:spPr>
+        <p:txBody>
+          <a:bodyPr wrap="square" anchor="t" lIns="0" rIns="0" tIns="0" bIns="0">
+            <a:spAutoFit/>
+          </a:bodyPr>
+          <a:lstStyle/>
+          <a:p>
+            <a:pPr algn="r">
+              <a:lnSpc>
+                <a:spcPct val="115000"/>
+              </a:lnSpc>
+              <a:spcBef>
+                <a:spcPts val="0"/>
+              </a:spcBef>
+            </a:pPr>
+            <a:r>
+              <a:rPr sz="900" b="0" i="0">
+                <a:solidFill>
+                  <a:srgbClr val="8A99A8"/>
+                </a:solidFill>
+                <a:latin typeface="Helvetica Neue"/>
+              </a:rPr>
+              <a:t>13</a:t>
             </a:r>
           </a:p>
         </p:txBody>
@@ -6131,7 +7145,7 @@
 </p:sld>
 </file>
 
-<file path=ppt/slides/slide13.xml><?xml version="1.0" encoding="utf-8"?>
+<file path=ppt/slides/slide14.xml><?xml version="1.0" encoding="utf-8"?>
 <p:sld xmlns:a="http://schemas.openxmlformats.org/drawingml/2006/main" xmlns:p="http://schemas.openxmlformats.org/presentationml/2006/main" xmlns:r="http://schemas.openxmlformats.org/officeDocument/2006/relationships">
   <p:cSld>
     <p:spTree>
@@ -6352,7 +7366,7 @@
                 </a:solidFill>
                 <a:latin typeface="Helvetica Neue"/>
               </a:rPr>
-              <a:t>13</a:t>
+              <a:t>14</a:t>
             </a:r>
           </a:p>
         </p:txBody>
@@ -14730,7 +15744,7 @@
                 </a:solidFill>
                 <a:latin typeface="Helvetica Neue"/>
               </a:rPr>
-              <a:t>RESULTS SO FAR</a:t>
+              <a:t>SCOPE</a:t>
             </a:r>
           </a:p>
         </p:txBody>
@@ -14772,7 +15786,7 @@
                 </a:solidFill>
                 <a:latin typeface="Helvetica Neue"/>
               </a:rPr>
-              <a:t>Every generated slide fails at least one gate</a:t>
+              <a:t>Sixty-five things you could measure. Six are worth it</a:t>
             </a:r>
           </a:p>
         </p:txBody>
@@ -14849,83 +15863,17 @@
           </a:p>
         </p:txBody>
       </p:sp>
-      <p:pic>
-        <p:nvPicPr>
-          <p:cNvPr id="8" name="Picture 7" descr="slide02.png"/>
-          <p:cNvPicPr>
-            <a:picLocks noChangeAspect="1"/>
-          </p:cNvPicPr>
-          <p:nvPr/>
-        </p:nvPicPr>
-        <p:blipFill>
-          <a:blip r:embed="rId2"/>
-          <a:stretch>
-            <a:fillRect/>
-          </a:stretch>
-        </p:blipFill>
-        <p:spPr>
-          <a:xfrm>
-            <a:off x="868680" y="1645920"/>
-            <a:ext cx="6263640" cy="3523298"/>
-          </a:xfrm>
-          <a:prstGeom prst="rect">
-            <a:avLst/>
-          </a:prstGeom>
-        </p:spPr>
-      </p:pic>
-      <p:sp>
-        <p:nvSpPr>
-          <p:cNvPr id="9" name="TextBox 8"/>
-          <p:cNvSpPr txBox="1"/>
-          <p:nvPr/>
-        </p:nvSpPr>
-        <p:spPr>
-          <a:xfrm>
-            <a:off x="868680" y="5257800"/>
-            <a:ext cx="6263640" cy="457200"/>
-          </a:xfrm>
-          <a:prstGeom prst="rect">
-            <a:avLst/>
-          </a:prstGeom>
-          <a:noFill/>
-        </p:spPr>
-        <p:txBody>
-          <a:bodyPr wrap="square" anchor="t" lIns="0" rIns="0" tIns="0" bIns="0">
-            <a:spAutoFit/>
-          </a:bodyPr>
-          <a:lstStyle/>
-          <a:p>
-            <a:pPr algn="l">
-              <a:lnSpc>
-                <a:spcPct val="115000"/>
-              </a:lnSpc>
-              <a:spcBef>
-                <a:spcPts val="0"/>
-              </a:spcBef>
-            </a:pPr>
-            <a:r>
-              <a:rPr sz="850" b="0" i="1">
-                <a:solidFill>
-                  <a:srgbClr val="5A6B7C"/>
-                </a:solidFill>
-                <a:latin typeface="Helvetica Neue"/>
-              </a:rPr>
-              <a:t>Slide 2 of the generated deck: figure placed, caption under it</a:t>
-            </a:r>
-          </a:p>
-        </p:txBody>
-      </p:sp>
       <p:graphicFrame>
         <p:nvGraphicFramePr>
-          <p:cNvPr id="10" name="Table 9"/>
+          <p:cNvPr id="8" name="Table 7"/>
           <p:cNvGraphicFramePr>
             <a:graphicFrameLocks noGrp="1"/>
           </p:cNvGraphicFramePr>
           <p:nvPr/>
         </p:nvGraphicFramePr>
         <p:xfrm>
-          <a:off x="7452360" y="1664208"/>
-          <a:ext cx="4160519" cy="2121408"/>
+          <a:off x="868680" y="1691640"/>
+          <a:ext cx="3566160" cy="2798064"/>
         </p:xfrm>
         <a:graphic>
           <a:graphicData uri="http://schemas.openxmlformats.org/drawingml/2006/table">
@@ -14934,9 +15882,8 @@
                 <a:tableStyleId>{5C22544A-7EE6-4342-B048-85BDC9FD1C3A}</a:tableStyleId>
               </a:tblPr>
               <a:tblGrid>
-                <a:gridCol w="1874519"/>
-                <a:gridCol w="1143000"/>
-                <a:gridCol w="1143000"/>
+                <a:gridCol w="2651760"/>
+                <a:gridCol w="914400"/>
               </a:tblGrid>
               <a:tr h="310896">
                 <a:tc>
@@ -14953,13 +15900,13 @@
                         </a:spcBef>
                       </a:pPr>
                       <a:r>
-                        <a:rPr sz="950" b="1" i="0">
+                        <a:rPr sz="900" b="1" i="0">
                           <a:solidFill>
                             <a:srgbClr val="10233A"/>
                           </a:solidFill>
                           <a:latin typeface="Helvetica Neue"/>
                         </a:rPr>
-                        <a:t/>
+                        <a:t>candidate</a:t>
                       </a:r>
                     </a:p>
                   </a:txBody>
@@ -14983,13 +15930,769 @@
                         </a:spcBef>
                       </a:pPr>
                       <a:r>
+                        <a:rPr sz="900" b="1" i="0">
+                          <a:solidFill>
+                            <a:srgbClr val="10233A"/>
+                          </a:solidFill>
+                          <a:latin typeface="Helvetica Neue"/>
+                        </a:rPr>
+                        <a:t>n</a:t>
+                      </a:r>
+                    </a:p>
+                  </a:txBody>
+                  <a:tcPr marL="73152" marT="36576" marB="36576">
+                    <a:solidFill>
+                      <a:srgbClr val="ECF1F5"/>
+                    </a:solidFill>
+                  </a:tcPr>
+                </a:tc>
+              </a:tr>
+              <a:tr h="310896">
+                <a:tc>
+                  <a:txBody>
+                    <a:bodyPr wrap="square"/>
+                    <a:lstStyle/>
+                    <a:p>
+                      <a:pPr algn="l">
+                        <a:lnSpc>
+                          <a:spcPct val="110000"/>
+                        </a:lnSpc>
+                        <a:spcBef>
+                          <a:spcPts val="0"/>
+                        </a:spcBef>
+                      </a:pPr>
+                      <a:r>
                         <a:rPr sz="950" b="1" i="0">
                           <a:solidFill>
                             <a:srgbClr val="10233A"/>
                           </a:solidFill>
                           <a:latin typeface="Helvetica Neue"/>
                         </a:rPr>
-                        <a:t>PPTAgent</a:t>
+                        <a:t>A  layout geometry</a:t>
+                      </a:r>
+                    </a:p>
+                  </a:txBody>
+                  <a:tcPr marL="73152" marT="36576" marB="36576">
+                    <a:solidFill>
+                      <a:srgbClr val="FFFFFF"/>
+                    </a:solidFill>
+                  </a:tcPr>
+                </a:tc>
+                <a:tc>
+                  <a:txBody>
+                    <a:bodyPr wrap="square"/>
+                    <a:lstStyle/>
+                    <a:p>
+                      <a:pPr algn="l">
+                        <a:lnSpc>
+                          <a:spcPct val="110000"/>
+                        </a:lnSpc>
+                        <a:spcBef>
+                          <a:spcPts val="0"/>
+                        </a:spcBef>
+                      </a:pPr>
+                      <a:r>
+                        <a:rPr sz="950" b="0" i="0">
+                          <a:solidFill>
+                            <a:srgbClr val="1E3652"/>
+                          </a:solidFill>
+                          <a:latin typeface="Helvetica Neue"/>
+                        </a:rPr>
+                        <a:t>14</a:t>
+                      </a:r>
+                    </a:p>
+                  </a:txBody>
+                  <a:tcPr marL="73152" marT="36576" marB="36576">
+                    <a:solidFill>
+                      <a:srgbClr val="FFFFFF"/>
+                    </a:solidFill>
+                  </a:tcPr>
+                </a:tc>
+              </a:tr>
+              <a:tr h="310896">
+                <a:tc>
+                  <a:txBody>
+                    <a:bodyPr wrap="square"/>
+                    <a:lstStyle/>
+                    <a:p>
+                      <a:pPr algn="l">
+                        <a:lnSpc>
+                          <a:spcPct val="110000"/>
+                        </a:lnSpc>
+                        <a:spcBef>
+                          <a:spcPts val="0"/>
+                        </a:spcBef>
+                      </a:pPr>
+                      <a:r>
+                        <a:rPr sz="950" b="1" i="0">
+                          <a:solidFill>
+                            <a:srgbClr val="10233A"/>
+                          </a:solidFill>
+                          <a:latin typeface="Helvetica Neue"/>
+                        </a:rPr>
+                        <a:t>B  typography</a:t>
+                      </a:r>
+                    </a:p>
+                  </a:txBody>
+                  <a:tcPr marL="73152" marT="36576" marB="36576">
+                    <a:solidFill>
+                      <a:srgbClr val="FFFFFF"/>
+                    </a:solidFill>
+                  </a:tcPr>
+                </a:tc>
+                <a:tc>
+                  <a:txBody>
+                    <a:bodyPr wrap="square"/>
+                    <a:lstStyle/>
+                    <a:p>
+                      <a:pPr algn="l">
+                        <a:lnSpc>
+                          <a:spcPct val="110000"/>
+                        </a:lnSpc>
+                        <a:spcBef>
+                          <a:spcPts val="0"/>
+                        </a:spcBef>
+                      </a:pPr>
+                      <a:r>
+                        <a:rPr sz="950" b="0" i="0">
+                          <a:solidFill>
+                            <a:srgbClr val="1E3652"/>
+                          </a:solidFill>
+                          <a:latin typeface="Helvetica Neue"/>
+                        </a:rPr>
+                        <a:t>15</a:t>
+                      </a:r>
+                    </a:p>
+                  </a:txBody>
+                  <a:tcPr marL="73152" marT="36576" marB="36576">
+                    <a:solidFill>
+                      <a:srgbClr val="FFFFFF"/>
+                    </a:solidFill>
+                  </a:tcPr>
+                </a:tc>
+              </a:tr>
+              <a:tr h="310896">
+                <a:tc>
+                  <a:txBody>
+                    <a:bodyPr wrap="square"/>
+                    <a:lstStyle/>
+                    <a:p>
+                      <a:pPr algn="l">
+                        <a:lnSpc>
+                          <a:spcPct val="110000"/>
+                        </a:lnSpc>
+                        <a:spcBef>
+                          <a:spcPts val="0"/>
+                        </a:spcBef>
+                      </a:pPr>
+                      <a:r>
+                        <a:rPr sz="950" b="1" i="0">
+                          <a:solidFill>
+                            <a:srgbClr val="10233A"/>
+                          </a:solidFill>
+                          <a:latin typeface="Helvetica Neue"/>
+                        </a:rPr>
+                        <a:t>C  colour and contrast</a:t>
+                      </a:r>
+                    </a:p>
+                  </a:txBody>
+                  <a:tcPr marL="73152" marT="36576" marB="36576">
+                    <a:solidFill>
+                      <a:srgbClr val="FFFFFF"/>
+                    </a:solidFill>
+                  </a:tcPr>
+                </a:tc>
+                <a:tc>
+                  <a:txBody>
+                    <a:bodyPr wrap="square"/>
+                    <a:lstStyle/>
+                    <a:p>
+                      <a:pPr algn="l">
+                        <a:lnSpc>
+                          <a:spcPct val="110000"/>
+                        </a:lnSpc>
+                        <a:spcBef>
+                          <a:spcPts val="0"/>
+                        </a:spcBef>
+                      </a:pPr>
+                      <a:r>
+                        <a:rPr sz="950" b="0" i="0">
+                          <a:solidFill>
+                            <a:srgbClr val="1E3652"/>
+                          </a:solidFill>
+                          <a:latin typeface="Helvetica Neue"/>
+                        </a:rPr>
+                        <a:t>7</a:t>
+                      </a:r>
+                    </a:p>
+                  </a:txBody>
+                  <a:tcPr marL="73152" marT="36576" marB="36576">
+                    <a:solidFill>
+                      <a:srgbClr val="FFFFFF"/>
+                    </a:solidFill>
+                  </a:tcPr>
+                </a:tc>
+              </a:tr>
+              <a:tr h="310896">
+                <a:tc>
+                  <a:txBody>
+                    <a:bodyPr wrap="square"/>
+                    <a:lstStyle/>
+                    <a:p>
+                      <a:pPr algn="l">
+                        <a:lnSpc>
+                          <a:spcPct val="110000"/>
+                        </a:lnSpc>
+                        <a:spcBef>
+                          <a:spcPts val="0"/>
+                        </a:spcBef>
+                      </a:pPr>
+                      <a:r>
+                        <a:rPr sz="950" b="1" i="0">
+                          <a:solidFill>
+                            <a:srgbClr val="10233A"/>
+                          </a:solidFill>
+                          <a:latin typeface="Helvetica Neue"/>
+                        </a:rPr>
+                        <a:t>D  content and meaning</a:t>
+                      </a:r>
+                    </a:p>
+                  </a:txBody>
+                  <a:tcPr marL="73152" marT="36576" marB="36576">
+                    <a:solidFill>
+                      <a:srgbClr val="FFFFFF"/>
+                    </a:solidFill>
+                  </a:tcPr>
+                </a:tc>
+                <a:tc>
+                  <a:txBody>
+                    <a:bodyPr wrap="square"/>
+                    <a:lstStyle/>
+                    <a:p>
+                      <a:pPr algn="l">
+                        <a:lnSpc>
+                          <a:spcPct val="110000"/>
+                        </a:lnSpc>
+                        <a:spcBef>
+                          <a:spcPts val="0"/>
+                        </a:spcBef>
+                      </a:pPr>
+                      <a:r>
+                        <a:rPr sz="950" b="0" i="0">
+                          <a:solidFill>
+                            <a:srgbClr val="1E3652"/>
+                          </a:solidFill>
+                          <a:latin typeface="Helvetica Neue"/>
+                        </a:rPr>
+                        <a:t>12</a:t>
+                      </a:r>
+                    </a:p>
+                  </a:txBody>
+                  <a:tcPr marL="73152" marT="36576" marB="36576">
+                    <a:solidFill>
+                      <a:srgbClr val="FFFFFF"/>
+                    </a:solidFill>
+                  </a:tcPr>
+                </a:tc>
+              </a:tr>
+              <a:tr h="310896">
+                <a:tc>
+                  <a:txBody>
+                    <a:bodyPr wrap="square"/>
+                    <a:lstStyle/>
+                    <a:p>
+                      <a:pPr algn="l">
+                        <a:lnSpc>
+                          <a:spcPct val="110000"/>
+                        </a:lnSpc>
+                        <a:spcBef>
+                          <a:spcPts val="0"/>
+                        </a:spcBef>
+                      </a:pPr>
+                      <a:r>
+                        <a:rPr sz="950" b="1" i="0">
+                          <a:solidFill>
+                            <a:srgbClr val="10233A"/>
+                          </a:solidFill>
+                          <a:latin typeface="Helvetica Neue"/>
+                        </a:rPr>
+                        <a:t>E  structure</a:t>
+                      </a:r>
+                    </a:p>
+                  </a:txBody>
+                  <a:tcPr marL="73152" marT="36576" marB="36576">
+                    <a:solidFill>
+                      <a:srgbClr val="FFFFFF"/>
+                    </a:solidFill>
+                  </a:tcPr>
+                </a:tc>
+                <a:tc>
+                  <a:txBody>
+                    <a:bodyPr wrap="square"/>
+                    <a:lstStyle/>
+                    <a:p>
+                      <a:pPr algn="l">
+                        <a:lnSpc>
+                          <a:spcPct val="110000"/>
+                        </a:lnSpc>
+                        <a:spcBef>
+                          <a:spcPts val="0"/>
+                        </a:spcBef>
+                      </a:pPr>
+                      <a:r>
+                        <a:rPr sz="950" b="0" i="0">
+                          <a:solidFill>
+                            <a:srgbClr val="1E3652"/>
+                          </a:solidFill>
+                          <a:latin typeface="Helvetica Neue"/>
+                        </a:rPr>
+                        <a:t>8</a:t>
+                      </a:r>
+                    </a:p>
+                  </a:txBody>
+                  <a:tcPr marL="73152" marT="36576" marB="36576">
+                    <a:solidFill>
+                      <a:srgbClr val="FFFFFF"/>
+                    </a:solidFill>
+                  </a:tcPr>
+                </a:tc>
+              </a:tr>
+              <a:tr h="310896">
+                <a:tc>
+                  <a:txBody>
+                    <a:bodyPr wrap="square"/>
+                    <a:lstStyle/>
+                    <a:p>
+                      <a:pPr algn="l">
+                        <a:lnSpc>
+                          <a:spcPct val="110000"/>
+                        </a:lnSpc>
+                        <a:spcBef>
+                          <a:spcPts val="0"/>
+                        </a:spcBef>
+                      </a:pPr>
+                      <a:r>
+                        <a:rPr sz="950" b="1" i="0">
+                          <a:solidFill>
+                            <a:srgbClr val="10233A"/>
+                          </a:solidFill>
+                          <a:latin typeface="Helvetica Neue"/>
+                        </a:rPr>
+                        <a:t>F  rendering</a:t>
+                      </a:r>
+                    </a:p>
+                  </a:txBody>
+                  <a:tcPr marL="73152" marT="36576" marB="36576">
+                    <a:solidFill>
+                      <a:srgbClr val="FFFFFF"/>
+                    </a:solidFill>
+                  </a:tcPr>
+                </a:tc>
+                <a:tc>
+                  <a:txBody>
+                    <a:bodyPr wrap="square"/>
+                    <a:lstStyle/>
+                    <a:p>
+                      <a:pPr algn="l">
+                        <a:lnSpc>
+                          <a:spcPct val="110000"/>
+                        </a:lnSpc>
+                        <a:spcBef>
+                          <a:spcPts val="0"/>
+                        </a:spcBef>
+                      </a:pPr>
+                      <a:r>
+                        <a:rPr sz="950" b="0" i="0">
+                          <a:solidFill>
+                            <a:srgbClr val="1E3652"/>
+                          </a:solidFill>
+                          <a:latin typeface="Helvetica Neue"/>
+                        </a:rPr>
+                        <a:t>5</a:t>
+                      </a:r>
+                    </a:p>
+                  </a:txBody>
+                  <a:tcPr marL="73152" marT="36576" marB="36576">
+                    <a:solidFill>
+                      <a:srgbClr val="FFFFFF"/>
+                    </a:solidFill>
+                  </a:tcPr>
+                </a:tc>
+              </a:tr>
+              <a:tr h="310896">
+                <a:tc>
+                  <a:txBody>
+                    <a:bodyPr wrap="square"/>
+                    <a:lstStyle/>
+                    <a:p>
+                      <a:pPr algn="l">
+                        <a:lnSpc>
+                          <a:spcPct val="110000"/>
+                        </a:lnSpc>
+                        <a:spcBef>
+                          <a:spcPts val="0"/>
+                        </a:spcBef>
+                      </a:pPr>
+                      <a:r>
+                        <a:rPr sz="950" b="1" i="0">
+                          <a:solidFill>
+                            <a:srgbClr val="10233A"/>
+                          </a:solidFill>
+                          <a:latin typeface="Helvetica Neue"/>
+                        </a:rPr>
+                        <a:t>G  audience</a:t>
+                      </a:r>
+                    </a:p>
+                  </a:txBody>
+                  <a:tcPr marL="73152" marT="36576" marB="36576">
+                    <a:solidFill>
+                      <a:srgbClr val="FFFFFF"/>
+                    </a:solidFill>
+                  </a:tcPr>
+                </a:tc>
+                <a:tc>
+                  <a:txBody>
+                    <a:bodyPr wrap="square"/>
+                    <a:lstStyle/>
+                    <a:p>
+                      <a:pPr algn="l">
+                        <a:lnSpc>
+                          <a:spcPct val="110000"/>
+                        </a:lnSpc>
+                        <a:spcBef>
+                          <a:spcPts val="0"/>
+                        </a:spcBef>
+                      </a:pPr>
+                      <a:r>
+                        <a:rPr sz="950" b="0" i="0">
+                          <a:solidFill>
+                            <a:srgbClr val="1E3652"/>
+                          </a:solidFill>
+                          <a:latin typeface="Helvetica Neue"/>
+                        </a:rPr>
+                        <a:t>4</a:t>
+                      </a:r>
+                    </a:p>
+                  </a:txBody>
+                  <a:tcPr marL="73152" marT="36576" marB="36576">
+                    <a:solidFill>
+                      <a:srgbClr val="FFFFFF"/>
+                    </a:solidFill>
+                  </a:tcPr>
+                </a:tc>
+              </a:tr>
+              <a:tr h="310896">
+                <a:tc>
+                  <a:txBody>
+                    <a:bodyPr wrap="square"/>
+                    <a:lstStyle/>
+                    <a:p>
+                      <a:pPr algn="l">
+                        <a:lnSpc>
+                          <a:spcPct val="115000"/>
+                        </a:lnSpc>
+                        <a:spcBef>
+                          <a:spcPts val="0"/>
+                        </a:spcBef>
+                      </a:pPr>
+                      <a:r>
+                        <a:rPr sz="950" b="1" i="0">
+                          <a:solidFill>
+                            <a:srgbClr val="10233A"/>
+                          </a:solidFill>
+                          <a:latin typeface="Helvetica Neue"/>
+                        </a:rPr>
+                        <a:t>total</a:t>
+                      </a:r>
+                    </a:p>
+                  </a:txBody>
+                  <a:tcPr marL="73152" marT="36576" marB="36576">
+                    <a:solidFill>
+                      <a:srgbClr val="FFFFFF"/>
+                    </a:solidFill>
+                  </a:tcPr>
+                </a:tc>
+                <a:tc>
+                  <a:txBody>
+                    <a:bodyPr wrap="square"/>
+                    <a:lstStyle/>
+                    <a:p>
+                      <a:pPr algn="l">
+                        <a:lnSpc>
+                          <a:spcPct val="115000"/>
+                        </a:lnSpc>
+                        <a:spcBef>
+                          <a:spcPts val="0"/>
+                        </a:spcBef>
+                      </a:pPr>
+                      <a:r>
+                        <a:rPr sz="950" b="1" i="0">
+                          <a:solidFill>
+                            <a:srgbClr val="C08A2E"/>
+                          </a:solidFill>
+                          <a:latin typeface="Helvetica Neue"/>
+                        </a:rPr>
+                        <a:t>65</a:t>
+                      </a:r>
+                    </a:p>
+                  </a:txBody>
+                  <a:tcPr marL="73152" marT="36576" marB="36576">
+                    <a:solidFill>
+                      <a:srgbClr val="FFFFFF"/>
+                    </a:solidFill>
+                  </a:tcPr>
+                </a:tc>
+              </a:tr>
+            </a:tbl>
+          </a:graphicData>
+        </a:graphic>
+      </p:graphicFrame>
+      <p:sp>
+        <p:nvSpPr>
+          <p:cNvPr id="9" name="TextBox 8"/>
+          <p:cNvSpPr txBox="1"/>
+          <p:nvPr/>
+        </p:nvSpPr>
+        <p:spPr>
+          <a:xfrm>
+            <a:off x="4800600" y="1691640"/>
+            <a:ext cx="2834640" cy="320040"/>
+          </a:xfrm>
+          <a:prstGeom prst="rect">
+            <a:avLst/>
+          </a:prstGeom>
+          <a:noFill/>
+        </p:spPr>
+        <p:txBody>
+          <a:bodyPr wrap="square" anchor="t" lIns="0" rIns="0" tIns="0" bIns="0">
+            <a:spAutoFit/>
+          </a:bodyPr>
+          <a:lstStyle/>
+          <a:p>
+            <a:pPr algn="l">
+              <a:lnSpc>
+                <a:spcPct val="115000"/>
+              </a:lnSpc>
+              <a:spcBef>
+                <a:spcPts val="0"/>
+              </a:spcBef>
+            </a:pPr>
+            <a:r>
+              <a:rPr sz="1100" b="1" i="0">
+                <a:solidFill>
+                  <a:srgbClr val="10233A"/>
+                </a:solidFill>
+                <a:latin typeface="Helvetica Neue"/>
+              </a:rPr>
+              <a:t>Five tests</a:t>
+            </a:r>
+          </a:p>
+        </p:txBody>
+      </p:sp>
+      <p:sp>
+        <p:nvSpPr>
+          <p:cNvPr id="10" name="TextBox 9"/>
+          <p:cNvSpPr txBox="1"/>
+          <p:nvPr/>
+        </p:nvSpPr>
+        <p:spPr>
+          <a:xfrm>
+            <a:off x="4800600" y="2057400"/>
+            <a:ext cx="2880360" cy="2194560"/>
+          </a:xfrm>
+          <a:prstGeom prst="rect">
+            <a:avLst/>
+          </a:prstGeom>
+          <a:noFill/>
+        </p:spPr>
+        <p:txBody>
+          <a:bodyPr wrap="square" anchor="t" lIns="0" rIns="0" tIns="0" bIns="0">
+            <a:spAutoFit/>
+          </a:bodyPr>
+          <a:lstStyle/>
+          <a:p>
+            <a:pPr algn="l">
+              <a:lnSpc>
+                <a:spcPct val="120000"/>
+              </a:lnSpc>
+              <a:spcBef>
+                <a:spcPts val="0"/>
+              </a:spcBef>
+            </a:pPr>
+            <a:r>
+              <a:rPr sz="900" b="0" i="0">
+                <a:solidFill>
+                  <a:srgbClr val="1E3652"/>
+                </a:solidFill>
+                <a:latin typeface="Helvetica Neue"/>
+              </a:rPr>
+              <a:t>-  decidable without a reference</a:t>
+            </a:r>
+          </a:p>
+          <a:p>
+            <a:pPr algn="l">
+              <a:lnSpc>
+                <a:spcPct val="120000"/>
+              </a:lnSpc>
+              <a:spcBef>
+                <a:spcPts val="700"/>
+              </a:spcBef>
+            </a:pPr>
+            <a:r>
+              <a:rPr sz="900" b="0" i="0">
+                <a:solidFill>
+                  <a:srgbClr val="1E3652"/>
+                </a:solidFill>
+                <a:latin typeface="Helvetica Neue"/>
+              </a:rPr>
+              <a:t>-  deterministic: same file, same number</a:t>
+            </a:r>
+          </a:p>
+          <a:p>
+            <a:pPr algn="l">
+              <a:lnSpc>
+                <a:spcPct val="120000"/>
+              </a:lnSpc>
+              <a:spcBef>
+                <a:spcPts val="700"/>
+              </a:spcBef>
+            </a:pPr>
+            <a:r>
+              <a:rPr sz="900" b="0" i="0">
+                <a:solidFill>
+                  <a:srgbClr val="1E3652"/>
+                </a:solidFill>
+                <a:latin typeface="Helvetica Neue"/>
+              </a:rPr>
+              <a:t>-  a violation is worse, not different</a:t>
+            </a:r>
+          </a:p>
+          <a:p>
+            <a:pPr algn="l">
+              <a:lnSpc>
+                <a:spcPct val="120000"/>
+              </a:lnSpc>
+              <a:spcBef>
+                <a:spcPts val="700"/>
+              </a:spcBef>
+            </a:pPr>
+            <a:r>
+              <a:rPr sz="900" b="0" i="0">
+                <a:solidFill>
+                  <a:srgbClr val="1E3652"/>
+                </a:solidFill>
+                <a:latin typeface="Helvetica Neue"/>
+              </a:rPr>
+              <a:t>-  cheap enough to run in the loop</a:t>
+            </a:r>
+          </a:p>
+          <a:p>
+            <a:pPr algn="l">
+              <a:lnSpc>
+                <a:spcPct val="120000"/>
+              </a:lnSpc>
+              <a:spcBef>
+                <a:spcPts val="700"/>
+              </a:spcBef>
+            </a:pPr>
+            <a:r>
+              <a:rPr sz="900" b="0" i="0">
+                <a:solidFill>
+                  <a:srgbClr val="1E3652"/>
+                </a:solidFill>
+                <a:latin typeface="Helvetica Neue"/>
+              </a:rPr>
+              <a:t>-  explainable: shape, value, threshold</a:t>
+            </a:r>
+          </a:p>
+        </p:txBody>
+      </p:sp>
+      <p:sp>
+        <p:nvSpPr>
+          <p:cNvPr id="11" name="TextBox 10"/>
+          <p:cNvSpPr txBox="1"/>
+          <p:nvPr/>
+        </p:nvSpPr>
+        <p:spPr>
+          <a:xfrm>
+            <a:off x="7909560" y="1691640"/>
+            <a:ext cx="3429000" cy="320040"/>
+          </a:xfrm>
+          <a:prstGeom prst="rect">
+            <a:avLst/>
+          </a:prstGeom>
+          <a:noFill/>
+        </p:spPr>
+        <p:txBody>
+          <a:bodyPr wrap="square" anchor="t" lIns="0" rIns="0" tIns="0" bIns="0">
+            <a:spAutoFit/>
+          </a:bodyPr>
+          <a:lstStyle/>
+          <a:p>
+            <a:pPr algn="l">
+              <a:lnSpc>
+                <a:spcPct val="115000"/>
+              </a:lnSpc>
+              <a:spcBef>
+                <a:spcPts val="0"/>
+              </a:spcBef>
+            </a:pPr>
+            <a:r>
+              <a:rPr sz="1100" b="1" i="0">
+                <a:solidFill>
+                  <a:srgbClr val="10233A"/>
+                </a:solidFill>
+                <a:latin typeface="Helvetica Neue"/>
+              </a:rPr>
+              <a:t>What survives</a:t>
+            </a:r>
+          </a:p>
+        </p:txBody>
+      </p:sp>
+      <p:graphicFrame>
+        <p:nvGraphicFramePr>
+          <p:cNvPr id="12" name="Table 11"/>
+          <p:cNvGraphicFramePr>
+            <a:graphicFrameLocks noGrp="1"/>
+          </p:cNvGraphicFramePr>
+          <p:nvPr/>
+        </p:nvGraphicFramePr>
+        <p:xfrm>
+          <a:off x="7909560" y="2057400"/>
+          <a:ext cx="3429000" cy="2121408"/>
+        </p:xfrm>
+        <a:graphic>
+          <a:graphicData uri="http://schemas.openxmlformats.org/drawingml/2006/table">
+            <a:tbl>
+              <a:tblPr firstRow="1" bandRow="1">
+                <a:tableStyleId>{5C22544A-7EE6-4342-B048-85BDC9FD1C3A}</a:tableStyleId>
+              </a:tblPr>
+              <a:tblGrid>
+                <a:gridCol w="2606040"/>
+                <a:gridCol w="822960"/>
+              </a:tblGrid>
+              <a:tr h="310896">
+                <a:tc>
+                  <a:txBody>
+                    <a:bodyPr wrap="square"/>
+                    <a:lstStyle/>
+                    <a:p>
+                      <a:pPr algn="l">
+                        <a:lnSpc>
+                          <a:spcPct val="115000"/>
+                        </a:lnSpc>
+                        <a:spcBef>
+                          <a:spcPts val="0"/>
+                        </a:spcBef>
+                      </a:pPr>
+                      <a:r>
+                        <a:rPr sz="900" b="1" i="0">
+                          <a:solidFill>
+                            <a:srgbClr val="10233A"/>
+                          </a:solidFill>
+                          <a:latin typeface="Helvetica Neue"/>
+                        </a:rPr>
+                        <a:t>gate</a:t>
                       </a:r>
                     </a:p>
                   </a:txBody>
@@ -15013,13 +16716,13 @@
                         </a:spcBef>
                       </a:pPr>
                       <a:r>
-                        <a:rPr sz="950" b="1" i="0">
+                        <a:rPr sz="900" b="1" i="0">
                           <a:solidFill>
                             <a:srgbClr val="10233A"/>
                           </a:solidFill>
                           <a:latin typeface="Helvetica Neue"/>
                         </a:rPr>
-                        <a:t>DOC2PPT</a:t>
+                        <a:t>from</a:t>
                       </a:r>
                     </a:p>
                   </a:txBody>
@@ -15045,13 +16748,13 @@
                         </a:spcBef>
                       </a:pPr>
                       <a:r>
-                        <a:rPr sz="1000" b="1" i="0">
+                        <a:rPr sz="950" b="1" i="0">
                           <a:solidFill>
                             <a:srgbClr val="10233A"/>
                           </a:solidFill>
                           <a:latin typeface="Helvetica Neue"/>
                         </a:rPr>
-                        <a:t>slides</a:t>
+                        <a:t>G1 containment</a:t>
                       </a:r>
                     </a:p>
                   </a:txBody>
@@ -15075,43 +16778,13 @@
                         </a:spcBef>
                       </a:pPr>
                       <a:r>
-                        <a:rPr sz="1000" b="0" i="0">
+                        <a:rPr sz="950" b="0" i="0">
                           <a:solidFill>
                             <a:srgbClr val="1E3652"/>
                           </a:solidFill>
                           <a:latin typeface="Helvetica Neue"/>
                         </a:rPr>
-                        <a:t>9</a:t>
-                      </a:r>
-                    </a:p>
-                  </a:txBody>
-                  <a:tcPr marL="73152" marT="36576" marB="36576">
-                    <a:solidFill>
-                      <a:srgbClr val="FFFFFF"/>
-                    </a:solidFill>
-                  </a:tcPr>
-                </a:tc>
-                <a:tc>
-                  <a:txBody>
-                    <a:bodyPr wrap="square"/>
-                    <a:lstStyle/>
-                    <a:p>
-                      <a:pPr algn="l">
-                        <a:lnSpc>
-                          <a:spcPct val="110000"/>
-                        </a:lnSpc>
-                        <a:spcBef>
-                          <a:spcPts val="0"/>
-                        </a:spcBef>
-                      </a:pPr>
-                      <a:r>
-                        <a:rPr sz="1000" b="0" i="0">
-                          <a:solidFill>
-                            <a:srgbClr val="1E3652"/>
-                          </a:solidFill>
-                          <a:latin typeface="Helvetica Neue"/>
-                        </a:rPr>
-                        <a:t>9</a:t>
+                        <a:t>A1</a:t>
                       </a:r>
                     </a:p>
                   </a:txBody>
@@ -15137,13 +16810,13 @@
                         </a:spcBef>
                       </a:pPr>
                       <a:r>
-                        <a:rPr sz="1000" b="1" i="0">
+                        <a:rPr sz="950" b="1" i="0">
                           <a:solidFill>
                             <a:srgbClr val="10233A"/>
                           </a:solidFill>
                           <a:latin typeface="Helvetica Neue"/>
                         </a:rPr>
-                        <a:t>clean slides</a:t>
+                        <a:t>G2 overlap</a:t>
                       </a:r>
                     </a:p>
                   </a:txBody>
@@ -15167,43 +16840,13 @@
                         </a:spcBef>
                       </a:pPr>
                       <a:r>
-                        <a:rPr sz="1000" b="0" i="0">
+                        <a:rPr sz="950" b="0" i="0">
                           <a:solidFill>
                             <a:srgbClr val="1E3652"/>
                           </a:solidFill>
                           <a:latin typeface="Helvetica Neue"/>
                         </a:rPr>
-                        <a:t>0</a:t>
-                      </a:r>
-                    </a:p>
-                  </a:txBody>
-                  <a:tcPr marL="73152" marT="36576" marB="36576">
-                    <a:solidFill>
-                      <a:srgbClr val="FFFFFF"/>
-                    </a:solidFill>
-                  </a:tcPr>
-                </a:tc>
-                <a:tc>
-                  <a:txBody>
-                    <a:bodyPr wrap="square"/>
-                    <a:lstStyle/>
-                    <a:p>
-                      <a:pPr algn="l">
-                        <a:lnSpc>
-                          <a:spcPct val="110000"/>
-                        </a:lnSpc>
-                        <a:spcBef>
-                          <a:spcPts val="0"/>
-                        </a:spcBef>
-                      </a:pPr>
-                      <a:r>
-                        <a:rPr sz="1000" b="0" i="0">
-                          <a:solidFill>
-                            <a:srgbClr val="1E3652"/>
-                          </a:solidFill>
-                          <a:latin typeface="Helvetica Neue"/>
-                        </a:rPr>
-                        <a:t>0</a:t>
+                        <a:t>A2</a:t>
                       </a:r>
                     </a:p>
                   </a:txBody>
@@ -15229,13 +16872,13 @@
                         </a:spcBef>
                       </a:pPr>
                       <a:r>
-                        <a:rPr sz="1000" b="1" i="0">
+                        <a:rPr sz="950" b="1" i="0">
                           <a:solidFill>
                             <a:srgbClr val="10233A"/>
                           </a:solidFill>
                           <a:latin typeface="Helvetica Neue"/>
                         </a:rPr>
-                        <a:t>SRR (slide-level)</a:t>
+                        <a:t>G3 font size</a:t>
                       </a:r>
                     </a:p>
                   </a:txBody>
@@ -15259,43 +16902,13 @@
                         </a:spcBef>
                       </a:pPr>
                       <a:r>
-                        <a:rPr sz="1000" b="0" i="0">
+                        <a:rPr sz="950" b="0" i="0">
                           <a:solidFill>
                             <a:srgbClr val="1E3652"/>
                           </a:solidFill>
                           <a:latin typeface="Helvetica Neue"/>
                         </a:rPr>
-                        <a:t>0.00</a:t>
-                      </a:r>
-                    </a:p>
-                  </a:txBody>
-                  <a:tcPr marL="73152" marT="36576" marB="36576">
-                    <a:solidFill>
-                      <a:srgbClr val="FFFFFF"/>
-                    </a:solidFill>
-                  </a:tcPr>
-                </a:tc>
-                <a:tc>
-                  <a:txBody>
-                    <a:bodyPr wrap="square"/>
-                    <a:lstStyle/>
-                    <a:p>
-                      <a:pPr algn="l">
-                        <a:lnSpc>
-                          <a:spcPct val="110000"/>
-                        </a:lnSpc>
-                        <a:spcBef>
-                          <a:spcPts val="0"/>
-                        </a:spcBef>
-                      </a:pPr>
-                      <a:r>
-                        <a:rPr sz="1000" b="0" i="0">
-                          <a:solidFill>
-                            <a:srgbClr val="1E3652"/>
-                          </a:solidFill>
-                          <a:latin typeface="Helvetica Neue"/>
-                        </a:rPr>
-                        <a:t>0.00</a:t>
+                        <a:t>B1</a:t>
                       </a:r>
                     </a:p>
                   </a:txBody>
@@ -15321,13 +16934,13 @@
                         </a:spcBef>
                       </a:pPr>
                       <a:r>
-                        <a:rPr sz="1000" b="1" i="0">
+                        <a:rPr sz="950" b="1" i="0">
                           <a:solidFill>
                             <a:srgbClr val="10233A"/>
                           </a:solidFill>
                           <a:latin typeface="Helvetica Neue"/>
                         </a:rPr>
-                        <a:t>violations</a:t>
+                        <a:t>G4 contrast</a:t>
                       </a:r>
                     </a:p>
                   </a:txBody>
@@ -15351,43 +16964,13 @@
                         </a:spcBef>
                       </a:pPr>
                       <a:r>
-                        <a:rPr sz="1000" b="0" i="0">
+                        <a:rPr sz="950" b="0" i="0">
                           <a:solidFill>
                             <a:srgbClr val="1E3652"/>
                           </a:solidFill>
                           <a:latin typeface="Helvetica Neue"/>
                         </a:rPr>
-                        <a:t>33</a:t>
-                      </a:r>
-                    </a:p>
-                  </a:txBody>
-                  <a:tcPr marL="73152" marT="36576" marB="36576">
-                    <a:solidFill>
-                      <a:srgbClr val="FFFFFF"/>
-                    </a:solidFill>
-                  </a:tcPr>
-                </a:tc>
-                <a:tc>
-                  <a:txBody>
-                    <a:bodyPr wrap="square"/>
-                    <a:lstStyle/>
-                    <a:p>
-                      <a:pPr algn="l">
-                        <a:lnSpc>
-                          <a:spcPct val="110000"/>
-                        </a:lnSpc>
-                        <a:spcBef>
-                          <a:spcPts val="0"/>
-                        </a:spcBef>
-                      </a:pPr>
-                      <a:r>
-                        <a:rPr sz="1000" b="0" i="0">
-                          <a:solidFill>
-                            <a:srgbClr val="1E3652"/>
-                          </a:solidFill>
-                          <a:latin typeface="Helvetica Neue"/>
-                        </a:rPr>
-                        <a:t>32</a:t>
+                        <a:t>C1</a:t>
                       </a:r>
                     </a:p>
                   </a:txBody>
@@ -15413,13 +16996,13 @@
                         </a:spcBef>
                       </a:pPr>
                       <a:r>
-                        <a:rPr sz="1000" b="1" i="0">
+                        <a:rPr sz="950" b="1" i="0">
                           <a:solidFill>
                             <a:srgbClr val="10233A"/>
                           </a:solidFill>
                           <a:latin typeface="Helvetica Neue"/>
                         </a:rPr>
-                        <a:t>slides failing G3</a:t>
+                        <a:t>G5 text fit</a:t>
                       </a:r>
                     </a:p>
                   </a:txBody>
@@ -15443,43 +17026,13 @@
                         </a:spcBef>
                       </a:pPr>
                       <a:r>
-                        <a:rPr sz="1000" b="0" i="0">
+                        <a:rPr sz="950" b="0" i="0">
                           <a:solidFill>
                             <a:srgbClr val="1E3652"/>
                           </a:solidFill>
                           <a:latin typeface="Helvetica Neue"/>
                         </a:rPr>
-                        <a:t>9 / 9</a:t>
-                      </a:r>
-                    </a:p>
-                  </a:txBody>
-                  <a:tcPr marL="73152" marT="36576" marB="36576">
-                    <a:solidFill>
-                      <a:srgbClr val="FFFFFF"/>
-                    </a:solidFill>
-                  </a:tcPr>
-                </a:tc>
-                <a:tc>
-                  <a:txBody>
-                    <a:bodyPr wrap="square"/>
-                    <a:lstStyle/>
-                    <a:p>
-                      <a:pPr algn="l">
-                        <a:lnSpc>
-                          <a:spcPct val="110000"/>
-                        </a:lnSpc>
-                        <a:spcBef>
-                          <a:spcPts val="0"/>
-                        </a:spcBef>
-                      </a:pPr>
-                      <a:r>
-                        <a:rPr sz="1000" b="0" i="0">
-                          <a:solidFill>
-                            <a:srgbClr val="1E3652"/>
-                          </a:solidFill>
-                          <a:latin typeface="Helvetica Neue"/>
-                        </a:rPr>
-                        <a:t>9 / 9</a:t>
+                        <a:t>B7</a:t>
                       </a:r>
                     </a:p>
                   </a:txBody>
@@ -15505,13 +17058,13 @@
                         </a:spcBef>
                       </a:pPr>
                       <a:r>
-                        <a:rPr sz="1000" b="1" i="0">
+                        <a:rPr sz="950" b="1" i="0">
                           <a:solidFill>
                             <a:srgbClr val="10233A"/>
                           </a:solidFill>
                           <a:latin typeface="Helvetica Neue"/>
                         </a:rPr>
-                        <a:t>slides failing G6</a:t>
+                        <a:t>G6 density</a:t>
                       </a:r>
                     </a:p>
                   </a:txBody>
@@ -15535,43 +17088,13 @@
                         </a:spcBef>
                       </a:pPr>
                       <a:r>
-                        <a:rPr sz="1000" b="0" i="0">
+                        <a:rPr sz="950" b="0" i="0">
                           <a:solidFill>
                             <a:srgbClr val="1E3652"/>
                           </a:solidFill>
                           <a:latin typeface="Helvetica Neue"/>
                         </a:rPr>
-                        <a:t>8 / 9</a:t>
-                      </a:r>
-                    </a:p>
-                  </a:txBody>
-                  <a:tcPr marL="73152" marT="36576" marB="36576">
-                    <a:solidFill>
-                      <a:srgbClr val="FFFFFF"/>
-                    </a:solidFill>
-                  </a:tcPr>
-                </a:tc>
-                <a:tc>
-                  <a:txBody>
-                    <a:bodyPr wrap="square"/>
-                    <a:lstStyle/>
-                    <a:p>
-                      <a:pPr algn="l">
-                        <a:lnSpc>
-                          <a:spcPct val="110000"/>
-                        </a:lnSpc>
-                        <a:spcBef>
-                          <a:spcPts val="0"/>
-                        </a:spcBef>
-                      </a:pPr>
-                      <a:r>
-                        <a:rPr sz="1000" b="0" i="0">
-                          <a:solidFill>
-                            <a:srgbClr val="1E3652"/>
-                          </a:solidFill>
-                          <a:latin typeface="Helvetica Neue"/>
-                        </a:rPr>
-                        <a:t>8 / 9</a:t>
+                        <a:t>B5+B6</a:t>
                       </a:r>
                     </a:p>
                   </a:txBody>
@@ -15588,14 +17111,74 @@
       </p:graphicFrame>
       <p:sp>
         <p:nvSpPr>
-          <p:cNvPr id="11" name="TextBox 10"/>
+          <p:cNvPr id="13" name="Rectangle 12"/>
+          <p:cNvSpPr/>
+          <p:nvPr/>
+        </p:nvSpPr>
+        <p:spPr>
+          <a:xfrm>
+            <a:off x="868680" y="5074920"/>
+            <a:ext cx="10881360" cy="1051560"/>
+          </a:xfrm>
+          <a:prstGeom prst="rect">
+            <a:avLst/>
+          </a:prstGeom>
+          <a:solidFill>
+            <a:srgbClr val="ECF1F5"/>
+          </a:solidFill>
+          <a:ln>
+            <a:noFill/>
+          </a:ln>
+          <a:effectLst/>
+        </p:spPr>
+        <p:txBody>
+          <a:bodyPr rtlCol="0" anchor="ctr" wrap="square"/>
+          <a:lstStyle/>
+          <a:p>
+            <a:pPr algn="ctr"/>
+          </a:p>
+        </p:txBody>
+      </p:sp>
+      <p:sp>
+        <p:nvSpPr>
+          <p:cNvPr id="14" name="Rectangle 13"/>
+          <p:cNvSpPr/>
+          <p:nvPr/>
+        </p:nvSpPr>
+        <p:spPr>
+          <a:xfrm>
+            <a:off x="868680" y="5074920"/>
+            <a:ext cx="64008" cy="1051560"/>
+          </a:xfrm>
+          <a:prstGeom prst="rect">
+            <a:avLst/>
+          </a:prstGeom>
+          <a:solidFill>
+            <a:srgbClr val="A83542"/>
+          </a:solidFill>
+          <a:ln>
+            <a:noFill/>
+          </a:ln>
+          <a:effectLst/>
+        </p:spPr>
+        <p:txBody>
+          <a:bodyPr rtlCol="0" anchor="ctr" wrap="square"/>
+          <a:lstStyle/>
+          <a:p>
+            <a:pPr algn="ctr"/>
+          </a:p>
+        </p:txBody>
+      </p:sp>
+      <p:sp>
+        <p:nvSpPr>
+          <p:cNvPr id="15" name="TextBox 14"/>
           <p:cNvSpPr txBox="1"/>
           <p:nvPr/>
         </p:nvSpPr>
         <p:spPr>
           <a:xfrm>
-            <a:off x="7452360" y="4224528"/>
-            <a:ext cx="4206240" cy="1463040"/>
+            <a:off x="1170432" y="5212080"/>
+            <a:ext cx="10332720" cy="822960"/>
           </a:xfrm>
           <a:prstGeom prst="rect">
             <a:avLst/>
@@ -15610,20 +17193,20 @@
           <a:p>
             <a:pPr algn="l">
               <a:lnSpc>
-                <a:spcPct val="135000"/>
+                <a:spcPct val="130000"/>
               </a:lnSpc>
               <a:spcBef>
                 <a:spcPts val="0"/>
               </a:spcBef>
             </a:pPr>
             <a:r>
-              <a:rPr sz="1000" b="0" i="0">
-                <a:solidFill>
-                  <a:srgbClr val="1E3652"/>
+              <a:rPr sz="1100" b="0" i="0">
+                <a:solidFill>
+                  <a:srgbClr val="10233A"/>
                 </a:solidFill>
                 <a:latin typeface="Helvetica Neue"/>
               </a:rPr>
-              <a:t>This is the expected result, not a defect: the baseline generator ignores every gate. What matters is that the number is reproducible and the violations are named.</a:t>
+              <a:t>And what it cannot see: a bullet can be grammatical, the right length, the right size - and still nonsense. That is the boundary of a mechanical metric, and it belongs to the human study.</a:t>
             </a:r>
           </a:p>
         </p:txBody>

</xml_diff>

<commit_message>
spec: formal SRR, and slide 8 now states it
Three corrections to the draft formulation:
- averaging slide-level ratios is a macro average, which gives a two-check
  title slide the same weight as a six-check content slide; the primary number
  is the check-level micro average, matching 'equal weight per check'
- the |J|=0 fallback is unnecessary under the micro average, and 0 would
  punish a blank slide before G0 catches it
- deck-ready requiring |J_s| = |G| on every slide is never satisfiable (every
  deck has a title slide); it now requires no failure anywhere and every gate
  judged at least once, which introduces no new free parameter

Also adds the per-gate decomposition (the attribution the thesis needs), the
sweep form SRR(theta) over threshold ranges, and the na/unknown reason codes.
</commit_message>
<xml_diff>
--- a/deck/progress_deck.pptx
+++ b/deck/progress_deck.pptx
@@ -14533,7 +14533,7 @@
         </p:nvGraphicFramePr>
         <p:xfrm>
           <a:off x="868680" y="1691640"/>
-          <a:ext cx="6949440" cy="2615184"/>
+          <a:ext cx="6812280" cy="2615184"/>
         </p:xfrm>
         <a:graphic>
           <a:graphicData uri="http://schemas.openxmlformats.org/drawingml/2006/table">
@@ -14542,9 +14542,9 @@
                 <a:tableStyleId>{5C22544A-7EE6-4342-B048-85BDC9FD1C3A}</a:tableStyleId>
               </a:tblPr>
               <a:tblGrid>
-                <a:gridCol w="1737360"/>
-                <a:gridCol w="3017520"/>
-                <a:gridCol w="1097280"/>
+                <a:gridCol w="1691640"/>
+                <a:gridCol w="2971800"/>
+                <a:gridCol w="1051560"/>
                 <a:gridCol w="1097280"/>
               </a:tblGrid>
               <a:tr h="310896">
@@ -14562,7 +14562,7 @@
                         </a:spcBef>
                       </a:pPr>
                       <a:r>
-                        <a:rPr sz="1000" b="1" i="0">
+                        <a:rPr sz="960" b="1" i="0">
                           <a:solidFill>
                             <a:srgbClr val="10233A"/>
                           </a:solidFill>
@@ -14592,7 +14592,7 @@
                         </a:spcBef>
                       </a:pPr>
                       <a:r>
-                        <a:rPr sz="1000" b="1" i="0">
+                        <a:rPr sz="960" b="1" i="0">
                           <a:solidFill>
                             <a:srgbClr val="10233A"/>
                           </a:solidFill>
@@ -14622,7 +14622,7 @@
                         </a:spcBef>
                       </a:pPr>
                       <a:r>
-                        <a:rPr sz="1000" b="1" i="0">
+                        <a:rPr sz="960" b="1" i="0">
                           <a:solidFill>
                             <a:srgbClr val="10233A"/>
                           </a:solidFill>
@@ -14652,7 +14652,7 @@
                         </a:spcBef>
                       </a:pPr>
                       <a:r>
-                        <a:rPr sz="1000" b="1" i="0">
+                        <a:rPr sz="960" b="1" i="0">
                           <a:solidFill>
                             <a:srgbClr val="10233A"/>
                           </a:solidFill>
@@ -14684,7 +14684,7 @@
                         </a:spcBef>
                       </a:pPr>
                       <a:r>
-                        <a:rPr sz="1000" b="1" i="0">
+                        <a:rPr sz="960" b="1" i="0">
                           <a:solidFill>
                             <a:srgbClr val="10233A"/>
                           </a:solidFill>
@@ -14714,7 +14714,7 @@
                         </a:spcBef>
                       </a:pPr>
                       <a:r>
-                        <a:rPr sz="1000" b="0" i="0">
+                        <a:rPr sz="960" b="0" i="0">
                           <a:solidFill>
                             <a:srgbClr val="1E3652"/>
                           </a:solidFill>
@@ -14744,7 +14744,7 @@
                         </a:spcBef>
                       </a:pPr>
                       <a:r>
-                        <a:rPr sz="1000" b="0" i="0">
+                        <a:rPr sz="960" b="0" i="0">
                           <a:solidFill>
                             <a:srgbClr val="1E3652"/>
                           </a:solidFill>
@@ -14774,7 +14774,7 @@
                         </a:spcBef>
                       </a:pPr>
                       <a:r>
-                        <a:rPr sz="1000" b="1" i="0">
+                        <a:rPr sz="960" b="1" i="0">
                           <a:solidFill>
                             <a:srgbClr val="2F7D5D"/>
                           </a:solidFill>
@@ -14806,7 +14806,7 @@
                         </a:spcBef>
                       </a:pPr>
                       <a:r>
-                        <a:rPr sz="1000" b="1" i="0">
+                        <a:rPr sz="960" b="1" i="0">
                           <a:solidFill>
                             <a:srgbClr val="10233A"/>
                           </a:solidFill>
@@ -14836,7 +14836,7 @@
                         </a:spcBef>
                       </a:pPr>
                       <a:r>
-                        <a:rPr sz="1000" b="0" i="0">
+                        <a:rPr sz="960" b="0" i="0">
                           <a:solidFill>
                             <a:srgbClr val="1E3652"/>
                           </a:solidFill>
@@ -14866,7 +14866,7 @@
                         </a:spcBef>
                       </a:pPr>
                       <a:r>
-                        <a:rPr sz="1000" b="0" i="0">
+                        <a:rPr sz="960" b="0" i="0">
                           <a:solidFill>
                             <a:srgbClr val="1E3652"/>
                           </a:solidFill>
@@ -14896,7 +14896,7 @@
                         </a:spcBef>
                       </a:pPr>
                       <a:r>
-                        <a:rPr sz="1000" b="1" i="0">
+                        <a:rPr sz="960" b="1" i="0">
                           <a:solidFill>
                             <a:srgbClr val="2F7D5D"/>
                           </a:solidFill>
@@ -14928,7 +14928,7 @@
                         </a:spcBef>
                       </a:pPr>
                       <a:r>
-                        <a:rPr sz="1000" b="1" i="0">
+                        <a:rPr sz="960" b="1" i="0">
                           <a:solidFill>
                             <a:srgbClr val="10233A"/>
                           </a:solidFill>
@@ -14958,7 +14958,7 @@
                         </a:spcBef>
                       </a:pPr>
                       <a:r>
-                        <a:rPr sz="1000" b="0" i="0">
+                        <a:rPr sz="960" b="0" i="0">
                           <a:solidFill>
                             <a:srgbClr val="1E3652"/>
                           </a:solidFill>
@@ -14988,7 +14988,7 @@
                         </a:spcBef>
                       </a:pPr>
                       <a:r>
-                        <a:rPr sz="1000" b="0" i="0">
+                        <a:rPr sz="960" b="0" i="0">
                           <a:solidFill>
                             <a:srgbClr val="1E3652"/>
                           </a:solidFill>
@@ -15018,7 +15018,7 @@
                         </a:spcBef>
                       </a:pPr>
                       <a:r>
-                        <a:rPr sz="1000" b="1" i="0">
+                        <a:rPr sz="960" b="1" i="0">
                           <a:solidFill>
                             <a:srgbClr val="B07A1E"/>
                           </a:solidFill>
@@ -15050,7 +15050,7 @@
                         </a:spcBef>
                       </a:pPr>
                       <a:r>
-                        <a:rPr sz="1000" b="1" i="0">
+                        <a:rPr sz="960" b="1" i="0">
                           <a:solidFill>
                             <a:srgbClr val="10233A"/>
                           </a:solidFill>
@@ -15080,7 +15080,7 @@
                         </a:spcBef>
                       </a:pPr>
                       <a:r>
-                        <a:rPr sz="1000" b="0" i="0">
+                        <a:rPr sz="960" b="0" i="0">
                           <a:solidFill>
                             <a:srgbClr val="1E3652"/>
                           </a:solidFill>
@@ -15110,7 +15110,7 @@
                         </a:spcBef>
                       </a:pPr>
                       <a:r>
-                        <a:rPr sz="1000" b="0" i="0">
+                        <a:rPr sz="960" b="0" i="0">
                           <a:solidFill>
                             <a:srgbClr val="1E3652"/>
                           </a:solidFill>
@@ -15140,7 +15140,7 @@
                         </a:spcBef>
                       </a:pPr>
                       <a:r>
-                        <a:rPr sz="1000" b="1" i="0">
+                        <a:rPr sz="960" b="1" i="0">
                           <a:solidFill>
                             <a:srgbClr val="B07A1E"/>
                           </a:solidFill>
@@ -15172,7 +15172,7 @@
                         </a:spcBef>
                       </a:pPr>
                       <a:r>
-                        <a:rPr sz="1000" b="1" i="0">
+                        <a:rPr sz="960" b="1" i="0">
                           <a:solidFill>
                             <a:srgbClr val="10233A"/>
                           </a:solidFill>
@@ -15202,7 +15202,7 @@
                         </a:spcBef>
                       </a:pPr>
                       <a:r>
-                        <a:rPr sz="1000" b="0" i="0">
+                        <a:rPr sz="960" b="0" i="0">
                           <a:solidFill>
                             <a:srgbClr val="1E3652"/>
                           </a:solidFill>
@@ -15232,7 +15232,7 @@
                         </a:spcBef>
                       </a:pPr>
                       <a:r>
-                        <a:rPr sz="1000" b="0" i="0">
+                        <a:rPr sz="960" b="0" i="0">
                           <a:solidFill>
                             <a:srgbClr val="1E3652"/>
                           </a:solidFill>
@@ -15262,7 +15262,7 @@
                         </a:spcBef>
                       </a:pPr>
                       <a:r>
-                        <a:rPr sz="1000" b="1" i="0">
+                        <a:rPr sz="960" b="1" i="0">
                           <a:solidFill>
                             <a:srgbClr val="A83542"/>
                           </a:solidFill>
@@ -15294,7 +15294,7 @@
                         </a:spcBef>
                       </a:pPr>
                       <a:r>
-                        <a:rPr sz="1000" b="1" i="0">
+                        <a:rPr sz="960" b="1" i="0">
                           <a:solidFill>
                             <a:srgbClr val="10233A"/>
                           </a:solidFill>
@@ -15324,7 +15324,7 @@
                         </a:spcBef>
                       </a:pPr>
                       <a:r>
-                        <a:rPr sz="1000" b="0" i="0">
+                        <a:rPr sz="960" b="0" i="0">
                           <a:solidFill>
                             <a:srgbClr val="1E3652"/>
                           </a:solidFill>
@@ -15354,7 +15354,7 @@
                         </a:spcBef>
                       </a:pPr>
                       <a:r>
-                        <a:rPr sz="1000" b="0" i="0">
+                        <a:rPr sz="960" b="0" i="0">
                           <a:solidFill>
                             <a:srgbClr val="1E3652"/>
                           </a:solidFill>
@@ -15384,7 +15384,7 @@
                         </a:spcBef>
                       </a:pPr>
                       <a:r>
-                        <a:rPr sz="1000" b="1" i="0">
+                        <a:rPr sz="960" b="1" i="0">
                           <a:solidFill>
                             <a:srgbClr val="A83542"/>
                           </a:solidFill>
@@ -15413,8 +15413,8 @@
         </p:nvSpPr>
         <p:spPr>
           <a:xfrm>
-            <a:off x="8092440" y="1691640"/>
-            <a:ext cx="3611880" cy="1417320"/>
+            <a:off x="7818120" y="1691640"/>
+            <a:ext cx="3520440" cy="1755648"/>
           </a:xfrm>
           <a:prstGeom prst="rect">
             <a:avLst/>
@@ -15443,8 +15443,8 @@
         </p:nvSpPr>
         <p:spPr>
           <a:xfrm>
-            <a:off x="8321040" y="1847088"/>
-            <a:ext cx="3200400" cy="1097280"/>
+            <a:off x="8046720" y="1810512"/>
+            <a:ext cx="3108960" cy="1554480"/>
           </a:xfrm>
           <a:prstGeom prst="rect">
             <a:avLst/>
@@ -15466,7 +15466,7 @@
               </a:spcBef>
             </a:pPr>
             <a:r>
-              <a:rPr sz="1600" b="1" i="0">
+              <a:rPr sz="1500" b="1" i="0">
                 <a:solidFill>
                   <a:srgbClr val="10233A"/>
                 </a:solidFill>
@@ -15478,20 +15478,39 @@
           <a:p>
             <a:pPr algn="l">
               <a:lnSpc>
-                <a:spcPct val="130000"/>
+                <a:spcPct val="115000"/>
               </a:lnSpc>
               <a:spcBef>
-                <a:spcPts val="600"/>
+                <a:spcPts val="500"/>
               </a:spcBef>
             </a:pPr>
             <a:r>
-              <a:rPr sz="1000" b="0" i="0">
-                <a:solidFill>
-                  <a:srgbClr val="1E3652"/>
+              <a:rPr sz="1250" b="0" i="0">
+                <a:solidFill>
+                  <a:srgbClr val="10233A"/>
                 </a:solidFill>
                 <a:latin typeface="Helvetica Neue"/>
               </a:rPr>
-              <a:t>Equal-weight pass rate over decidable checks. No gate weight is fitted; unknown checks leave the average but block deck-ready.</a:t>
+              <a:t>SRR = Σ P / Σ J</a:t>
+            </a:r>
+          </a:p>
+          <a:p>
+            <a:pPr algn="l">
+              <a:lnSpc>
+                <a:spcPct val="125000"/>
+              </a:lnSpc>
+              <a:spcBef>
+                <a:spcPts val="500"/>
+              </a:spcBef>
+            </a:pPr>
+            <a:r>
+              <a:rPr sz="840" b="0" i="0">
+                <a:solidFill>
+                  <a:srgbClr val="1E3652"/>
+                </a:solidFill>
+                <a:latin typeface="Helvetica Neue"/>
+              </a:rPr>
+              <a:t>J = checks that could be judged, P = those that passed. One weight per check; none is fitted.</a:t>
             </a:r>
           </a:p>
         </p:txBody>
@@ -15504,8 +15523,8 @@
         </p:nvSpPr>
         <p:spPr>
           <a:xfrm>
-            <a:off x="8092440" y="3291840"/>
-            <a:ext cx="3611880" cy="1417320"/>
+            <a:off x="7818120" y="3584448"/>
+            <a:ext cx="3520440" cy="1371600"/>
           </a:xfrm>
           <a:prstGeom prst="rect">
             <a:avLst/>
@@ -15534,8 +15553,8 @@
         </p:nvSpPr>
         <p:spPr>
           <a:xfrm>
-            <a:off x="8321040" y="3447288"/>
-            <a:ext cx="3200400" cy="1097280"/>
+            <a:off x="8046720" y="3694176"/>
+            <a:ext cx="3108960" cy="1188720"/>
           </a:xfrm>
           <a:prstGeom prst="rect">
             <a:avLst/>
@@ -15557,74 +15576,172 @@
               </a:spcBef>
             </a:pPr>
             <a:r>
-              <a:rPr sz="1300" b="1" i="0">
+              <a:rPr sz="1050" b="1" i="0">
                 <a:solidFill>
                   <a:srgbClr val="10233A"/>
                 </a:solidFill>
                 <a:latin typeface="Helvetica Neue"/>
               </a:rPr>
-              <a:t>Why no weights</a:t>
-            </a:r>
-          </a:p>
+              <a:t>unknown is not n/a</a:t>
+            </a:r>
+          </a:p>
+          <a:p>
+            <a:pPr algn="l">
+              <a:lnSpc>
+                <a:spcPct val="120000"/>
+              </a:lnSpc>
+              <a:spcBef>
+                <a:spcPts val="400"/>
+              </a:spcBef>
+            </a:pPr>
+            <a:r>
+              <a:rPr sz="819" b="0" i="0">
+                <a:solidFill>
+                  <a:srgbClr val="1E3652"/>
+                </a:solidFill>
+                <a:latin typeface="Helvetica Neue"/>
+              </a:rPr>
+              <a:t>n/a: does not apply - one text box, so no G2 pair</a:t>
+            </a:r>
+          </a:p>
+          <a:p>
+            <a:pPr algn="l">
+              <a:lnSpc>
+                <a:spcPct val="120000"/>
+              </a:lnSpc>
+              <a:spcBef>
+                <a:spcPts val="300"/>
+              </a:spcBef>
+            </a:pPr>
+            <a:r>
+              <a:rPr sz="819" b="0" i="0">
+                <a:solidFill>
+                  <a:srgbClr val="1E3652"/>
+                </a:solidFill>
+                <a:latin typeface="Helvetica Neue"/>
+              </a:rPr>
+              <a:t>unknown: applies but cannot be computed - image background</a:t>
+            </a:r>
+          </a:p>
+          <a:p>
+            <a:pPr algn="l">
+              <a:lnSpc>
+                <a:spcPct val="120000"/>
+              </a:lnSpc>
+              <a:spcBef>
+                <a:spcPts val="300"/>
+              </a:spcBef>
+            </a:pPr>
+            <a:r>
+              <a:rPr sz="819" b="0" i="0">
+                <a:solidFill>
+                  <a:srgbClr val="5A6B7C"/>
+                </a:solidFill>
+                <a:latin typeface="Helvetica Neue"/>
+              </a:rPr>
+              <a:t>both leave the denominator, both carry a reason code</a:t>
+            </a:r>
+          </a:p>
+        </p:txBody>
+      </p:sp>
+      <p:sp>
+        <p:nvSpPr>
+          <p:cNvPr id="13" name="Rectangle 12"/>
+          <p:cNvSpPr/>
+          <p:nvPr/>
+        </p:nvSpPr>
+        <p:spPr>
+          <a:xfrm>
+            <a:off x="868680" y="5102352"/>
+            <a:ext cx="10469880" cy="841248"/>
+          </a:xfrm>
+          <a:prstGeom prst="rect">
+            <a:avLst/>
+          </a:prstGeom>
+          <a:solidFill>
+            <a:srgbClr val="ECF1F5"/>
+          </a:solidFill>
+          <a:ln>
+            <a:noFill/>
+          </a:ln>
+          <a:effectLst/>
+        </p:spPr>
+        <p:txBody>
+          <a:bodyPr rtlCol="0" anchor="ctr" wrap="square"/>
+          <a:lstStyle/>
+          <a:p>
+            <a:pPr algn="ctr"/>
+          </a:p>
+        </p:txBody>
+      </p:sp>
+      <p:sp>
+        <p:nvSpPr>
+          <p:cNvPr id="14" name="Rectangle 13"/>
+          <p:cNvSpPr/>
+          <p:nvPr/>
+        </p:nvSpPr>
+        <p:spPr>
+          <a:xfrm>
+            <a:off x="868680" y="5102352"/>
+            <a:ext cx="64008" cy="841248"/>
+          </a:xfrm>
+          <a:prstGeom prst="rect">
+            <a:avLst/>
+          </a:prstGeom>
+          <a:solidFill>
+            <a:srgbClr val="C08A2E"/>
+          </a:solidFill>
+          <a:ln>
+            <a:noFill/>
+          </a:ln>
+          <a:effectLst/>
+        </p:spPr>
+        <p:txBody>
+          <a:bodyPr rtlCol="0" anchor="ctr" wrap="square"/>
+          <a:lstStyle/>
+          <a:p>
+            <a:pPr algn="ctr"/>
+          </a:p>
+        </p:txBody>
+      </p:sp>
+      <p:sp>
+        <p:nvSpPr>
+          <p:cNvPr id="15" name="TextBox 14"/>
+          <p:cNvSpPr txBox="1"/>
+          <p:nvPr/>
+        </p:nvSpPr>
+        <p:spPr>
+          <a:xfrm>
+            <a:off x="1170432" y="5212080"/>
+            <a:ext cx="9966960" cy="685800"/>
+          </a:xfrm>
+          <a:prstGeom prst="rect">
+            <a:avLst/>
+          </a:prstGeom>
+          <a:noFill/>
+        </p:spPr>
+        <p:txBody>
+          <a:bodyPr wrap="square" anchor="t" lIns="0" rIns="0" tIns="0" bIns="0">
+            <a:spAutoFit/>
+          </a:bodyPr>
+          <a:lstStyle/>
           <a:p>
             <a:pPr algn="l">
               <a:lnSpc>
                 <a:spcPct val="130000"/>
               </a:lnSpc>
               <a:spcBef>
-                <a:spcPts val="600"/>
-              </a:spcBef>
-            </a:pPr>
-            <a:r>
-              <a:rPr sz="1000" b="0" i="0">
-                <a:solidFill>
-                  <a:srgbClr val="1E3652"/>
-                </a:solidFill>
-                <a:latin typeface="Helvetica Neue"/>
-              </a:rPr>
-              <a:t>A weight would be a number with no evidence behind it - the same objection the report makes to the 24-point rule.</a:t>
-            </a:r>
-          </a:p>
-        </p:txBody>
-      </p:sp>
-      <p:sp>
-        <p:nvSpPr>
-          <p:cNvPr id="13" name="TextBox 12"/>
-          <p:cNvSpPr txBox="1"/>
-          <p:nvPr/>
-        </p:nvSpPr>
-        <p:spPr>
-          <a:xfrm>
-            <a:off x="868680" y="4892040"/>
-            <a:ext cx="10881360" cy="1097280"/>
-          </a:xfrm>
-          <a:prstGeom prst="rect">
-            <a:avLst/>
-          </a:prstGeom>
-          <a:noFill/>
-        </p:spPr>
-        <p:txBody>
-          <a:bodyPr wrap="square" anchor="t" lIns="0" rIns="0" tIns="0" bIns="0">
-            <a:spAutoFit/>
-          </a:bodyPr>
-          <a:lstStyle/>
-          <a:p>
-            <a:pPr algn="l">
-              <a:lnSpc>
-                <a:spcPct val="135000"/>
-              </a:lnSpc>
-              <a:spcBef>
                 <a:spcPts val="0"/>
               </a:spcBef>
             </a:pPr>
             <a:r>
               <a:rPr sz="1050" b="0" i="0">
                 <a:solidFill>
-                  <a:srgbClr val="5A6B7C"/>
+                  <a:srgbClr val="10233A"/>
                 </a:solidFill>
                 <a:latin typeface="Helvetica Neue"/>
               </a:rPr>
-              <a:t>G4 and G5 are the two that need real resolution: colour has to be resolved through the theme and z-order, and text height has to be estimated from font metrics. Both are scheduled before the loop is built, because a metric that cannot be trusted cannot be the signal.</a:t>
+              <a:t>deck-ready = no failure anywhere, and every gate judged at least once. A title slide does not need G6; the deck does.</a:t>
             </a:r>
           </a:p>
         </p:txBody>

</xml_diff>

<commit_message>
clean up the dead decks, rebuild one consistent pair
Deleted six files that were superseded or scratch:
  out/t.pptx, build/t.*.json          (scratch run)
  out/DOC2PPT.pptx                    (duplicate of the dated output)
  deck/proposal_deck.pptx, _en.pptx   (21 Oct, superseded by proposal_en/zh)

Then made the numbers agree with the current code. The deck was quoting a run
from before the parser fixes: 8 sections / 24 captions / 11 figures / 32
violations, where the code now produces 12 / 25 / 13 / 40. Both decks are
regenerated, the console capture keeps its 'fail if a line is not in the log'
rule, and the results table now reads 9 vs 12 slides, 33 vs 40 violations.
</commit_message>
<xml_diff>
--- a/deck/progress_deck.pptx
+++ b/deck/progress_deck.pptx
@@ -3674,7 +3674,7 @@
                 </a:solidFill>
                 <a:latin typeface="Helvetica Neue"/>
               </a:rPr>
-              <a:t>Slide 2 of the generated deck: figure placed, caption under it</a:t>
+              <a:t>Slide 2 of the PPTAgent deck, generated by this pipeline</a:t>
             </a:r>
           </a:p>
         </p:txBody>
@@ -3875,7 +3875,7 @@
                           </a:solidFill>
                           <a:latin typeface="Helvetica Neue"/>
                         </a:rPr>
-                        <a:t>9</a:t>
+                        <a:t>12</a:t>
                       </a:r>
                     </a:p>
                   </a:txBody>
@@ -4151,7 +4151,7 @@
                           </a:solidFill>
                           <a:latin typeface="Helvetica Neue"/>
                         </a:rPr>
-                        <a:t>32</a:t>
+                        <a:t>40</a:t>
                       </a:r>
                     </a:p>
                   </a:txBody>
@@ -4243,7 +4243,7 @@
                           </a:solidFill>
                           <a:latin typeface="Helvetica Neue"/>
                         </a:rPr>
-                        <a:t>9 / 9</a:t>
+                        <a:t>12 / 12</a:t>
                       </a:r>
                     </a:p>
                   </a:txBody>
@@ -4335,7 +4335,7 @@
                           </a:solidFill>
                           <a:latin typeface="Helvetica Neue"/>
                         </a:rPr>
-                        <a:t>8 / 9</a:t>
+                        <a:t>11 / 12</a:t>
                       </a:r>
                     </a:p>
                   </a:txBody>
@@ -4549,7 +4549,7 @@
                 </a:solidFill>
                 <a:latin typeface="Helvetica Neue"/>
               </a:rPr>
-              <a:t>It runs end to end, and it fails honestly</a:t>
+              <a:t>It runs end to end, and it reports 40 real problems</a:t>
             </a:r>
           </a:p>
         </p:txBody>
@@ -4748,7 +4748,7 @@
                 </a:solidFill>
                 <a:latin typeface="Helvetica Neue"/>
               </a:rPr>
-              <a:t>8 sections, 24 captions, 11 figures clipped</a:t>
+              <a:t>12 sections, 25 captions, 13 figures clipped</a:t>
             </a:r>
           </a:p>
         </p:txBody>
@@ -4809,7 +4809,7 @@
                 </a:solidFill>
                 <a:latin typeface="Helvetica Neue"/>
               </a:rPr>
-              <a:t>8 slides, 90 seconds each</a:t>
+              <a:t>11 slides at 65 seconds</a:t>
             </a:r>
           </a:p>
         </p:txBody>
@@ -4870,7 +4870,7 @@
                 </a:solidFill>
                 <a:latin typeface="Helvetica Neue"/>
               </a:rPr>
-              <a:t>a 9-slide deck, native and editable</a:t>
+              <a:t>a 12-slide deck, native and editable</a:t>
             </a:r>
           </a:p>
         </p:txBody>
@@ -4931,7 +4931,7 @@
                 </a:solidFill>
                 <a:latin typeface="Helvetica Neue"/>
               </a:rPr>
-              <a:t>32 violations, SRR 0.00</a:t>
+              <a:t>40 violations, SRR 0.00</a:t>
             </a:r>
           </a:p>
         </p:txBody>
@@ -5389,7 +5389,7 @@
                 </a:solidFill>
                 <a:latin typeface="Helvetica Neue"/>
               </a:rPr>
-              <a:t>-  figure clipping, 12/32 on the sample</a:t>
+              <a:t>-  figure clipping, 25 captions -&gt; 13 crops</a:t>
             </a:r>
           </a:p>
           <a:p>

</xml_diff>